<commit_message>
Replace AHP process flowchart with card-grid infographic
Use three themed columns (data collection, quality control, output)
with numbered cards and no arrows or flowchart connectors.

Co-authored-by: sazmanfava854-sudo <sazmanfava854-sudo@users.noreply.github.com>
</commit_message>
<xml_diff>
--- a/presentations/فرآیند_تجمیع_نظرات_خبرگان_AHP.pptx
+++ b/presentations/فرآیند_تجمیع_نظرات_خبرگان_AHP.pptx
@@ -3182,8 +3182,8 @@
         </p:nvSpPr>
         <p:spPr>
           <a:xfrm>
-            <a:off x="457200" y="256032"/>
-            <a:ext cx="8229600" cy="502920"/>
+            <a:off x="411480" y="256032"/>
+            <a:ext cx="8321040" cy="502920"/>
           </a:xfrm>
           <a:prstGeom prst="rect">
             <a:avLst/>
@@ -3204,7 +3204,7 @@
                 </a:solidFill>
                 <a:latin typeface="Tahoma"/>
               </a:rPr>
-              <a:t>فرآیند گردآوری و تجمیع نظرات خبرگان (AHP)</a:t>
+              <a:t>گردآوری و تجمیع نظرات خبرگان در AHP</a:t>
             </a:r>
           </a:p>
         </p:txBody>
@@ -3217,8 +3217,8 @@
         </p:nvSpPr>
         <p:spPr>
           <a:xfrm>
-            <a:off x="457200" y="749808"/>
-            <a:ext cx="8229600" cy="320040"/>
+            <a:off x="411480" y="749808"/>
+            <a:ext cx="8321040" cy="320040"/>
           </a:xfrm>
           <a:prstGeom prst="rect">
             <a:avLst/>
@@ -3239,7 +3239,7 @@
                 </a:solidFill>
                 <a:latin typeface="Tahoma"/>
               </a:rPr>
-              <a:t>از جمع‌آوری ماتریس‌های زوجی تا محاسبه وزن نهایی معیارها</a:t>
+              <a:t>سه فاز: گردآوری داده  ·  کنترل کیفیت  ·  تجمیع و خروجی</a:t>
             </a:r>
           </a:p>
         </p:txBody>
@@ -3252,19 +3252,17 @@
         </p:nvSpPr>
         <p:spPr>
           <a:xfrm>
-            <a:off x="5989320" y="1234440"/>
-            <a:ext cx="2606040" cy="868680"/>
+            <a:off x="411480" y="1234440"/>
+            <a:ext cx="2606040" cy="384048"/>
           </a:xfrm>
           <a:prstGeom prst="roundRect">
             <a:avLst/>
           </a:prstGeom>
           <a:solidFill>
-            <a:srgbClr val="FFFFFF"/>
-          </a:solidFill>
-          <a:ln w="19050">
-            <a:solidFill>
-              <a:srgbClr val="D1D9E6"/>
-            </a:solidFill>
+            <a:srgbClr val="2B5C8A"/>
+          </a:solidFill>
+          <a:ln>
+            <a:noFill/>
           </a:ln>
         </p:spPr>
         <p:style>
@@ -3285,7 +3283,16 @@
           <a:bodyPr rtlCol="0" anchor="ctr"/>
           <a:lstStyle/>
           <a:p>
-            <a:pPr algn="ctr"/>
+            <a:pPr algn="ctr" a:rtl="1"/>
+            <a:r>
+              <a:rPr sz="1300" b="1">
+                <a:solidFill>
+                  <a:srgbClr val="FFFFFF"/>
+                </a:solidFill>
+                <a:latin typeface="Tahoma"/>
+              </a:rPr>
+              <a:t>گردآوری داده</a:t>
+            </a:r>
           </a:p>
         </p:txBody>
       </p:sp>
@@ -3297,17 +3304,19 @@
         </p:nvSpPr>
         <p:spPr>
           <a:xfrm>
-            <a:off x="8138160" y="1325880"/>
-            <a:ext cx="347472" cy="347472"/>
+            <a:off x="411480" y="1728216"/>
+            <a:ext cx="2606040" cy="1051560"/>
           </a:xfrm>
           <a:prstGeom prst="roundRect">
             <a:avLst/>
           </a:prstGeom>
           <a:solidFill>
-            <a:srgbClr val="2B5C8A"/>
-          </a:solidFill>
-          <a:ln>
-            <a:noFill/>
+            <a:srgbClr val="FFFFFF"/>
+          </a:solidFill>
+          <a:ln w="15240">
+            <a:solidFill>
+              <a:srgbClr val="2B5C8A"/>
+            </a:solidFill>
           </a:ln>
         </p:spPr>
         <p:style>
@@ -3329,8 +3338,182 @@
           <a:lstStyle/>
           <a:p>
             <a:pPr algn="ctr"/>
-            <a:r>
-              <a:rPr sz="1400" b="1">
+          </a:p>
+        </p:txBody>
+      </p:sp>
+      <p:sp>
+        <p:nvSpPr>
+          <p:cNvPr id="8" name="Rectangle 7"/>
+          <p:cNvSpPr/>
+          <p:nvPr/>
+        </p:nvSpPr>
+        <p:spPr>
+          <a:xfrm>
+            <a:off x="411480" y="1728216"/>
+            <a:ext cx="2606040" cy="54864"/>
+          </a:xfrm>
+          <a:prstGeom prst="rect">
+            <a:avLst/>
+          </a:prstGeom>
+          <a:solidFill>
+            <a:srgbClr val="2B5C8A"/>
+          </a:solidFill>
+          <a:ln>
+            <a:noFill/>
+          </a:ln>
+        </p:spPr>
+        <p:style>
+          <a:lnRef idx="1">
+            <a:schemeClr val="accent1"/>
+          </a:lnRef>
+          <a:fillRef idx="3">
+            <a:schemeClr val="accent1"/>
+          </a:fillRef>
+          <a:effectRef idx="2">
+            <a:schemeClr val="accent1"/>
+          </a:effectRef>
+          <a:fontRef idx="minor">
+            <a:schemeClr val="lt1"/>
+          </a:fontRef>
+        </p:style>
+        <p:txBody>
+          <a:bodyPr rtlCol="0" anchor="ctr"/>
+          <a:lstStyle/>
+          <a:p>
+            <a:pPr algn="ctr"/>
+          </a:p>
+        </p:txBody>
+      </p:sp>
+      <p:sp>
+        <p:nvSpPr>
+          <p:cNvPr id="9" name="Rounded Rectangle 8"/>
+          <p:cNvSpPr/>
+          <p:nvPr/>
+        </p:nvSpPr>
+        <p:spPr>
+          <a:xfrm>
+            <a:off x="539496" y="1892808"/>
+            <a:ext cx="384048" cy="384048"/>
+          </a:xfrm>
+          <a:prstGeom prst="roundRect">
+            <a:avLst/>
+          </a:prstGeom>
+          <a:solidFill>
+            <a:srgbClr val="E3F2FD"/>
+          </a:solidFill>
+          <a:ln w="12700">
+            <a:solidFill>
+              <a:srgbClr val="2B5C8A"/>
+            </a:solidFill>
+          </a:ln>
+        </p:spPr>
+        <p:style>
+          <a:lnRef idx="1">
+            <a:schemeClr val="accent1"/>
+          </a:lnRef>
+          <a:fillRef idx="3">
+            <a:schemeClr val="accent1"/>
+          </a:fillRef>
+          <a:effectRef idx="2">
+            <a:schemeClr val="accent1"/>
+          </a:effectRef>
+          <a:fontRef idx="minor">
+            <a:schemeClr val="lt1"/>
+          </a:fontRef>
+        </p:style>
+        <p:txBody>
+          <a:bodyPr rtlCol="0" anchor="ctr"/>
+          <a:lstStyle/>
+          <a:p>
+            <a:pPr algn="ctr"/>
+          </a:p>
+        </p:txBody>
+      </p:sp>
+      <p:sp>
+        <p:nvSpPr>
+          <p:cNvPr id="10" name="Action Button: Beginning 9"/>
+          <p:cNvSpPr/>
+          <p:nvPr/>
+        </p:nvSpPr>
+        <p:spPr>
+          <a:xfrm>
+            <a:off x="612648" y="1956816"/>
+            <a:ext cx="237744" cy="237744"/>
+          </a:xfrm>
+          <a:prstGeom prst="actionButtonBeginning">
+            <a:avLst/>
+          </a:prstGeom>
+          <a:solidFill>
+            <a:srgbClr val="2B5C8A"/>
+          </a:solidFill>
+          <a:ln>
+            <a:noFill/>
+          </a:ln>
+        </p:spPr>
+        <p:style>
+          <a:lnRef idx="1">
+            <a:schemeClr val="accent1"/>
+          </a:lnRef>
+          <a:fillRef idx="3">
+            <a:schemeClr val="accent1"/>
+          </a:fillRef>
+          <a:effectRef idx="2">
+            <a:schemeClr val="accent1"/>
+          </a:effectRef>
+          <a:fontRef idx="minor">
+            <a:schemeClr val="lt1"/>
+          </a:fontRef>
+        </p:style>
+        <p:txBody>
+          <a:bodyPr rtlCol="0" anchor="ctr"/>
+          <a:lstStyle/>
+          <a:p>
+            <a:pPr algn="ctr"/>
+          </a:p>
+        </p:txBody>
+      </p:sp>
+      <p:sp>
+        <p:nvSpPr>
+          <p:cNvPr id="11" name="Rounded Rectangle 10"/>
+          <p:cNvSpPr/>
+          <p:nvPr/>
+        </p:nvSpPr>
+        <p:spPr>
+          <a:xfrm>
+            <a:off x="2578608" y="1856232"/>
+            <a:ext cx="310896" cy="310896"/>
+          </a:xfrm>
+          <a:prstGeom prst="roundRect">
+            <a:avLst/>
+          </a:prstGeom>
+          <a:solidFill>
+            <a:srgbClr val="2B5C8A"/>
+          </a:solidFill>
+          <a:ln>
+            <a:noFill/>
+          </a:ln>
+        </p:spPr>
+        <p:style>
+          <a:lnRef idx="1">
+            <a:schemeClr val="accent1"/>
+          </a:lnRef>
+          <a:fillRef idx="3">
+            <a:schemeClr val="accent1"/>
+          </a:fillRef>
+          <a:effectRef idx="2">
+            <a:schemeClr val="accent1"/>
+          </a:effectRef>
+          <a:fontRef idx="minor">
+            <a:schemeClr val="lt1"/>
+          </a:fontRef>
+        </p:style>
+        <p:txBody>
+          <a:bodyPr rtlCol="0" anchor="ctr"/>
+          <a:lstStyle/>
+          <a:p>
+            <a:pPr algn="ctr"/>
+            <a:r>
+              <a:rPr sz="1300" b="1">
                 <a:solidFill>
                   <a:srgbClr val="FFFFFF"/>
                 </a:solidFill>
@@ -3343,14 +3526,14 @@
       </p:sp>
       <p:sp>
         <p:nvSpPr>
-          <p:cNvPr id="8" name="TextBox 7"/>
+          <p:cNvPr id="12" name="TextBox 11"/>
           <p:cNvSpPr txBox="1"/>
           <p:nvPr/>
         </p:nvSpPr>
         <p:spPr>
           <a:xfrm>
-            <a:off x="6126480" y="1344168"/>
-            <a:ext cx="2011680" cy="320040"/>
+            <a:off x="978408" y="1874520"/>
+            <a:ext cx="1892808" cy="292608"/>
           </a:xfrm>
           <a:prstGeom prst="rect">
             <a:avLst/>
@@ -3365,7 +3548,7 @@
           <a:p>
             <a:pPr algn="r" a:rtl="1"/>
             <a:r>
-              <a:rPr sz="1300" b="1">
+              <a:rPr sz="1200" b="1">
                 <a:solidFill>
                   <a:srgbClr val="2D343E"/>
                 </a:solidFill>
@@ -3378,14 +3561,14 @@
       </p:sp>
       <p:sp>
         <p:nvSpPr>
-          <p:cNvPr id="9" name="TextBox 8"/>
+          <p:cNvPr id="13" name="TextBox 12"/>
           <p:cNvSpPr txBox="1"/>
           <p:nvPr/>
         </p:nvSpPr>
         <p:spPr>
           <a:xfrm>
-            <a:off x="6126480" y="1673352"/>
-            <a:ext cx="2423160" cy="384048"/>
+            <a:off x="978408" y="2185416"/>
+            <a:ext cx="1892808" cy="502920"/>
           </a:xfrm>
           <a:prstGeom prst="rect">
             <a:avLst/>
@@ -3400,7 +3583,7 @@
           <a:p>
             <a:pPr algn="r" a:rtl="1"/>
             <a:r>
-              <a:rPr sz="1000" b="0">
+              <a:rPr sz="950" b="0">
                 <a:solidFill>
                   <a:srgbClr val="6B7280"/>
                 </a:solidFill>
@@ -3413,14 +3596,14 @@
       </p:sp>
       <p:sp>
         <p:nvSpPr>
-          <p:cNvPr id="10" name="Rounded Rectangle 9"/>
+          <p:cNvPr id="14" name="Rounded Rectangle 13"/>
           <p:cNvSpPr/>
           <p:nvPr/>
         </p:nvSpPr>
         <p:spPr>
           <a:xfrm>
-            <a:off x="3063240" y="1234440"/>
-            <a:ext cx="2606040" cy="868680"/>
+            <a:off x="411480" y="2944368"/>
+            <a:ext cx="2606040" cy="1051560"/>
           </a:xfrm>
           <a:prstGeom prst="roundRect">
             <a:avLst/>
@@ -3428,9 +3611,9 @@
           <a:solidFill>
             <a:srgbClr val="FFFFFF"/>
           </a:solidFill>
-          <a:ln w="19050">
+          <a:ln w="15240">
             <a:solidFill>
-              <a:srgbClr val="D1D9E6"/>
+              <a:srgbClr val="2B5C8A"/>
             </a:solidFill>
           </a:ln>
         </p:spPr>
@@ -3458,16 +3641,16 @@
       </p:sp>
       <p:sp>
         <p:nvSpPr>
-          <p:cNvPr id="11" name="Rounded Rectangle 10"/>
+          <p:cNvPr id="15" name="Rectangle 14"/>
           <p:cNvSpPr/>
           <p:nvPr/>
         </p:nvSpPr>
         <p:spPr>
           <a:xfrm>
-            <a:off x="5212080" y="1325880"/>
-            <a:ext cx="347472" cy="347472"/>
-          </a:xfrm>
-          <a:prstGeom prst="roundRect">
+            <a:off x="411480" y="2944368"/>
+            <a:ext cx="2606040" cy="54864"/>
+          </a:xfrm>
+          <a:prstGeom prst="rect">
             <a:avLst/>
           </a:prstGeom>
           <a:solidFill>
@@ -3496,8 +3679,139 @@
           <a:lstStyle/>
           <a:p>
             <a:pPr algn="ctr"/>
-            <a:r>
-              <a:rPr sz="1400" b="1">
+          </a:p>
+        </p:txBody>
+      </p:sp>
+      <p:sp>
+        <p:nvSpPr>
+          <p:cNvPr id="16" name="Rounded Rectangle 15"/>
+          <p:cNvSpPr/>
+          <p:nvPr/>
+        </p:nvSpPr>
+        <p:spPr>
+          <a:xfrm>
+            <a:off x="539496" y="3108960"/>
+            <a:ext cx="384048" cy="384048"/>
+          </a:xfrm>
+          <a:prstGeom prst="roundRect">
+            <a:avLst/>
+          </a:prstGeom>
+          <a:solidFill>
+            <a:srgbClr val="E3F2FD"/>
+          </a:solidFill>
+          <a:ln w="12700">
+            <a:solidFill>
+              <a:srgbClr val="2B5C8A"/>
+            </a:solidFill>
+          </a:ln>
+        </p:spPr>
+        <p:style>
+          <a:lnRef idx="1">
+            <a:schemeClr val="accent1"/>
+          </a:lnRef>
+          <a:fillRef idx="3">
+            <a:schemeClr val="accent1"/>
+          </a:fillRef>
+          <a:effectRef idx="2">
+            <a:schemeClr val="accent1"/>
+          </a:effectRef>
+          <a:fontRef idx="minor">
+            <a:schemeClr val="lt1"/>
+          </a:fontRef>
+        </p:style>
+        <p:txBody>
+          <a:bodyPr rtlCol="0" anchor="ctr"/>
+          <a:lstStyle/>
+          <a:p>
+            <a:pPr algn="ctr"/>
+          </a:p>
+        </p:txBody>
+      </p:sp>
+      <p:sp>
+        <p:nvSpPr>
+          <p:cNvPr id="17" name="Action Button: Back or Previous 16"/>
+          <p:cNvSpPr/>
+          <p:nvPr/>
+        </p:nvSpPr>
+        <p:spPr>
+          <a:xfrm>
+            <a:off x="612648" y="3172968"/>
+            <a:ext cx="237744" cy="237744"/>
+          </a:xfrm>
+          <a:prstGeom prst="actionButtonBackPrevious">
+            <a:avLst/>
+          </a:prstGeom>
+          <a:solidFill>
+            <a:srgbClr val="2B5C8A"/>
+          </a:solidFill>
+          <a:ln>
+            <a:noFill/>
+          </a:ln>
+        </p:spPr>
+        <p:style>
+          <a:lnRef idx="1">
+            <a:schemeClr val="accent1"/>
+          </a:lnRef>
+          <a:fillRef idx="3">
+            <a:schemeClr val="accent1"/>
+          </a:fillRef>
+          <a:effectRef idx="2">
+            <a:schemeClr val="accent1"/>
+          </a:effectRef>
+          <a:fontRef idx="minor">
+            <a:schemeClr val="lt1"/>
+          </a:fontRef>
+        </p:style>
+        <p:txBody>
+          <a:bodyPr rtlCol="0" anchor="ctr"/>
+          <a:lstStyle/>
+          <a:p>
+            <a:pPr algn="ctr"/>
+          </a:p>
+        </p:txBody>
+      </p:sp>
+      <p:sp>
+        <p:nvSpPr>
+          <p:cNvPr id="18" name="Rounded Rectangle 17"/>
+          <p:cNvSpPr/>
+          <p:nvPr/>
+        </p:nvSpPr>
+        <p:spPr>
+          <a:xfrm>
+            <a:off x="2578608" y="3072384"/>
+            <a:ext cx="310896" cy="310896"/>
+          </a:xfrm>
+          <a:prstGeom prst="roundRect">
+            <a:avLst/>
+          </a:prstGeom>
+          <a:solidFill>
+            <a:srgbClr val="2B5C8A"/>
+          </a:solidFill>
+          <a:ln>
+            <a:noFill/>
+          </a:ln>
+        </p:spPr>
+        <p:style>
+          <a:lnRef idx="1">
+            <a:schemeClr val="accent1"/>
+          </a:lnRef>
+          <a:fillRef idx="3">
+            <a:schemeClr val="accent1"/>
+          </a:fillRef>
+          <a:effectRef idx="2">
+            <a:schemeClr val="accent1"/>
+          </a:effectRef>
+          <a:fontRef idx="minor">
+            <a:schemeClr val="lt1"/>
+          </a:fontRef>
+        </p:style>
+        <p:txBody>
+          <a:bodyPr rtlCol="0" anchor="ctr"/>
+          <a:lstStyle/>
+          <a:p>
+            <a:pPr algn="ctr"/>
+            <a:r>
+              <a:rPr sz="1300" b="1">
                 <a:solidFill>
                   <a:srgbClr val="FFFFFF"/>
                 </a:solidFill>
@@ -3510,14 +3824,14 @@
       </p:sp>
       <p:sp>
         <p:nvSpPr>
-          <p:cNvPr id="12" name="TextBox 11"/>
+          <p:cNvPr id="19" name="TextBox 18"/>
           <p:cNvSpPr txBox="1"/>
           <p:nvPr/>
         </p:nvSpPr>
         <p:spPr>
           <a:xfrm>
-            <a:off x="3200400" y="1344168"/>
-            <a:ext cx="2011680" cy="320040"/>
+            <a:off x="978408" y="3090672"/>
+            <a:ext cx="1892808" cy="292608"/>
           </a:xfrm>
           <a:prstGeom prst="rect">
             <a:avLst/>
@@ -3532,7 +3846,7 @@
           <a:p>
             <a:pPr algn="r" a:rtl="1"/>
             <a:r>
-              <a:rPr sz="1300" b="1">
+              <a:rPr sz="1200" b="1">
                 <a:solidFill>
                   <a:srgbClr val="2D343E"/>
                 </a:solidFill>
@@ -3545,14 +3859,14 @@
       </p:sp>
       <p:sp>
         <p:nvSpPr>
-          <p:cNvPr id="13" name="TextBox 12"/>
+          <p:cNvPr id="20" name="TextBox 19"/>
           <p:cNvSpPr txBox="1"/>
           <p:nvPr/>
         </p:nvSpPr>
         <p:spPr>
           <a:xfrm>
-            <a:off x="3200400" y="1673352"/>
-            <a:ext cx="2423160" cy="384048"/>
+            <a:off x="978408" y="3401568"/>
+            <a:ext cx="1892808" cy="502920"/>
           </a:xfrm>
           <a:prstGeom prst="rect">
             <a:avLst/>
@@ -3567,7 +3881,7 @@
           <a:p>
             <a:pPr algn="r" a:rtl="1"/>
             <a:r>
-              <a:rPr sz="1000" b="0">
+              <a:rPr sz="950" b="0">
                 <a:solidFill>
                   <a:srgbClr val="6B7280"/>
                 </a:solidFill>
@@ -3580,25 +3894,23 @@
       </p:sp>
       <p:sp>
         <p:nvSpPr>
-          <p:cNvPr id="14" name="Rounded Rectangle 13"/>
+          <p:cNvPr id="21" name="Rounded Rectangle 20"/>
           <p:cNvSpPr/>
           <p:nvPr/>
         </p:nvSpPr>
         <p:spPr>
           <a:xfrm>
-            <a:off x="137160" y="1234440"/>
-            <a:ext cx="2606040" cy="868680"/>
+            <a:off x="3218688" y="1234440"/>
+            <a:ext cx="2606040" cy="384048"/>
           </a:xfrm>
           <a:prstGeom prst="roundRect">
             <a:avLst/>
           </a:prstGeom>
           <a:solidFill>
-            <a:srgbClr val="E0F2F1"/>
-          </a:solidFill>
-          <a:ln w="19050">
-            <a:solidFill>
-              <a:srgbClr val="009688"/>
-            </a:solidFill>
+            <a:srgbClr val="009688"/>
+          </a:solidFill>
+          <a:ln>
+            <a:noFill/>
           </a:ln>
         </p:spPr>
         <p:style>
@@ -3619,29 +3931,40 @@
           <a:bodyPr rtlCol="0" anchor="ctr"/>
           <a:lstStyle/>
           <a:p>
-            <a:pPr algn="ctr"/>
-          </a:p>
-        </p:txBody>
-      </p:sp>
-      <p:sp>
-        <p:nvSpPr>
-          <p:cNvPr id="15" name="Rounded Rectangle 14"/>
+            <a:pPr algn="ctr" a:rtl="1"/>
+            <a:r>
+              <a:rPr sz="1300" b="1">
+                <a:solidFill>
+                  <a:srgbClr val="FFFFFF"/>
+                </a:solidFill>
+                <a:latin typeface="Tahoma"/>
+              </a:rPr>
+              <a:t>کنترل کیفیت</a:t>
+            </a:r>
+          </a:p>
+        </p:txBody>
+      </p:sp>
+      <p:sp>
+        <p:nvSpPr>
+          <p:cNvPr id="22" name="Rounded Rectangle 21"/>
           <p:cNvSpPr/>
           <p:nvPr/>
         </p:nvSpPr>
         <p:spPr>
           <a:xfrm>
-            <a:off x="2286000" y="1325880"/>
-            <a:ext cx="347472" cy="347472"/>
+            <a:off x="3218688" y="1728216"/>
+            <a:ext cx="2606040" cy="1051560"/>
           </a:xfrm>
           <a:prstGeom prst="roundRect">
             <a:avLst/>
           </a:prstGeom>
           <a:solidFill>
-            <a:srgbClr val="009688"/>
-          </a:solidFill>
-          <a:ln>
-            <a:noFill/>
+            <a:srgbClr val="FFFFFF"/>
+          </a:solidFill>
+          <a:ln w="15240">
+            <a:solidFill>
+              <a:srgbClr val="009688"/>
+            </a:solidFill>
           </a:ln>
         </p:spPr>
         <p:style>
@@ -3663,8 +3986,182 @@
           <a:lstStyle/>
           <a:p>
             <a:pPr algn="ctr"/>
-            <a:r>
-              <a:rPr sz="1400" b="1">
+          </a:p>
+        </p:txBody>
+      </p:sp>
+      <p:sp>
+        <p:nvSpPr>
+          <p:cNvPr id="23" name="Rectangle 22"/>
+          <p:cNvSpPr/>
+          <p:nvPr/>
+        </p:nvSpPr>
+        <p:spPr>
+          <a:xfrm>
+            <a:off x="3218688" y="1728216"/>
+            <a:ext cx="2606040" cy="54864"/>
+          </a:xfrm>
+          <a:prstGeom prst="rect">
+            <a:avLst/>
+          </a:prstGeom>
+          <a:solidFill>
+            <a:srgbClr val="009688"/>
+          </a:solidFill>
+          <a:ln>
+            <a:noFill/>
+          </a:ln>
+        </p:spPr>
+        <p:style>
+          <a:lnRef idx="1">
+            <a:schemeClr val="accent1"/>
+          </a:lnRef>
+          <a:fillRef idx="3">
+            <a:schemeClr val="accent1"/>
+          </a:fillRef>
+          <a:effectRef idx="2">
+            <a:schemeClr val="accent1"/>
+          </a:effectRef>
+          <a:fontRef idx="minor">
+            <a:schemeClr val="lt1"/>
+          </a:fontRef>
+        </p:style>
+        <p:txBody>
+          <a:bodyPr rtlCol="0" anchor="ctr"/>
+          <a:lstStyle/>
+          <a:p>
+            <a:pPr algn="ctr"/>
+          </a:p>
+        </p:txBody>
+      </p:sp>
+      <p:sp>
+        <p:nvSpPr>
+          <p:cNvPr id="24" name="Rounded Rectangle 23"/>
+          <p:cNvSpPr/>
+          <p:nvPr/>
+        </p:nvSpPr>
+        <p:spPr>
+          <a:xfrm>
+            <a:off x="3346704" y="1892808"/>
+            <a:ext cx="384048" cy="384048"/>
+          </a:xfrm>
+          <a:prstGeom prst="roundRect">
+            <a:avLst/>
+          </a:prstGeom>
+          <a:solidFill>
+            <a:srgbClr val="E0F2F1"/>
+          </a:solidFill>
+          <a:ln w="12700">
+            <a:solidFill>
+              <a:srgbClr val="009688"/>
+            </a:solidFill>
+          </a:ln>
+        </p:spPr>
+        <p:style>
+          <a:lnRef idx="1">
+            <a:schemeClr val="accent1"/>
+          </a:lnRef>
+          <a:fillRef idx="3">
+            <a:schemeClr val="accent1"/>
+          </a:fillRef>
+          <a:effectRef idx="2">
+            <a:schemeClr val="accent1"/>
+          </a:effectRef>
+          <a:fontRef idx="minor">
+            <a:schemeClr val="lt1"/>
+          </a:fontRef>
+        </p:style>
+        <p:txBody>
+          <a:bodyPr rtlCol="0" anchor="ctr"/>
+          <a:lstStyle/>
+          <a:p>
+            <a:pPr algn="ctr"/>
+          </a:p>
+        </p:txBody>
+      </p:sp>
+      <p:sp>
+        <p:nvSpPr>
+          <p:cNvPr id="25" name="Action Button: Document 24"/>
+          <p:cNvSpPr/>
+          <p:nvPr/>
+        </p:nvSpPr>
+        <p:spPr>
+          <a:xfrm>
+            <a:off x="3419856" y="1956816"/>
+            <a:ext cx="237744" cy="237744"/>
+          </a:xfrm>
+          <a:prstGeom prst="actionButtonDocument">
+            <a:avLst/>
+          </a:prstGeom>
+          <a:solidFill>
+            <a:srgbClr val="009688"/>
+          </a:solidFill>
+          <a:ln>
+            <a:noFill/>
+          </a:ln>
+        </p:spPr>
+        <p:style>
+          <a:lnRef idx="1">
+            <a:schemeClr val="accent1"/>
+          </a:lnRef>
+          <a:fillRef idx="3">
+            <a:schemeClr val="accent1"/>
+          </a:fillRef>
+          <a:effectRef idx="2">
+            <a:schemeClr val="accent1"/>
+          </a:effectRef>
+          <a:fontRef idx="minor">
+            <a:schemeClr val="lt1"/>
+          </a:fontRef>
+        </p:style>
+        <p:txBody>
+          <a:bodyPr rtlCol="0" anchor="ctr"/>
+          <a:lstStyle/>
+          <a:p>
+            <a:pPr algn="ctr"/>
+          </a:p>
+        </p:txBody>
+      </p:sp>
+      <p:sp>
+        <p:nvSpPr>
+          <p:cNvPr id="26" name="Rounded Rectangle 25"/>
+          <p:cNvSpPr/>
+          <p:nvPr/>
+        </p:nvSpPr>
+        <p:spPr>
+          <a:xfrm>
+            <a:off x="5385816" y="1856232"/>
+            <a:ext cx="310896" cy="310896"/>
+          </a:xfrm>
+          <a:prstGeom prst="roundRect">
+            <a:avLst/>
+          </a:prstGeom>
+          <a:solidFill>
+            <a:srgbClr val="009688"/>
+          </a:solidFill>
+          <a:ln>
+            <a:noFill/>
+          </a:ln>
+        </p:spPr>
+        <p:style>
+          <a:lnRef idx="1">
+            <a:schemeClr val="accent1"/>
+          </a:lnRef>
+          <a:fillRef idx="3">
+            <a:schemeClr val="accent1"/>
+          </a:fillRef>
+          <a:effectRef idx="2">
+            <a:schemeClr val="accent1"/>
+          </a:effectRef>
+          <a:fontRef idx="minor">
+            <a:schemeClr val="lt1"/>
+          </a:fontRef>
+        </p:style>
+        <p:txBody>
+          <a:bodyPr rtlCol="0" anchor="ctr"/>
+          <a:lstStyle/>
+          <a:p>
+            <a:pPr algn="ctr"/>
+            <a:r>
+              <a:rPr sz="1300" b="1">
                 <a:solidFill>
                   <a:srgbClr val="FFFFFF"/>
                 </a:solidFill>
@@ -3677,14 +4174,14 @@
       </p:sp>
       <p:sp>
         <p:nvSpPr>
-          <p:cNvPr id="16" name="TextBox 15"/>
+          <p:cNvPr id="27" name="TextBox 26"/>
           <p:cNvSpPr txBox="1"/>
           <p:nvPr/>
         </p:nvSpPr>
         <p:spPr>
           <a:xfrm>
-            <a:off x="274320" y="1344168"/>
-            <a:ext cx="2011680" cy="320040"/>
+            <a:off x="3785616" y="1874520"/>
+            <a:ext cx="1892808" cy="292608"/>
           </a:xfrm>
           <a:prstGeom prst="rect">
             <a:avLst/>
@@ -3699,7 +4196,7 @@
           <a:p>
             <a:pPr algn="r" a:rtl="1"/>
             <a:r>
-              <a:rPr sz="1300" b="1">
+              <a:rPr sz="1200" b="1">
                 <a:solidFill>
                   <a:srgbClr val="2D343E"/>
                 </a:solidFill>
@@ -3712,14 +4209,14 @@
       </p:sp>
       <p:sp>
         <p:nvSpPr>
-          <p:cNvPr id="17" name="TextBox 16"/>
+          <p:cNvPr id="28" name="TextBox 27"/>
           <p:cNvSpPr txBox="1"/>
           <p:nvPr/>
         </p:nvSpPr>
         <p:spPr>
           <a:xfrm>
-            <a:off x="274320" y="1673352"/>
-            <a:ext cx="2423160" cy="384048"/>
+            <a:off x="3785616" y="2185416"/>
+            <a:ext cx="1892808" cy="502920"/>
           </a:xfrm>
           <a:prstGeom prst="rect">
             <a:avLst/>
@@ -3734,7 +4231,7 @@
           <a:p>
             <a:pPr algn="r" a:rtl="1"/>
             <a:r>
-              <a:rPr sz="1000" b="0">
+              <a:rPr sz="950" b="0">
                 <a:solidFill>
                   <a:srgbClr val="6B7280"/>
                 </a:solidFill>
@@ -3747,24 +4244,24 @@
       </p:sp>
       <p:sp>
         <p:nvSpPr>
-          <p:cNvPr id="18" name="Rounded Rectangle 17"/>
+          <p:cNvPr id="29" name="Rounded Rectangle 28"/>
           <p:cNvSpPr/>
           <p:nvPr/>
         </p:nvSpPr>
         <p:spPr>
           <a:xfrm>
-            <a:off x="5989320" y="2606040"/>
-            <a:ext cx="2606040" cy="868680"/>
+            <a:off x="3218688" y="2944368"/>
+            <a:ext cx="2606040" cy="1051560"/>
           </a:xfrm>
           <a:prstGeom prst="roundRect">
             <a:avLst/>
           </a:prstGeom>
           <a:solidFill>
-            <a:srgbClr val="E8F5E9"/>
-          </a:solidFill>
-          <a:ln w="25400">
+            <a:srgbClr val="FFFFFF"/>
+          </a:solidFill>
+          <a:ln w="15240">
             <a:solidFill>
-              <a:srgbClr val="2E7D32"/>
+              <a:srgbClr val="009688"/>
             </a:solidFill>
           </a:ln>
         </p:spPr>
@@ -3792,20 +4289,20 @@
       </p:sp>
       <p:sp>
         <p:nvSpPr>
-          <p:cNvPr id="19" name="Rounded Rectangle 18"/>
+          <p:cNvPr id="30" name="Rectangle 29"/>
           <p:cNvSpPr/>
           <p:nvPr/>
         </p:nvSpPr>
         <p:spPr>
           <a:xfrm>
-            <a:off x="8138160" y="2697480"/>
-            <a:ext cx="347472" cy="347472"/>
-          </a:xfrm>
-          <a:prstGeom prst="roundRect">
-            <a:avLst/>
-          </a:prstGeom>
-          <a:solidFill>
-            <a:srgbClr val="2E7D32"/>
+            <a:off x="3218688" y="2944368"/>
+            <a:ext cx="2606040" cy="54864"/>
+          </a:xfrm>
+          <a:prstGeom prst="rect">
+            <a:avLst/>
+          </a:prstGeom>
+          <a:solidFill>
+            <a:srgbClr val="009688"/>
           </a:solidFill>
           <a:ln>
             <a:noFill/>
@@ -3830,8 +4327,139 @@
           <a:lstStyle/>
           <a:p>
             <a:pPr algn="ctr"/>
-            <a:r>
-              <a:rPr sz="1400" b="1">
+          </a:p>
+        </p:txBody>
+      </p:sp>
+      <p:sp>
+        <p:nvSpPr>
+          <p:cNvPr id="31" name="Rounded Rectangle 30"/>
+          <p:cNvSpPr/>
+          <p:nvPr/>
+        </p:nvSpPr>
+        <p:spPr>
+          <a:xfrm>
+            <a:off x="3346704" y="3108960"/>
+            <a:ext cx="384048" cy="384048"/>
+          </a:xfrm>
+          <a:prstGeom prst="roundRect">
+            <a:avLst/>
+          </a:prstGeom>
+          <a:solidFill>
+            <a:srgbClr val="E0F2F1"/>
+          </a:solidFill>
+          <a:ln w="12700">
+            <a:solidFill>
+              <a:srgbClr val="009688"/>
+            </a:solidFill>
+          </a:ln>
+        </p:spPr>
+        <p:style>
+          <a:lnRef idx="1">
+            <a:schemeClr val="accent1"/>
+          </a:lnRef>
+          <a:fillRef idx="3">
+            <a:schemeClr val="accent1"/>
+          </a:fillRef>
+          <a:effectRef idx="2">
+            <a:schemeClr val="accent1"/>
+          </a:effectRef>
+          <a:fontRef idx="minor">
+            <a:schemeClr val="lt1"/>
+          </a:fontRef>
+        </p:style>
+        <p:txBody>
+          <a:bodyPr rtlCol="0" anchor="ctr"/>
+          <a:lstStyle/>
+          <a:p>
+            <a:pPr algn="ctr"/>
+          </a:p>
+        </p:txBody>
+      </p:sp>
+      <p:sp>
+        <p:nvSpPr>
+          <p:cNvPr id="32" name="Action Button: End 31"/>
+          <p:cNvSpPr/>
+          <p:nvPr/>
+        </p:nvSpPr>
+        <p:spPr>
+          <a:xfrm>
+            <a:off x="3419856" y="3172968"/>
+            <a:ext cx="237744" cy="237744"/>
+          </a:xfrm>
+          <a:prstGeom prst="actionButtonEnd">
+            <a:avLst/>
+          </a:prstGeom>
+          <a:solidFill>
+            <a:srgbClr val="009688"/>
+          </a:solidFill>
+          <a:ln>
+            <a:noFill/>
+          </a:ln>
+        </p:spPr>
+        <p:style>
+          <a:lnRef idx="1">
+            <a:schemeClr val="accent1"/>
+          </a:lnRef>
+          <a:fillRef idx="3">
+            <a:schemeClr val="accent1"/>
+          </a:fillRef>
+          <a:effectRef idx="2">
+            <a:schemeClr val="accent1"/>
+          </a:effectRef>
+          <a:fontRef idx="minor">
+            <a:schemeClr val="lt1"/>
+          </a:fontRef>
+        </p:style>
+        <p:txBody>
+          <a:bodyPr rtlCol="0" anchor="ctr"/>
+          <a:lstStyle/>
+          <a:p>
+            <a:pPr algn="ctr"/>
+          </a:p>
+        </p:txBody>
+      </p:sp>
+      <p:sp>
+        <p:nvSpPr>
+          <p:cNvPr id="33" name="Rounded Rectangle 32"/>
+          <p:cNvSpPr/>
+          <p:nvPr/>
+        </p:nvSpPr>
+        <p:spPr>
+          <a:xfrm>
+            <a:off x="5385816" y="3072384"/>
+            <a:ext cx="310896" cy="310896"/>
+          </a:xfrm>
+          <a:prstGeom prst="roundRect">
+            <a:avLst/>
+          </a:prstGeom>
+          <a:solidFill>
+            <a:srgbClr val="009688"/>
+          </a:solidFill>
+          <a:ln>
+            <a:noFill/>
+          </a:ln>
+        </p:spPr>
+        <p:style>
+          <a:lnRef idx="1">
+            <a:schemeClr val="accent1"/>
+          </a:lnRef>
+          <a:fillRef idx="3">
+            <a:schemeClr val="accent1"/>
+          </a:fillRef>
+          <a:effectRef idx="2">
+            <a:schemeClr val="accent1"/>
+          </a:effectRef>
+          <a:fontRef idx="minor">
+            <a:schemeClr val="lt1"/>
+          </a:fontRef>
+        </p:style>
+        <p:txBody>
+          <a:bodyPr rtlCol="0" anchor="ctr"/>
+          <a:lstStyle/>
+          <a:p>
+            <a:pPr algn="ctr"/>
+            <a:r>
+              <a:rPr sz="1300" b="1">
                 <a:solidFill>
                   <a:srgbClr val="FFFFFF"/>
                 </a:solidFill>
@@ -3844,14 +4472,14 @@
       </p:sp>
       <p:sp>
         <p:nvSpPr>
-          <p:cNvPr id="20" name="TextBox 19"/>
+          <p:cNvPr id="34" name="TextBox 33"/>
           <p:cNvSpPr txBox="1"/>
           <p:nvPr/>
         </p:nvSpPr>
         <p:spPr>
           <a:xfrm>
-            <a:off x="6126480" y="2715768"/>
-            <a:ext cx="2011680" cy="320040"/>
+            <a:off x="3785616" y="3090672"/>
+            <a:ext cx="1892808" cy="292608"/>
           </a:xfrm>
           <a:prstGeom prst="rect">
             <a:avLst/>
@@ -3866,7 +4494,7 @@
           <a:p>
             <a:pPr algn="r" a:rtl="1"/>
             <a:r>
-              <a:rPr sz="1300" b="1">
+              <a:rPr sz="1200" b="1">
                 <a:solidFill>
                   <a:srgbClr val="2D343E"/>
                 </a:solidFill>
@@ -3879,14 +4507,14 @@
       </p:sp>
       <p:sp>
         <p:nvSpPr>
-          <p:cNvPr id="21" name="TextBox 20"/>
+          <p:cNvPr id="35" name="TextBox 34"/>
           <p:cNvSpPr txBox="1"/>
           <p:nvPr/>
         </p:nvSpPr>
         <p:spPr>
           <a:xfrm>
-            <a:off x="6126480" y="3044952"/>
-            <a:ext cx="2423160" cy="384048"/>
+            <a:off x="3785616" y="3401568"/>
+            <a:ext cx="1892808" cy="502920"/>
           </a:xfrm>
           <a:prstGeom prst="rect">
             <a:avLst/>
@@ -3901,73 +4529,90 @@
           <a:p>
             <a:pPr algn="r" a:rtl="1"/>
             <a:r>
-              <a:rPr sz="1000" b="0">
+              <a:rPr sz="950" b="0">
                 <a:solidFill>
                   <a:srgbClr val="6B7280"/>
                 </a:solidFill>
                 <a:latin typeface="Tahoma"/>
               </a:rPr>
-              <a:t>فقط ماتریس‌هایی با CR &lt; ۰٫۱ پذیرفته می‌شوند</a:t>
-            </a:r>
-          </a:p>
-        </p:txBody>
-      </p:sp>
-      <p:sp>
-        <p:nvSpPr>
-          <p:cNvPr id="22" name="TextBox 21"/>
-          <p:cNvSpPr txBox="1"/>
+              <a:t>فقط ماتریس‌هایی با نسبت سازگاری کمتر از ۰٫۱ پذیرفته می‌شوند</a:t>
+            </a:r>
+          </a:p>
+        </p:txBody>
+      </p:sp>
+      <p:sp>
+        <p:nvSpPr>
+          <p:cNvPr id="36" name="Rounded Rectangle 35"/>
+          <p:cNvSpPr/>
           <p:nvPr/>
         </p:nvSpPr>
         <p:spPr>
           <a:xfrm>
-            <a:off x="6126480" y="3182112"/>
-            <a:ext cx="2423160" cy="228600"/>
-          </a:xfrm>
-          <a:prstGeom prst="rect">
-            <a:avLst/>
-          </a:prstGeom>
-          <a:noFill/>
-        </p:spPr>
-        <p:txBody>
-          <a:bodyPr wrap="square" anchor="ctr">
-            <a:spAutoFit/>
-          </a:bodyPr>
+            <a:off x="3346704" y="3685032"/>
+            <a:ext cx="960120" cy="219456"/>
+          </a:xfrm>
+          <a:prstGeom prst="roundRect">
+            <a:avLst/>
+          </a:prstGeom>
+          <a:solidFill>
+            <a:srgbClr val="E8F5E9"/>
+          </a:solidFill>
+          <a:ln w="12700">
+            <a:solidFill>
+              <a:srgbClr val="2E7D32"/>
+            </a:solidFill>
+          </a:ln>
+        </p:spPr>
+        <p:style>
+          <a:lnRef idx="1">
+            <a:schemeClr val="accent1"/>
+          </a:lnRef>
+          <a:fillRef idx="3">
+            <a:schemeClr val="accent1"/>
+          </a:fillRef>
+          <a:effectRef idx="2">
+            <a:schemeClr val="accent1"/>
+          </a:effectRef>
+          <a:fontRef idx="minor">
+            <a:schemeClr val="lt1"/>
+          </a:fontRef>
+        </p:style>
+        <p:txBody>
+          <a:bodyPr rtlCol="0" anchor="ctr"/>
           <a:lstStyle/>
           <a:p>
             <a:pPr algn="ctr"/>
             <a:r>
-              <a:rPr sz="1100" b="1">
+              <a:rPr sz="900" b="1">
                 <a:solidFill>
                   <a:srgbClr val="1B5E20"/>
                 </a:solidFill>
                 <a:latin typeface="Tahoma"/>
               </a:rPr>
-              <a:t>✓  CR &lt; 0.1</a:t>
-            </a:r>
-          </a:p>
-        </p:txBody>
-      </p:sp>
-      <p:sp>
-        <p:nvSpPr>
-          <p:cNvPr id="23" name="Rounded Rectangle 22"/>
+              <a:t>CR &lt; 0.1</a:t>
+            </a:r>
+          </a:p>
+        </p:txBody>
+      </p:sp>
+      <p:sp>
+        <p:nvSpPr>
+          <p:cNvPr id="37" name="Rounded Rectangle 36"/>
           <p:cNvSpPr/>
           <p:nvPr/>
         </p:nvSpPr>
         <p:spPr>
           <a:xfrm>
-            <a:off x="3063240" y="2606040"/>
-            <a:ext cx="2606040" cy="868680"/>
+            <a:off x="6025896" y="1234440"/>
+            <a:ext cx="2606040" cy="384048"/>
           </a:xfrm>
           <a:prstGeom prst="roundRect">
             <a:avLst/>
           </a:prstGeom>
           <a:solidFill>
-            <a:srgbClr val="FFFFFF"/>
-          </a:solidFill>
-          <a:ln w="19050">
-            <a:solidFill>
-              <a:srgbClr val="D1D9E6"/>
-            </a:solidFill>
+            <a:srgbClr val="1E3A5F"/>
+          </a:solidFill>
+          <a:ln>
+            <a:noFill/>
           </a:ln>
         </p:spPr>
         <p:style>
@@ -3988,29 +4633,40 @@
           <a:bodyPr rtlCol="0" anchor="ctr"/>
           <a:lstStyle/>
           <a:p>
-            <a:pPr algn="ctr"/>
-          </a:p>
-        </p:txBody>
-      </p:sp>
-      <p:sp>
-        <p:nvSpPr>
-          <p:cNvPr id="24" name="Rounded Rectangle 23"/>
+            <a:pPr algn="ctr" a:rtl="1"/>
+            <a:r>
+              <a:rPr sz="1300" b="1">
+                <a:solidFill>
+                  <a:srgbClr val="FFFFFF"/>
+                </a:solidFill>
+                <a:latin typeface="Tahoma"/>
+              </a:rPr>
+              <a:t>تجمیع و خروجی</a:t>
+            </a:r>
+          </a:p>
+        </p:txBody>
+      </p:sp>
+      <p:sp>
+        <p:nvSpPr>
+          <p:cNvPr id="38" name="Rounded Rectangle 37"/>
           <p:cNvSpPr/>
           <p:nvPr/>
         </p:nvSpPr>
         <p:spPr>
           <a:xfrm>
-            <a:off x="5212080" y="2697480"/>
-            <a:ext cx="347472" cy="347472"/>
+            <a:off x="6025896" y="1728216"/>
+            <a:ext cx="2606040" cy="1051560"/>
           </a:xfrm>
           <a:prstGeom prst="roundRect">
             <a:avLst/>
           </a:prstGeom>
           <a:solidFill>
-            <a:srgbClr val="2B5C8A"/>
-          </a:solidFill>
-          <a:ln>
-            <a:noFill/>
+            <a:srgbClr val="FFFFFF"/>
+          </a:solidFill>
+          <a:ln w="15240">
+            <a:solidFill>
+              <a:srgbClr val="1E3A5F"/>
+            </a:solidFill>
           </a:ln>
         </p:spPr>
         <p:style>
@@ -4032,8 +4688,182 @@
           <a:lstStyle/>
           <a:p>
             <a:pPr algn="ctr"/>
-            <a:r>
-              <a:rPr sz="1400" b="1">
+          </a:p>
+        </p:txBody>
+      </p:sp>
+      <p:sp>
+        <p:nvSpPr>
+          <p:cNvPr id="39" name="Rectangle 38"/>
+          <p:cNvSpPr/>
+          <p:nvPr/>
+        </p:nvSpPr>
+        <p:spPr>
+          <a:xfrm>
+            <a:off x="6025896" y="1728216"/>
+            <a:ext cx="2606040" cy="54864"/>
+          </a:xfrm>
+          <a:prstGeom prst="rect">
+            <a:avLst/>
+          </a:prstGeom>
+          <a:solidFill>
+            <a:srgbClr val="1E3A5F"/>
+          </a:solidFill>
+          <a:ln>
+            <a:noFill/>
+          </a:ln>
+        </p:spPr>
+        <p:style>
+          <a:lnRef idx="1">
+            <a:schemeClr val="accent1"/>
+          </a:lnRef>
+          <a:fillRef idx="3">
+            <a:schemeClr val="accent1"/>
+          </a:fillRef>
+          <a:effectRef idx="2">
+            <a:schemeClr val="accent1"/>
+          </a:effectRef>
+          <a:fontRef idx="minor">
+            <a:schemeClr val="lt1"/>
+          </a:fontRef>
+        </p:style>
+        <p:txBody>
+          <a:bodyPr rtlCol="0" anchor="ctr"/>
+          <a:lstStyle/>
+          <a:p>
+            <a:pPr algn="ctr"/>
+          </a:p>
+        </p:txBody>
+      </p:sp>
+      <p:sp>
+        <p:nvSpPr>
+          <p:cNvPr id="40" name="Rounded Rectangle 39"/>
+          <p:cNvSpPr/>
+          <p:nvPr/>
+        </p:nvSpPr>
+        <p:spPr>
+          <a:xfrm>
+            <a:off x="6153912" y="1892808"/>
+            <a:ext cx="384048" cy="384048"/>
+          </a:xfrm>
+          <a:prstGeom prst="roundRect">
+            <a:avLst/>
+          </a:prstGeom>
+          <a:solidFill>
+            <a:srgbClr val="E8F5E9"/>
+          </a:solidFill>
+          <a:ln w="12700">
+            <a:solidFill>
+              <a:srgbClr val="1E3A5F"/>
+            </a:solidFill>
+          </a:ln>
+        </p:spPr>
+        <p:style>
+          <a:lnRef idx="1">
+            <a:schemeClr val="accent1"/>
+          </a:lnRef>
+          <a:fillRef idx="3">
+            <a:schemeClr val="accent1"/>
+          </a:fillRef>
+          <a:effectRef idx="2">
+            <a:schemeClr val="accent1"/>
+          </a:effectRef>
+          <a:fontRef idx="minor">
+            <a:schemeClr val="lt1"/>
+          </a:fontRef>
+        </p:style>
+        <p:txBody>
+          <a:bodyPr rtlCol="0" anchor="ctr"/>
+          <a:lstStyle/>
+          <a:p>
+            <a:pPr algn="ctr"/>
+          </a:p>
+        </p:txBody>
+      </p:sp>
+      <p:sp>
+        <p:nvSpPr>
+          <p:cNvPr id="41" name="Action Button: Return 40"/>
+          <p:cNvSpPr/>
+          <p:nvPr/>
+        </p:nvSpPr>
+        <p:spPr>
+          <a:xfrm>
+            <a:off x="6227064" y="1956816"/>
+            <a:ext cx="237744" cy="237744"/>
+          </a:xfrm>
+          <a:prstGeom prst="actionButtonReturn">
+            <a:avLst/>
+          </a:prstGeom>
+          <a:solidFill>
+            <a:srgbClr val="1E3A5F"/>
+          </a:solidFill>
+          <a:ln>
+            <a:noFill/>
+          </a:ln>
+        </p:spPr>
+        <p:style>
+          <a:lnRef idx="1">
+            <a:schemeClr val="accent1"/>
+          </a:lnRef>
+          <a:fillRef idx="3">
+            <a:schemeClr val="accent1"/>
+          </a:fillRef>
+          <a:effectRef idx="2">
+            <a:schemeClr val="accent1"/>
+          </a:effectRef>
+          <a:fontRef idx="minor">
+            <a:schemeClr val="lt1"/>
+          </a:fontRef>
+        </p:style>
+        <p:txBody>
+          <a:bodyPr rtlCol="0" anchor="ctr"/>
+          <a:lstStyle/>
+          <a:p>
+            <a:pPr algn="ctr"/>
+          </a:p>
+        </p:txBody>
+      </p:sp>
+      <p:sp>
+        <p:nvSpPr>
+          <p:cNvPr id="42" name="Rounded Rectangle 41"/>
+          <p:cNvSpPr/>
+          <p:nvPr/>
+        </p:nvSpPr>
+        <p:spPr>
+          <a:xfrm>
+            <a:off x="8193024" y="1856232"/>
+            <a:ext cx="310896" cy="310896"/>
+          </a:xfrm>
+          <a:prstGeom prst="roundRect">
+            <a:avLst/>
+          </a:prstGeom>
+          <a:solidFill>
+            <a:srgbClr val="1E3A5F"/>
+          </a:solidFill>
+          <a:ln>
+            <a:noFill/>
+          </a:ln>
+        </p:spPr>
+        <p:style>
+          <a:lnRef idx="1">
+            <a:schemeClr val="accent1"/>
+          </a:lnRef>
+          <a:fillRef idx="3">
+            <a:schemeClr val="accent1"/>
+          </a:fillRef>
+          <a:effectRef idx="2">
+            <a:schemeClr val="accent1"/>
+          </a:effectRef>
+          <a:fontRef idx="minor">
+            <a:schemeClr val="lt1"/>
+          </a:fontRef>
+        </p:style>
+        <p:txBody>
+          <a:bodyPr rtlCol="0" anchor="ctr"/>
+          <a:lstStyle/>
+          <a:p>
+            <a:pPr algn="ctr"/>
+            <a:r>
+              <a:rPr sz="1300" b="1">
                 <a:solidFill>
                   <a:srgbClr val="FFFFFF"/>
                 </a:solidFill>
@@ -4046,14 +4876,14 @@
       </p:sp>
       <p:sp>
         <p:nvSpPr>
-          <p:cNvPr id="25" name="TextBox 24"/>
+          <p:cNvPr id="43" name="TextBox 42"/>
           <p:cNvSpPr txBox="1"/>
           <p:nvPr/>
         </p:nvSpPr>
         <p:spPr>
           <a:xfrm>
-            <a:off x="3200400" y="2715768"/>
-            <a:ext cx="2011680" cy="320040"/>
+            <a:off x="6592824" y="1874520"/>
+            <a:ext cx="1892808" cy="292608"/>
           </a:xfrm>
           <a:prstGeom prst="rect">
             <a:avLst/>
@@ -4068,7 +4898,7 @@
           <a:p>
             <a:pPr algn="r" a:rtl="1"/>
             <a:r>
-              <a:rPr sz="1300" b="1">
+              <a:rPr sz="1200" b="1">
                 <a:solidFill>
                   <a:srgbClr val="2D343E"/>
                 </a:solidFill>
@@ -4081,14 +4911,14 @@
       </p:sp>
       <p:sp>
         <p:nvSpPr>
-          <p:cNvPr id="26" name="TextBox 25"/>
+          <p:cNvPr id="44" name="TextBox 43"/>
           <p:cNvSpPr txBox="1"/>
           <p:nvPr/>
         </p:nvSpPr>
         <p:spPr>
           <a:xfrm>
-            <a:off x="3200400" y="3044952"/>
-            <a:ext cx="2423160" cy="384048"/>
+            <a:off x="6592824" y="2185416"/>
+            <a:ext cx="1892808" cy="502920"/>
           </a:xfrm>
           <a:prstGeom prst="rect">
             <a:avLst/>
@@ -4103,27 +4933,27 @@
           <a:p>
             <a:pPr algn="r" a:rtl="1"/>
             <a:r>
-              <a:rPr sz="1000" b="0">
+              <a:rPr sz="950" b="0">
                 <a:solidFill>
                   <a:srgbClr val="6B7280"/>
                 </a:solidFill>
                 <a:latin typeface="Tahoma"/>
               </a:rPr>
-              <a:t>ادغام نظرات پذیرفته‌شده خبرگان</a:t>
-            </a:r>
-          </a:p>
-        </p:txBody>
-      </p:sp>
-      <p:sp>
-        <p:nvSpPr>
-          <p:cNvPr id="27" name="Rounded Rectangle 26"/>
+              <a:t>نظرات پذیرفته‌شده با میانگین هندسی ادغام می‌شوند</a:t>
+            </a:r>
+          </a:p>
+        </p:txBody>
+      </p:sp>
+      <p:sp>
+        <p:nvSpPr>
+          <p:cNvPr id="45" name="Rounded Rectangle 44"/>
           <p:cNvSpPr/>
           <p:nvPr/>
         </p:nvSpPr>
         <p:spPr>
           <a:xfrm>
-            <a:off x="137160" y="2606040"/>
-            <a:ext cx="2606040" cy="868680"/>
+            <a:off x="6025896" y="2944368"/>
+            <a:ext cx="2606040" cy="1051560"/>
           </a:xfrm>
           <a:prstGeom prst="roundRect">
             <a:avLst/>
@@ -4131,7 +4961,7 @@
           <a:solidFill>
             <a:srgbClr val="1E3A5F"/>
           </a:solidFill>
-          <a:ln w="19050">
+          <a:ln w="25400">
             <a:solidFill>
               <a:srgbClr val="1E3A5F"/>
             </a:solidFill>
@@ -4161,20 +4991,20 @@
       </p:sp>
       <p:sp>
         <p:nvSpPr>
-          <p:cNvPr id="28" name="Rounded Rectangle 27"/>
+          <p:cNvPr id="46" name="Rectangle 45"/>
           <p:cNvSpPr/>
           <p:nvPr/>
         </p:nvSpPr>
         <p:spPr>
           <a:xfrm>
-            <a:off x="2286000" y="2697480"/>
-            <a:ext cx="347472" cy="347472"/>
-          </a:xfrm>
-          <a:prstGeom prst="roundRect">
-            <a:avLst/>
-          </a:prstGeom>
-          <a:solidFill>
-            <a:srgbClr val="009688"/>
+            <a:off x="6025896" y="2944368"/>
+            <a:ext cx="2606040" cy="54864"/>
+          </a:xfrm>
+          <a:prstGeom prst="rect">
+            <a:avLst/>
+          </a:prstGeom>
+          <a:solidFill>
+            <a:srgbClr val="1E3A5F"/>
           </a:solidFill>
           <a:ln>
             <a:noFill/>
@@ -4199,8 +5029,139 @@
           <a:lstStyle/>
           <a:p>
             <a:pPr algn="ctr"/>
-            <a:r>
-              <a:rPr sz="1400" b="1">
+          </a:p>
+        </p:txBody>
+      </p:sp>
+      <p:sp>
+        <p:nvSpPr>
+          <p:cNvPr id="47" name="Rounded Rectangle 46"/>
+          <p:cNvSpPr/>
+          <p:nvPr/>
+        </p:nvSpPr>
+        <p:spPr>
+          <a:xfrm>
+            <a:off x="6153912" y="3108960"/>
+            <a:ext cx="384048" cy="384048"/>
+          </a:xfrm>
+          <a:prstGeom prst="roundRect">
+            <a:avLst/>
+          </a:prstGeom>
+          <a:solidFill>
+            <a:srgbClr val="E8F5E9"/>
+          </a:solidFill>
+          <a:ln w="12700">
+            <a:solidFill>
+              <a:srgbClr val="1E3A5F"/>
+            </a:solidFill>
+          </a:ln>
+        </p:spPr>
+        <p:style>
+          <a:lnRef idx="1">
+            <a:schemeClr val="accent1"/>
+          </a:lnRef>
+          <a:fillRef idx="3">
+            <a:schemeClr val="accent1"/>
+          </a:fillRef>
+          <a:effectRef idx="2">
+            <a:schemeClr val="accent1"/>
+          </a:effectRef>
+          <a:fontRef idx="minor">
+            <a:schemeClr val="lt1"/>
+          </a:fontRef>
+        </p:style>
+        <p:txBody>
+          <a:bodyPr rtlCol="0" anchor="ctr"/>
+          <a:lstStyle/>
+          <a:p>
+            <a:pPr algn="ctr"/>
+          </a:p>
+        </p:txBody>
+      </p:sp>
+      <p:sp>
+        <p:nvSpPr>
+          <p:cNvPr id="48" name="5-Point Star 47"/>
+          <p:cNvSpPr/>
+          <p:nvPr/>
+        </p:nvSpPr>
+        <p:spPr>
+          <a:xfrm>
+            <a:off x="6227064" y="3172968"/>
+            <a:ext cx="237744" cy="237744"/>
+          </a:xfrm>
+          <a:prstGeom prst="star5">
+            <a:avLst/>
+          </a:prstGeom>
+          <a:solidFill>
+            <a:srgbClr val="1E3A5F"/>
+          </a:solidFill>
+          <a:ln>
+            <a:noFill/>
+          </a:ln>
+        </p:spPr>
+        <p:style>
+          <a:lnRef idx="1">
+            <a:schemeClr val="accent1"/>
+          </a:lnRef>
+          <a:fillRef idx="3">
+            <a:schemeClr val="accent1"/>
+          </a:fillRef>
+          <a:effectRef idx="2">
+            <a:schemeClr val="accent1"/>
+          </a:effectRef>
+          <a:fontRef idx="minor">
+            <a:schemeClr val="lt1"/>
+          </a:fontRef>
+        </p:style>
+        <p:txBody>
+          <a:bodyPr rtlCol="0" anchor="ctr"/>
+          <a:lstStyle/>
+          <a:p>
+            <a:pPr algn="ctr"/>
+          </a:p>
+        </p:txBody>
+      </p:sp>
+      <p:sp>
+        <p:nvSpPr>
+          <p:cNvPr id="49" name="Rounded Rectangle 48"/>
+          <p:cNvSpPr/>
+          <p:nvPr/>
+        </p:nvSpPr>
+        <p:spPr>
+          <a:xfrm>
+            <a:off x="8193024" y="3072384"/>
+            <a:ext cx="310896" cy="310896"/>
+          </a:xfrm>
+          <a:prstGeom prst="roundRect">
+            <a:avLst/>
+          </a:prstGeom>
+          <a:solidFill>
+            <a:srgbClr val="1E3A5F"/>
+          </a:solidFill>
+          <a:ln>
+            <a:noFill/>
+          </a:ln>
+        </p:spPr>
+        <p:style>
+          <a:lnRef idx="1">
+            <a:schemeClr val="accent1"/>
+          </a:lnRef>
+          <a:fillRef idx="3">
+            <a:schemeClr val="accent1"/>
+          </a:fillRef>
+          <a:effectRef idx="2">
+            <a:schemeClr val="accent1"/>
+          </a:effectRef>
+          <a:fontRef idx="minor">
+            <a:schemeClr val="lt1"/>
+          </a:fontRef>
+        </p:style>
+        <p:txBody>
+          <a:bodyPr rtlCol="0" anchor="ctr"/>
+          <a:lstStyle/>
+          <a:p>
+            <a:pPr algn="ctr"/>
+            <a:r>
+              <a:rPr sz="1300" b="1">
                 <a:solidFill>
                   <a:srgbClr val="FFFFFF"/>
                 </a:solidFill>
@@ -4213,14 +5174,14 @@
       </p:sp>
       <p:sp>
         <p:nvSpPr>
-          <p:cNvPr id="29" name="TextBox 28"/>
+          <p:cNvPr id="50" name="TextBox 49"/>
           <p:cNvSpPr txBox="1"/>
           <p:nvPr/>
         </p:nvSpPr>
         <p:spPr>
           <a:xfrm>
-            <a:off x="274320" y="2715768"/>
-            <a:ext cx="2011680" cy="320040"/>
+            <a:off x="6592824" y="3090672"/>
+            <a:ext cx="1892808" cy="292608"/>
           </a:xfrm>
           <a:prstGeom prst="rect">
             <a:avLst/>
@@ -4235,7 +5196,7 @@
           <a:p>
             <a:pPr algn="r" a:rtl="1"/>
             <a:r>
-              <a:rPr sz="1300" b="1">
+              <a:rPr sz="1200" b="1">
                 <a:solidFill>
                   <a:srgbClr val="FFFFFF"/>
                 </a:solidFill>
@@ -4248,14 +5209,14 @@
       </p:sp>
       <p:sp>
         <p:nvSpPr>
-          <p:cNvPr id="30" name="TextBox 29"/>
+          <p:cNvPr id="51" name="TextBox 50"/>
           <p:cNvSpPr txBox="1"/>
           <p:nvPr/>
         </p:nvSpPr>
         <p:spPr>
           <a:xfrm>
-            <a:off x="274320" y="3044952"/>
-            <a:ext cx="2423160" cy="384048"/>
+            <a:off x="6592824" y="3401568"/>
+            <a:ext cx="1892808" cy="502920"/>
           </a:xfrm>
           <a:prstGeom prst="rect">
             <a:avLst/>
@@ -4270,7 +5231,7 @@
           <a:p>
             <a:pPr algn="r" a:rtl="1"/>
             <a:r>
-              <a:rPr sz="1000" b="0">
+              <a:rPr sz="950" b="0">
                 <a:solidFill>
                   <a:srgbClr val="BBDEFB"/>
                 </a:solidFill>
@@ -4281,206 +5242,26 @@
           </a:p>
         </p:txBody>
       </p:sp>
-      <p:cxnSp>
-        <p:nvCxnSpPr>
-          <p:cNvPr id="31" name="Connector 30"/>
-          <p:cNvCxnSpPr/>
-          <p:nvPr/>
-        </p:nvCxnSpPr>
-        <p:spPr>
-          <a:xfrm flipH="1">
-            <a:off x="5669280" y="1668780.0"/>
-            <a:ext cx="320040" cy="0.0"/>
-          </a:xfrm>
-          <a:prstGeom prst="line">
-            <a:avLst/>
-          </a:prstGeom>
-          <a:ln w="31750">
-            <a:solidFill>
-              <a:srgbClr val="009688"/>
-            </a:solidFill>
-            <a:tailEnd type="triangle"/>
-          </a:ln>
-        </p:spPr>
-        <p:style>
-          <a:lnRef idx="2">
-            <a:schemeClr val="accent1"/>
-          </a:lnRef>
-          <a:fillRef idx="0">
-            <a:schemeClr val="accent1"/>
-          </a:fillRef>
-          <a:effectRef idx="1">
-            <a:schemeClr val="accent1"/>
-          </a:effectRef>
-          <a:fontRef idx="minor">
-            <a:schemeClr val="tx1"/>
-          </a:fontRef>
-        </p:style>
-      </p:cxnSp>
-      <p:cxnSp>
-        <p:nvCxnSpPr>
-          <p:cNvPr id="32" name="Connector 31"/>
-          <p:cNvCxnSpPr/>
-          <p:nvPr/>
-        </p:nvCxnSpPr>
-        <p:spPr>
-          <a:xfrm flipH="1">
-            <a:off x="2743200" y="1668780.0"/>
-            <a:ext cx="320040" cy="0.0"/>
-          </a:xfrm>
-          <a:prstGeom prst="line">
-            <a:avLst/>
-          </a:prstGeom>
-          <a:ln w="31750">
-            <a:solidFill>
-              <a:srgbClr val="009688"/>
-            </a:solidFill>
-            <a:tailEnd type="triangle"/>
-          </a:ln>
-        </p:spPr>
-        <p:style>
-          <a:lnRef idx="2">
-            <a:schemeClr val="accent1"/>
-          </a:lnRef>
-          <a:fillRef idx="0">
-            <a:schemeClr val="accent1"/>
-          </a:fillRef>
-          <a:effectRef idx="1">
-            <a:schemeClr val="accent1"/>
-          </a:effectRef>
-          <a:fontRef idx="minor">
-            <a:schemeClr val="tx1"/>
-          </a:fontRef>
-        </p:style>
-      </p:cxnSp>
-      <p:cxnSp>
-        <p:nvCxnSpPr>
-          <p:cNvPr id="33" name="Connector 32"/>
-          <p:cNvCxnSpPr/>
-          <p:nvPr/>
-        </p:nvCxnSpPr>
-        <p:spPr>
-          <a:xfrm>
-            <a:off x="1440180.0" y="2103120"/>
-            <a:ext cx="0.0" cy="502920"/>
-          </a:xfrm>
-          <a:prstGeom prst="line">
-            <a:avLst/>
-          </a:prstGeom>
-          <a:ln w="31750">
-            <a:solidFill>
-              <a:srgbClr val="009688"/>
-            </a:solidFill>
-            <a:tailEnd type="triangle"/>
-          </a:ln>
-        </p:spPr>
-        <p:style>
-          <a:lnRef idx="2">
-            <a:schemeClr val="accent1"/>
-          </a:lnRef>
-          <a:fillRef idx="0">
-            <a:schemeClr val="accent1"/>
-          </a:fillRef>
-          <a:effectRef idx="1">
-            <a:schemeClr val="accent1"/>
-          </a:effectRef>
-          <a:fontRef idx="minor">
-            <a:schemeClr val="tx1"/>
-          </a:fontRef>
-        </p:style>
-      </p:cxnSp>
-      <p:cxnSp>
-        <p:nvCxnSpPr>
-          <p:cNvPr id="34" name="Connector 33"/>
-          <p:cNvCxnSpPr/>
-          <p:nvPr/>
-        </p:nvCxnSpPr>
-        <p:spPr>
-          <a:xfrm flipH="1">
-            <a:off x="5669280" y="3040380.0"/>
-            <a:ext cx="320040" cy="0.0"/>
-          </a:xfrm>
-          <a:prstGeom prst="line">
-            <a:avLst/>
-          </a:prstGeom>
-          <a:ln w="31750">
-            <a:solidFill>
-              <a:srgbClr val="009688"/>
-            </a:solidFill>
-            <a:tailEnd type="triangle"/>
-          </a:ln>
-        </p:spPr>
-        <p:style>
-          <a:lnRef idx="2">
-            <a:schemeClr val="accent1"/>
-          </a:lnRef>
-          <a:fillRef idx="0">
-            <a:schemeClr val="accent1"/>
-          </a:fillRef>
-          <a:effectRef idx="1">
-            <a:schemeClr val="accent1"/>
-          </a:effectRef>
-          <a:fontRef idx="minor">
-            <a:schemeClr val="tx1"/>
-          </a:fontRef>
-        </p:style>
-      </p:cxnSp>
-      <p:cxnSp>
-        <p:nvCxnSpPr>
-          <p:cNvPr id="35" name="Connector 34"/>
-          <p:cNvCxnSpPr/>
-          <p:nvPr/>
-        </p:nvCxnSpPr>
-        <p:spPr>
-          <a:xfrm flipH="1">
-            <a:off x="2743200" y="3040380.0"/>
-            <a:ext cx="320040" cy="0.0"/>
-          </a:xfrm>
-          <a:prstGeom prst="line">
-            <a:avLst/>
-          </a:prstGeom>
-          <a:ln w="31750">
-            <a:solidFill>
-              <a:srgbClr val="009688"/>
-            </a:solidFill>
-            <a:tailEnd type="triangle"/>
-          </a:ln>
-        </p:spPr>
-        <p:style>
-          <a:lnRef idx="2">
-            <a:schemeClr val="accent1"/>
-          </a:lnRef>
-          <a:fillRef idx="0">
-            <a:schemeClr val="accent1"/>
-          </a:fillRef>
-          <a:effectRef idx="1">
-            <a:schemeClr val="accent1"/>
-          </a:effectRef>
-          <a:fontRef idx="minor">
-            <a:schemeClr val="tx1"/>
-          </a:fontRef>
-        </p:style>
-      </p:cxnSp>
-      <p:sp>
-        <p:nvSpPr>
-          <p:cNvPr id="36" name="Rounded Rectangle 35"/>
+      <p:sp>
+        <p:nvSpPr>
+          <p:cNvPr id="52" name="Rounded Rectangle 51"/>
           <p:cNvSpPr/>
           <p:nvPr/>
         </p:nvSpPr>
         <p:spPr>
           <a:xfrm>
-            <a:off x="4572000" y="2926080"/>
-            <a:ext cx="1280160" cy="502920"/>
+            <a:off x="411480" y="4315968"/>
+            <a:ext cx="8321040" cy="566928"/>
           </a:xfrm>
           <a:prstGeom prst="roundRect">
             <a:avLst/>
           </a:prstGeom>
           <a:solidFill>
-            <a:srgbClr val="FFEBEE"/>
-          </a:solidFill>
-          <a:ln w="19050">
+            <a:srgbClr val="FFF3E0"/>
+          </a:solidFill>
+          <a:ln w="12700">
             <a:solidFill>
-              <a:srgbClr val="C62828"/>
+              <a:srgbClr val="F57C00"/>
             </a:solidFill>
           </a:ln>
         </p:spPr>
@@ -4508,14 +5289,14 @@
       </p:sp>
       <p:sp>
         <p:nvSpPr>
-          <p:cNvPr id="37" name="TextBox 36"/>
+          <p:cNvPr id="53" name="TextBox 52"/>
           <p:cNvSpPr txBox="1"/>
           <p:nvPr/>
         </p:nvSpPr>
         <p:spPr>
           <a:xfrm>
-            <a:off x="4617720" y="2971800"/>
-            <a:ext cx="1188720" cy="411480"/>
+            <a:off x="548640" y="4434840"/>
+            <a:ext cx="8046720" cy="347472"/>
           </a:xfrm>
           <a:prstGeom prst="rect">
             <a:avLst/>
@@ -4529,204 +5310,6 @@
           <a:lstStyle/>
           <a:p>
             <a:pPr algn="ctr" a:rtl="1"/>
-            <a:r>
-              <a:rPr sz="900" b="1">
-                <a:solidFill>
-                  <a:srgbClr val="C62828"/>
-                </a:solidFill>
-                <a:latin typeface="Tahoma"/>
-              </a:rPr>
-              <a:t>CR ≥ 0.1</a:t>
-            </a:r>
-            <a:br/>
-            <a:r>
-              <a:t>بازنگری / حذف</a:t>
-            </a:r>
-          </a:p>
-        </p:txBody>
-      </p:sp>
-      <p:cxnSp>
-        <p:nvCxnSpPr>
-          <p:cNvPr id="38" name="Connector 37"/>
-          <p:cNvCxnSpPr/>
-          <p:nvPr/>
-        </p:nvCxnSpPr>
-        <p:spPr>
-          <a:xfrm flipH="1">
-            <a:off x="5852160" y="3154680"/>
-            <a:ext cx="137160" cy="27432"/>
-          </a:xfrm>
-          <a:prstGeom prst="line">
-            <a:avLst/>
-          </a:prstGeom>
-          <a:ln w="19050">
-            <a:solidFill>
-              <a:srgbClr val="C62828"/>
-            </a:solidFill>
-            <a:prstDash val="sysDot"/>
-          </a:ln>
-        </p:spPr>
-        <p:style>
-          <a:lnRef idx="2">
-            <a:schemeClr val="accent1"/>
-          </a:lnRef>
-          <a:fillRef idx="0">
-            <a:schemeClr val="accent1"/>
-          </a:fillRef>
-          <a:effectRef idx="1">
-            <a:schemeClr val="accent1"/>
-          </a:effectRef>
-          <a:fontRef idx="minor">
-            <a:schemeClr val="tx1"/>
-          </a:fontRef>
-        </p:style>
-      </p:cxnSp>
-      <p:sp>
-        <p:nvSpPr>
-          <p:cNvPr id="39" name="Rounded Rectangle 38"/>
-          <p:cNvSpPr/>
-          <p:nvPr/>
-        </p:nvSpPr>
-        <p:spPr>
-          <a:xfrm>
-            <a:off x="365760" y="1234440"/>
-            <a:ext cx="2286000" cy="2331720"/>
-          </a:xfrm>
-          <a:prstGeom prst="roundRect">
-            <a:avLst/>
-          </a:prstGeom>
-          <a:solidFill>
-            <a:srgbClr val="FFFFFF"/>
-          </a:solidFill>
-          <a:ln w="19050">
-            <a:solidFill>
-              <a:srgbClr val="D1D9E6"/>
-            </a:solidFill>
-          </a:ln>
-        </p:spPr>
-        <p:style>
-          <a:lnRef idx="1">
-            <a:schemeClr val="accent1"/>
-          </a:lnRef>
-          <a:fillRef idx="3">
-            <a:schemeClr val="accent1"/>
-          </a:fillRef>
-          <a:effectRef idx="2">
-            <a:schemeClr val="accent1"/>
-          </a:effectRef>
-          <a:fontRef idx="minor">
-            <a:schemeClr val="lt1"/>
-          </a:fontRef>
-        </p:style>
-        <p:txBody>
-          <a:bodyPr rtlCol="0" anchor="ctr"/>
-          <a:lstStyle/>
-          <a:p>
-            <a:pPr algn="ctr"/>
-          </a:p>
-        </p:txBody>
-      </p:sp>
-      <p:sp>
-        <p:nvSpPr>
-          <p:cNvPr id="40" name="TextBox 39"/>
-          <p:cNvSpPr txBox="1"/>
-          <p:nvPr/>
-        </p:nvSpPr>
-        <p:spPr>
-          <a:xfrm>
-            <a:off x="502920" y="1371600"/>
-            <a:ext cx="2011680" cy="274320"/>
-          </a:xfrm>
-          <a:prstGeom prst="rect">
-            <a:avLst/>
-          </a:prstGeom>
-          <a:noFill/>
-        </p:spPr>
-        <p:txBody>
-          <a:bodyPr wrap="square" anchor="ctr">
-            <a:spAutoFit/>
-          </a:bodyPr>
-          <a:lstStyle/>
-          <a:p>
-            <a:pPr algn="ctr" a:rtl="1"/>
-            <a:r>
-              <a:rPr sz="1300" b="1">
-                <a:solidFill>
-                  <a:srgbClr val="1E3A5F"/>
-                </a:solidFill>
-                <a:latin typeface="Tahoma"/>
-              </a:rPr>
-              <a:t>راهنمای نمادها</a:t>
-            </a:r>
-          </a:p>
-        </p:txBody>
-      </p:sp>
-      <p:sp>
-        <p:nvSpPr>
-          <p:cNvPr id="41" name="Oval 40"/>
-          <p:cNvSpPr/>
-          <p:nvPr/>
-        </p:nvSpPr>
-        <p:spPr>
-          <a:xfrm>
-            <a:off x="594360" y="1737360"/>
-            <a:ext cx="164592" cy="164592"/>
-          </a:xfrm>
-          <a:prstGeom prst="ellipse">
-            <a:avLst/>
-          </a:prstGeom>
-          <a:solidFill>
-            <a:srgbClr val="2B5C8A"/>
-          </a:solidFill>
-          <a:ln>
-            <a:noFill/>
-          </a:ln>
-        </p:spPr>
-        <p:style>
-          <a:lnRef idx="1">
-            <a:schemeClr val="accent1"/>
-          </a:lnRef>
-          <a:fillRef idx="3">
-            <a:schemeClr val="accent1"/>
-          </a:fillRef>
-          <a:effectRef idx="2">
-            <a:schemeClr val="accent1"/>
-          </a:effectRef>
-          <a:fontRef idx="minor">
-            <a:schemeClr val="lt1"/>
-          </a:fontRef>
-        </p:style>
-        <p:txBody>
-          <a:bodyPr rtlCol="0" anchor="ctr"/>
-          <a:lstStyle/>
-          <a:p>
-            <a:pPr algn="ctr"/>
-          </a:p>
-        </p:txBody>
-      </p:sp>
-      <p:sp>
-        <p:nvSpPr>
-          <p:cNvPr id="42" name="TextBox 41"/>
-          <p:cNvSpPr txBox="1"/>
-          <p:nvPr/>
-        </p:nvSpPr>
-        <p:spPr>
-          <a:xfrm>
-            <a:off x="868680" y="1719072"/>
-            <a:ext cx="1645920" cy="228600"/>
-          </a:xfrm>
-          <a:prstGeom prst="rect">
-            <a:avLst/>
-          </a:prstGeom>
-          <a:noFill/>
-        </p:spPr>
-        <p:txBody>
-          <a:bodyPr wrap="square" anchor="ctr">
-            <a:spAutoFit/>
-          </a:bodyPr>
-          <a:lstStyle/>
-          <a:p>
-            <a:pPr algn="r" a:rtl="1"/>
             <a:r>
               <a:rPr sz="1000" b="0">
                 <a:solidFill>
@@ -4734,434 +5317,7 @@
                 </a:solidFill>
                 <a:latin typeface="Tahoma"/>
               </a:rPr>
-              <a:t>مرحله پردازش</a:t>
-            </a:r>
-          </a:p>
-        </p:txBody>
-      </p:sp>
-      <p:sp>
-        <p:nvSpPr>
-          <p:cNvPr id="43" name="Oval 42"/>
-          <p:cNvSpPr/>
-          <p:nvPr/>
-        </p:nvSpPr>
-        <p:spPr>
-          <a:xfrm>
-            <a:off x="594360" y="2084832"/>
-            <a:ext cx="164592" cy="164592"/>
-          </a:xfrm>
-          <a:prstGeom prst="ellipse">
-            <a:avLst/>
-          </a:prstGeom>
-          <a:solidFill>
-            <a:srgbClr val="009688"/>
-          </a:solidFill>
-          <a:ln>
-            <a:noFill/>
-          </a:ln>
-        </p:spPr>
-        <p:style>
-          <a:lnRef idx="1">
-            <a:schemeClr val="accent1"/>
-          </a:lnRef>
-          <a:fillRef idx="3">
-            <a:schemeClr val="accent1"/>
-          </a:fillRef>
-          <a:effectRef idx="2">
-            <a:schemeClr val="accent1"/>
-          </a:effectRef>
-          <a:fontRef idx="minor">
-            <a:schemeClr val="lt1"/>
-          </a:fontRef>
-        </p:style>
-        <p:txBody>
-          <a:bodyPr rtlCol="0" anchor="ctr"/>
-          <a:lstStyle/>
-          <a:p>
-            <a:pPr algn="ctr"/>
-          </a:p>
-        </p:txBody>
-      </p:sp>
-      <p:sp>
-        <p:nvSpPr>
-          <p:cNvPr id="44" name="TextBox 43"/>
-          <p:cNvSpPr txBox="1"/>
-          <p:nvPr/>
-        </p:nvSpPr>
-        <p:spPr>
-          <a:xfrm>
-            <a:off x="868680" y="2066544"/>
-            <a:ext cx="1645920" cy="228600"/>
-          </a:xfrm>
-          <a:prstGeom prst="rect">
-            <a:avLst/>
-          </a:prstGeom>
-          <a:noFill/>
-        </p:spPr>
-        <p:txBody>
-          <a:bodyPr wrap="square" anchor="ctr">
-            <a:spAutoFit/>
-          </a:bodyPr>
-          <a:lstStyle/>
-          <a:p>
-            <a:pPr algn="r" a:rtl="1"/>
-            <a:r>
-              <a:rPr sz="1000" b="0">
-                <a:solidFill>
-                  <a:srgbClr val="2D343E"/>
-                </a:solidFill>
-                <a:latin typeface="Tahoma"/>
-              </a:rPr>
-              <a:t>بررسی سازگاری</a:t>
-            </a:r>
-          </a:p>
-        </p:txBody>
-      </p:sp>
-      <p:sp>
-        <p:nvSpPr>
-          <p:cNvPr id="45" name="Oval 44"/>
-          <p:cNvSpPr/>
-          <p:nvPr/>
-        </p:nvSpPr>
-        <p:spPr>
-          <a:xfrm>
-            <a:off x="594360" y="2432304"/>
-            <a:ext cx="164592" cy="164592"/>
-          </a:xfrm>
-          <a:prstGeom prst="ellipse">
-            <a:avLst/>
-          </a:prstGeom>
-          <a:solidFill>
-            <a:srgbClr val="2E7D32"/>
-          </a:solidFill>
-          <a:ln>
-            <a:noFill/>
-          </a:ln>
-        </p:spPr>
-        <p:style>
-          <a:lnRef idx="1">
-            <a:schemeClr val="accent1"/>
-          </a:lnRef>
-          <a:fillRef idx="3">
-            <a:schemeClr val="accent1"/>
-          </a:fillRef>
-          <a:effectRef idx="2">
-            <a:schemeClr val="accent1"/>
-          </a:effectRef>
-          <a:fontRef idx="minor">
-            <a:schemeClr val="lt1"/>
-          </a:fontRef>
-        </p:style>
-        <p:txBody>
-          <a:bodyPr rtlCol="0" anchor="ctr"/>
-          <a:lstStyle/>
-          <a:p>
-            <a:pPr algn="ctr"/>
-          </a:p>
-        </p:txBody>
-      </p:sp>
-      <p:sp>
-        <p:nvSpPr>
-          <p:cNvPr id="46" name="TextBox 45"/>
-          <p:cNvSpPr txBox="1"/>
-          <p:nvPr/>
-        </p:nvSpPr>
-        <p:spPr>
-          <a:xfrm>
-            <a:off x="868680" y="2414016"/>
-            <a:ext cx="1645920" cy="228600"/>
-          </a:xfrm>
-          <a:prstGeom prst="rect">
-            <a:avLst/>
-          </a:prstGeom>
-          <a:noFill/>
-        </p:spPr>
-        <p:txBody>
-          <a:bodyPr wrap="square" anchor="ctr">
-            <a:spAutoFit/>
-          </a:bodyPr>
-          <a:lstStyle/>
-          <a:p>
-            <a:pPr algn="r" a:rtl="1"/>
-            <a:r>
-              <a:rPr sz="1000" b="0">
-                <a:solidFill>
-                  <a:srgbClr val="2D343E"/>
-                </a:solidFill>
-                <a:latin typeface="Tahoma"/>
-              </a:rPr>
-              <a:t>فیلتر پذیرش (CR)</a:t>
-            </a:r>
-          </a:p>
-        </p:txBody>
-      </p:sp>
-      <p:sp>
-        <p:nvSpPr>
-          <p:cNvPr id="47" name="Oval 46"/>
-          <p:cNvSpPr/>
-          <p:nvPr/>
-        </p:nvSpPr>
-        <p:spPr>
-          <a:xfrm>
-            <a:off x="594360" y="2779776"/>
-            <a:ext cx="164592" cy="164592"/>
-          </a:xfrm>
-          <a:prstGeom prst="ellipse">
-            <a:avLst/>
-          </a:prstGeom>
-          <a:solidFill>
-            <a:srgbClr val="1E3A5F"/>
-          </a:solidFill>
-          <a:ln>
-            <a:noFill/>
-          </a:ln>
-        </p:spPr>
-        <p:style>
-          <a:lnRef idx="1">
-            <a:schemeClr val="accent1"/>
-          </a:lnRef>
-          <a:fillRef idx="3">
-            <a:schemeClr val="accent1"/>
-          </a:fillRef>
-          <a:effectRef idx="2">
-            <a:schemeClr val="accent1"/>
-          </a:effectRef>
-          <a:fontRef idx="minor">
-            <a:schemeClr val="lt1"/>
-          </a:fontRef>
-        </p:style>
-        <p:txBody>
-          <a:bodyPr rtlCol="0" anchor="ctr"/>
-          <a:lstStyle/>
-          <a:p>
-            <a:pPr algn="ctr"/>
-          </a:p>
-        </p:txBody>
-      </p:sp>
-      <p:sp>
-        <p:nvSpPr>
-          <p:cNvPr id="48" name="TextBox 47"/>
-          <p:cNvSpPr txBox="1"/>
-          <p:nvPr/>
-        </p:nvSpPr>
-        <p:spPr>
-          <a:xfrm>
-            <a:off x="868680" y="2761488"/>
-            <a:ext cx="1645920" cy="228600"/>
-          </a:xfrm>
-          <a:prstGeom prst="rect">
-            <a:avLst/>
-          </a:prstGeom>
-          <a:noFill/>
-        </p:spPr>
-        <p:txBody>
-          <a:bodyPr wrap="square" anchor="ctr">
-            <a:spAutoFit/>
-          </a:bodyPr>
-          <a:lstStyle/>
-          <a:p>
-            <a:pPr algn="r" a:rtl="1"/>
-            <a:r>
-              <a:rPr sz="1000" b="0">
-                <a:solidFill>
-                  <a:srgbClr val="2D343E"/>
-                </a:solidFill>
-                <a:latin typeface="Tahoma"/>
-              </a:rPr>
-              <a:t>خروجی نهایی</a:t>
-            </a:r>
-          </a:p>
-        </p:txBody>
-      </p:sp>
-      <p:sp>
-        <p:nvSpPr>
-          <p:cNvPr id="49" name="Oval 48"/>
-          <p:cNvSpPr/>
-          <p:nvPr/>
-        </p:nvSpPr>
-        <p:spPr>
-          <a:xfrm>
-            <a:off x="594360" y="3127248"/>
-            <a:ext cx="164592" cy="164592"/>
-          </a:xfrm>
-          <a:prstGeom prst="ellipse">
-            <a:avLst/>
-          </a:prstGeom>
-          <a:solidFill>
-            <a:srgbClr val="C62828"/>
-          </a:solidFill>
-          <a:ln>
-            <a:noFill/>
-          </a:ln>
-        </p:spPr>
-        <p:style>
-          <a:lnRef idx="1">
-            <a:schemeClr val="accent1"/>
-          </a:lnRef>
-          <a:fillRef idx="3">
-            <a:schemeClr val="accent1"/>
-          </a:fillRef>
-          <a:effectRef idx="2">
-            <a:schemeClr val="accent1"/>
-          </a:effectRef>
-          <a:fontRef idx="minor">
-            <a:schemeClr val="lt1"/>
-          </a:fontRef>
-        </p:style>
-        <p:txBody>
-          <a:bodyPr rtlCol="0" anchor="ctr"/>
-          <a:lstStyle/>
-          <a:p>
-            <a:pPr algn="ctr"/>
-          </a:p>
-        </p:txBody>
-      </p:sp>
-      <p:sp>
-        <p:nvSpPr>
-          <p:cNvPr id="50" name="TextBox 49"/>
-          <p:cNvSpPr txBox="1"/>
-          <p:nvPr/>
-        </p:nvSpPr>
-        <p:spPr>
-          <a:xfrm>
-            <a:off x="868680" y="3108960"/>
-            <a:ext cx="1645920" cy="228600"/>
-          </a:xfrm>
-          <a:prstGeom prst="rect">
-            <a:avLst/>
-          </a:prstGeom>
-          <a:noFill/>
-        </p:spPr>
-        <p:txBody>
-          <a:bodyPr wrap="square" anchor="ctr">
-            <a:spAutoFit/>
-          </a:bodyPr>
-          <a:lstStyle/>
-          <a:p>
-            <a:pPr algn="r" a:rtl="1"/>
-            <a:r>
-              <a:rPr sz="1000" b="0">
-                <a:solidFill>
-                  <a:srgbClr val="2D343E"/>
-                </a:solidFill>
-                <a:latin typeface="Tahoma"/>
-              </a:rPr>
-              <a:t>رد / بازنگری</a:t>
-            </a:r>
-          </a:p>
-        </p:txBody>
-      </p:sp>
-      <p:sp>
-        <p:nvSpPr>
-          <p:cNvPr id="51" name="Rounded Rectangle 50"/>
-          <p:cNvSpPr/>
-          <p:nvPr/>
-        </p:nvSpPr>
-        <p:spPr>
-          <a:xfrm>
-            <a:off x="365760" y="3794760"/>
-            <a:ext cx="2286000" cy="777240"/>
-          </a:xfrm>
-          <a:prstGeom prst="roundRect">
-            <a:avLst/>
-          </a:prstGeom>
-          <a:solidFill>
-            <a:srgbClr val="FFF3E0"/>
-          </a:solidFill>
-          <a:ln w="19050">
-            <a:solidFill>
-              <a:srgbClr val="F57C00"/>
-            </a:solidFill>
-          </a:ln>
-        </p:spPr>
-        <p:style>
-          <a:lnRef idx="1">
-            <a:schemeClr val="accent1"/>
-          </a:lnRef>
-          <a:fillRef idx="3">
-            <a:schemeClr val="accent1"/>
-          </a:fillRef>
-          <a:effectRef idx="2">
-            <a:schemeClr val="accent1"/>
-          </a:effectRef>
-          <a:fontRef idx="minor">
-            <a:schemeClr val="lt1"/>
-          </a:fontRef>
-        </p:style>
-        <p:txBody>
-          <a:bodyPr rtlCol="0" anchor="ctr"/>
-          <a:lstStyle/>
-          <a:p>
-            <a:pPr algn="ctr"/>
-          </a:p>
-        </p:txBody>
-      </p:sp>
-      <p:sp>
-        <p:nvSpPr>
-          <p:cNvPr id="52" name="TextBox 51"/>
-          <p:cNvSpPr txBox="1"/>
-          <p:nvPr/>
-        </p:nvSpPr>
-        <p:spPr>
-          <a:xfrm>
-            <a:off x="502920" y="3913632"/>
-            <a:ext cx="2011680" cy="228600"/>
-          </a:xfrm>
-          <a:prstGeom prst="rect">
-            <a:avLst/>
-          </a:prstGeom>
-          <a:noFill/>
-        </p:spPr>
-        <p:txBody>
-          <a:bodyPr wrap="square" anchor="ctr">
-            <a:spAutoFit/>
-          </a:bodyPr>
-          <a:lstStyle/>
-          <a:p>
-            <a:pPr algn="ctr" a:rtl="1"/>
-            <a:r>
-              <a:rPr sz="1100" b="1">
-                <a:solidFill>
-                  <a:srgbClr val="F57C00"/>
-                </a:solidFill>
-                <a:latin typeface="Tahoma"/>
-              </a:rPr>
-              <a:t>مقیاس ساعتی AHP</a:t>
-            </a:r>
-          </a:p>
-        </p:txBody>
-      </p:sp>
-      <p:sp>
-        <p:nvSpPr>
-          <p:cNvPr id="53" name="TextBox 52"/>
-          <p:cNvSpPr txBox="1"/>
-          <p:nvPr/>
-        </p:nvSpPr>
-        <p:spPr>
-          <a:xfrm>
-            <a:off x="502920" y="4160520"/>
-            <a:ext cx="2011680" cy="274320"/>
-          </a:xfrm>
-          <a:prstGeom prst="rect">
-            <a:avLst/>
-          </a:prstGeom>
-          <a:noFill/>
-        </p:spPr>
-        <p:txBody>
-          <a:bodyPr wrap="square" anchor="ctr">
-            <a:spAutoFit/>
-          </a:bodyPr>
-          <a:lstStyle/>
-          <a:p>
-            <a:pPr algn="ctr" a:rtl="1"/>
-            <a:r>
-              <a:rPr sz="900" b="0">
-                <a:solidFill>
-                  <a:srgbClr val="2D343E"/>
-                </a:solidFill>
-                <a:latin typeface="Tahoma"/>
-              </a:rPr>
-              <a:t>۱ = برابر  ·  ۳ = متوسط  ·  ۵ = قوی  ·  ۹ = مطلق</a:t>
+              <a:t>مقیاس ساعتی: ۱ = برابر  ·  ۳ = متوسط  ·  ۵ = قوی  ·  ۷ = خیلی قوی  ·  ۹ = مطلق  |  آستانه سازگاری: CR &lt; 0.1</a:t>
             </a:r>
           </a:p>
         </p:txBody>
@@ -5174,8 +5330,8 @@
         </p:nvSpPr>
         <p:spPr>
           <a:xfrm>
-            <a:off x="365760" y="4663440"/>
-            <a:ext cx="8412480" cy="228600"/>
+            <a:off x="411480" y="4681728"/>
+            <a:ext cx="8321040" cy="201168"/>
           </a:xfrm>
           <a:prstGeom prst="rect">
             <a:avLst/>

</xml_diff>

<commit_message>
Redesign AHP process slide as horizontal RTL timeline
Replace card grid with numbered circles on a horizontal axis,
alternating labels above/below, phase color bands, and start/end markers.

Co-authored-by: sazmanfava854-sudo <sazmanfava854-sudo@users.noreply.github.com>
</commit_message>
<xml_diff>
--- a/presentations/فرآیند_تجمیع_نظرات_خبرگان_AHP.pptx
+++ b/presentations/فرآیند_تجمیع_نظرات_خبرگان_AHP.pptx
@@ -3196,7 +3196,7 @@
           </a:bodyPr>
           <a:lstStyle/>
           <a:p>
-            <a:pPr algn="r" a:rtl="1"/>
+            <a:pPr algn="ctr" a:rtl="1"/>
             <a:r>
               <a:rPr sz="2800" b="1">
                 <a:solidFill>
@@ -3231,7 +3231,7 @@
           </a:bodyPr>
           <a:lstStyle/>
           <a:p>
-            <a:pPr algn="r" a:rtl="1"/>
+            <a:pPr algn="ctr" a:rtl="1"/>
             <a:r>
               <a:rPr sz="1300" b="0">
                 <a:solidFill>
@@ -3239,23 +3239,66 @@
                 </a:solidFill>
                 <a:latin typeface="Tahoma"/>
               </a:rPr>
-              <a:t>سه فاز: گردآوری داده  ·  کنترل کیفیت  ·  تجمیع و خروجی</a:t>
-            </a:r>
-          </a:p>
-        </p:txBody>
-      </p:sp>
-      <p:sp>
-        <p:nvSpPr>
-          <p:cNvPr id="6" name="Rounded Rectangle 5"/>
+              <a:t>تایم‌لاین افقی مراحل فرآیند</a:t>
+            </a:r>
+          </a:p>
+        </p:txBody>
+      </p:sp>
+      <p:sp>
+        <p:nvSpPr>
+          <p:cNvPr id="6" name="Rectangle 5"/>
           <p:cNvSpPr/>
           <p:nvPr/>
         </p:nvSpPr>
         <p:spPr>
           <a:xfrm>
-            <a:off x="411480" y="1234440"/>
-            <a:ext cx="2606040" cy="384048"/>
-          </a:xfrm>
-          <a:prstGeom prst="roundRect">
+            <a:off x="685800" y="2672080"/>
+            <a:ext cx="7772400" cy="50800"/>
+          </a:xfrm>
+          <a:prstGeom prst="rect">
+            <a:avLst/>
+          </a:prstGeom>
+          <a:solidFill>
+            <a:srgbClr val="D1D9E6"/>
+          </a:solidFill>
+          <a:ln>
+            <a:noFill/>
+          </a:ln>
+        </p:spPr>
+        <p:style>
+          <a:lnRef idx="1">
+            <a:schemeClr val="accent1"/>
+          </a:lnRef>
+          <a:fillRef idx="3">
+            <a:schemeClr val="accent1"/>
+          </a:fillRef>
+          <a:effectRef idx="2">
+            <a:schemeClr val="accent1"/>
+          </a:effectRef>
+          <a:fontRef idx="minor">
+            <a:schemeClr val="lt1"/>
+          </a:fontRef>
+        </p:style>
+        <p:txBody>
+          <a:bodyPr rtlCol="0" anchor="ctr"/>
+          <a:lstStyle/>
+          <a:p>
+            <a:pPr algn="ctr"/>
+          </a:p>
+        </p:txBody>
+      </p:sp>
+      <p:sp>
+        <p:nvSpPr>
+          <p:cNvPr id="7" name="Rectangle 6"/>
+          <p:cNvSpPr/>
+          <p:nvPr/>
+        </p:nvSpPr>
+        <p:spPr>
+          <a:xfrm>
+            <a:off x="685800" y="2852928"/>
+            <a:ext cx="2377440" cy="36576"/>
+          </a:xfrm>
+          <a:prstGeom prst="rect">
             <a:avLst/>
           </a:prstGeom>
           <a:solidFill>
@@ -3283,40 +3326,64 @@
           <a:bodyPr rtlCol="0" anchor="ctr"/>
           <a:lstStyle/>
           <a:p>
+            <a:pPr algn="ctr"/>
+          </a:p>
+        </p:txBody>
+      </p:sp>
+      <p:sp>
+        <p:nvSpPr>
+          <p:cNvPr id="8" name="TextBox 7"/>
+          <p:cNvSpPr txBox="1"/>
+          <p:nvPr/>
+        </p:nvSpPr>
+        <p:spPr>
+          <a:xfrm>
+            <a:off x="685800" y="2907792"/>
+            <a:ext cx="2377440" cy="201168"/>
+          </a:xfrm>
+          <a:prstGeom prst="rect">
+            <a:avLst/>
+          </a:prstGeom>
+          <a:noFill/>
+        </p:spPr>
+        <p:txBody>
+          <a:bodyPr wrap="square" anchor="ctr">
+            <a:spAutoFit/>
+          </a:bodyPr>
+          <a:lstStyle/>
+          <a:p>
             <a:pPr algn="ctr" a:rtl="1"/>
             <a:r>
-              <a:rPr sz="1300" b="1">
+              <a:rPr sz="800" b="0">
                 <a:solidFill>
-                  <a:srgbClr val="FFFFFF"/>
+                  <a:srgbClr val="2B5C8A"/>
                 </a:solidFill>
                 <a:latin typeface="Tahoma"/>
               </a:rPr>
-              <a:t>گردآوری داده</a:t>
-            </a:r>
-          </a:p>
-        </p:txBody>
-      </p:sp>
-      <p:sp>
-        <p:nvSpPr>
-          <p:cNvPr id="7" name="Rounded Rectangle 6"/>
+              <a:t>گردآوری</a:t>
+            </a:r>
+          </a:p>
+        </p:txBody>
+      </p:sp>
+      <p:sp>
+        <p:nvSpPr>
+          <p:cNvPr id="9" name="Rectangle 8"/>
           <p:cNvSpPr/>
           <p:nvPr/>
         </p:nvSpPr>
         <p:spPr>
           <a:xfrm>
-            <a:off x="411480" y="1728216"/>
-            <a:ext cx="2606040" cy="1051560"/>
-          </a:xfrm>
-          <a:prstGeom prst="roundRect">
+            <a:off x="3063240" y="2852928"/>
+            <a:ext cx="2377440" cy="36576"/>
+          </a:xfrm>
+          <a:prstGeom prst="rect">
             <a:avLst/>
           </a:prstGeom>
           <a:solidFill>
-            <a:srgbClr val="FFFFFF"/>
+            <a:srgbClr val="009688"/>
           </a:solidFill>
-          <a:ln w="15240">
-            <a:solidFill>
-              <a:srgbClr val="2B5C8A"/>
-            </a:solidFill>
+          <a:ln>
+            <a:noFill/>
           </a:ln>
         </p:spPr>
         <p:style>
@@ -3343,16 +3410,174 @@
       </p:sp>
       <p:sp>
         <p:nvSpPr>
-          <p:cNvPr id="8" name="Rectangle 7"/>
+          <p:cNvPr id="10" name="TextBox 9"/>
+          <p:cNvSpPr txBox="1"/>
+          <p:nvPr/>
+        </p:nvSpPr>
+        <p:spPr>
+          <a:xfrm>
+            <a:off x="3063240" y="2907792"/>
+            <a:ext cx="2377440" cy="201168"/>
+          </a:xfrm>
+          <a:prstGeom prst="rect">
+            <a:avLst/>
+          </a:prstGeom>
+          <a:noFill/>
+        </p:spPr>
+        <p:txBody>
+          <a:bodyPr wrap="square" anchor="ctr">
+            <a:spAutoFit/>
+          </a:bodyPr>
+          <a:lstStyle/>
+          <a:p>
+            <a:pPr algn="ctr" a:rtl="1"/>
+            <a:r>
+              <a:rPr sz="800" b="0">
+                <a:solidFill>
+                  <a:srgbClr val="009688"/>
+                </a:solidFill>
+                <a:latin typeface="Tahoma"/>
+              </a:rPr>
+              <a:t>کنترل کیفیت</a:t>
+            </a:r>
+          </a:p>
+        </p:txBody>
+      </p:sp>
+      <p:sp>
+        <p:nvSpPr>
+          <p:cNvPr id="11" name="Rectangle 10"/>
           <p:cNvSpPr/>
           <p:nvPr/>
         </p:nvSpPr>
         <p:spPr>
           <a:xfrm>
-            <a:off x="411480" y="1728216"/>
-            <a:ext cx="2606040" cy="54864"/>
+            <a:off x="5440680" y="2852928"/>
+            <a:ext cx="3017520" cy="36576"/>
           </a:xfrm>
           <a:prstGeom prst="rect">
+            <a:avLst/>
+          </a:prstGeom>
+          <a:solidFill>
+            <a:srgbClr val="1E3A5F"/>
+          </a:solidFill>
+          <a:ln>
+            <a:noFill/>
+          </a:ln>
+        </p:spPr>
+        <p:style>
+          <a:lnRef idx="1">
+            <a:schemeClr val="accent1"/>
+          </a:lnRef>
+          <a:fillRef idx="3">
+            <a:schemeClr val="accent1"/>
+          </a:fillRef>
+          <a:effectRef idx="2">
+            <a:schemeClr val="accent1"/>
+          </a:effectRef>
+          <a:fontRef idx="minor">
+            <a:schemeClr val="lt1"/>
+          </a:fontRef>
+        </p:style>
+        <p:txBody>
+          <a:bodyPr rtlCol="0" anchor="ctr"/>
+          <a:lstStyle/>
+          <a:p>
+            <a:pPr algn="ctr"/>
+          </a:p>
+        </p:txBody>
+      </p:sp>
+      <p:sp>
+        <p:nvSpPr>
+          <p:cNvPr id="12" name="TextBox 11"/>
+          <p:cNvSpPr txBox="1"/>
+          <p:nvPr/>
+        </p:nvSpPr>
+        <p:spPr>
+          <a:xfrm>
+            <a:off x="5440680" y="2907792"/>
+            <a:ext cx="3017520" cy="201168"/>
+          </a:xfrm>
+          <a:prstGeom prst="rect">
+            <a:avLst/>
+          </a:prstGeom>
+          <a:noFill/>
+        </p:spPr>
+        <p:txBody>
+          <a:bodyPr wrap="square" anchor="ctr">
+            <a:spAutoFit/>
+          </a:bodyPr>
+          <a:lstStyle/>
+          <a:p>
+            <a:pPr algn="ctr" a:rtl="1"/>
+            <a:r>
+              <a:rPr sz="800" b="0">
+                <a:solidFill>
+                  <a:srgbClr val="1E3A5F"/>
+                </a:solidFill>
+                <a:latin typeface="Tahoma"/>
+              </a:rPr>
+              <a:t>خروجی</a:t>
+            </a:r>
+          </a:p>
+        </p:txBody>
+      </p:sp>
+      <p:sp>
+        <p:nvSpPr>
+          <p:cNvPr id="13" name="Oval 12"/>
+          <p:cNvSpPr/>
+          <p:nvPr/>
+        </p:nvSpPr>
+        <p:spPr>
+          <a:xfrm>
+            <a:off x="8147304" y="2386584"/>
+            <a:ext cx="621792" cy="621792"/>
+          </a:xfrm>
+          <a:prstGeom prst="ellipse">
+            <a:avLst/>
+          </a:prstGeom>
+          <a:solidFill>
+            <a:srgbClr val="E3F2FD"/>
+          </a:solidFill>
+          <a:ln w="22860">
+            <a:solidFill>
+              <a:srgbClr val="2B5C8A"/>
+            </a:solidFill>
+          </a:ln>
+        </p:spPr>
+        <p:style>
+          <a:lnRef idx="1">
+            <a:schemeClr val="accent1"/>
+          </a:lnRef>
+          <a:fillRef idx="3">
+            <a:schemeClr val="accent1"/>
+          </a:fillRef>
+          <a:effectRef idx="2">
+            <a:schemeClr val="accent1"/>
+          </a:effectRef>
+          <a:fontRef idx="minor">
+            <a:schemeClr val="lt1"/>
+          </a:fontRef>
+        </p:style>
+        <p:txBody>
+          <a:bodyPr rtlCol="0" anchor="ctr"/>
+          <a:lstStyle/>
+          <a:p>
+            <a:pPr algn="ctr"/>
+          </a:p>
+        </p:txBody>
+      </p:sp>
+      <p:sp>
+        <p:nvSpPr>
+          <p:cNvPr id="14" name="Oval 13"/>
+          <p:cNvSpPr/>
+          <p:nvPr/>
+        </p:nvSpPr>
+        <p:spPr>
+          <a:xfrm>
+            <a:off x="8202168" y="2441448"/>
+            <a:ext cx="512064" cy="512064"/>
+          </a:xfrm>
+          <a:prstGeom prst="ellipse">
             <a:avLst/>
           </a:prstGeom>
           <a:solidFill>
@@ -3381,25 +3606,34 @@
           <a:lstStyle/>
           <a:p>
             <a:pPr algn="ctr"/>
-          </a:p>
-        </p:txBody>
-      </p:sp>
-      <p:sp>
-        <p:nvSpPr>
-          <p:cNvPr id="9" name="Rounded Rectangle 8"/>
+            <a:r>
+              <a:rPr sz="1400" b="1">
+                <a:solidFill>
+                  <a:srgbClr val="FFFFFF"/>
+                </a:solidFill>
+                <a:latin typeface="Tahoma"/>
+              </a:rPr>
+              <a:t>۱</a:t>
+            </a:r>
+          </a:p>
+        </p:txBody>
+      </p:sp>
+      <p:sp>
+        <p:nvSpPr>
+          <p:cNvPr id="15" name="Rounded Rectangle 14"/>
           <p:cNvSpPr/>
           <p:nvPr/>
         </p:nvSpPr>
         <p:spPr>
           <a:xfrm>
-            <a:off x="539496" y="1892808"/>
-            <a:ext cx="384048" cy="384048"/>
+            <a:off x="7808976" y="1408176"/>
+            <a:ext cx="1298448" cy="868680"/>
           </a:xfrm>
           <a:prstGeom prst="roundRect">
             <a:avLst/>
           </a:prstGeom>
           <a:solidFill>
-            <a:srgbClr val="E3F2FD"/>
+            <a:srgbClr val="FFFFFF"/>
           </a:solidFill>
           <a:ln w="12700">
             <a:solidFill>
@@ -3431,16 +3665,86 @@
       </p:sp>
       <p:sp>
         <p:nvSpPr>
-          <p:cNvPr id="10" name="Action Button: Beginning 9"/>
+          <p:cNvPr id="16" name="TextBox 15"/>
+          <p:cNvSpPr txBox="1"/>
+          <p:nvPr/>
+        </p:nvSpPr>
+        <p:spPr>
+          <a:xfrm>
+            <a:off x="7863840" y="1481328"/>
+            <a:ext cx="1188720" cy="274320"/>
+          </a:xfrm>
+          <a:prstGeom prst="rect">
+            <a:avLst/>
+          </a:prstGeom>
+          <a:noFill/>
+        </p:spPr>
+        <p:txBody>
+          <a:bodyPr wrap="square" anchor="ctr">
+            <a:spAutoFit/>
+          </a:bodyPr>
+          <a:lstStyle/>
+          <a:p>
+            <a:pPr algn="ctr" a:rtl="1"/>
+            <a:r>
+              <a:rPr sz="1000" b="1">
+                <a:solidFill>
+                  <a:srgbClr val="2D343E"/>
+                </a:solidFill>
+                <a:latin typeface="Tahoma"/>
+              </a:rPr>
+              <a:t>گردآوری نظرات خبرگان</a:t>
+            </a:r>
+          </a:p>
+        </p:txBody>
+      </p:sp>
+      <p:sp>
+        <p:nvSpPr>
+          <p:cNvPr id="17" name="TextBox 16"/>
+          <p:cNvSpPr txBox="1"/>
+          <p:nvPr/>
+        </p:nvSpPr>
+        <p:spPr>
+          <a:xfrm>
+            <a:off x="7863840" y="1755648"/>
+            <a:ext cx="1188720" cy="384048"/>
+          </a:xfrm>
+          <a:prstGeom prst="rect">
+            <a:avLst/>
+          </a:prstGeom>
+          <a:noFill/>
+        </p:spPr>
+        <p:txBody>
+          <a:bodyPr wrap="square" anchor="ctr">
+            <a:spAutoFit/>
+          </a:bodyPr>
+          <a:lstStyle/>
+          <a:p>
+            <a:pPr algn="ctr" a:rtl="1"/>
+            <a:r>
+              <a:rPr sz="850" b="0">
+                <a:solidFill>
+                  <a:srgbClr val="6B7280"/>
+                </a:solidFill>
+                <a:latin typeface="Tahoma"/>
+              </a:rPr>
+              <a:t>جمع‌آوری ماتریس‌های مقایسه زوجی</a:t>
+            </a:r>
+          </a:p>
+        </p:txBody>
+      </p:sp>
+      <p:sp>
+        <p:nvSpPr>
+          <p:cNvPr id="18" name="Rectangle 17"/>
           <p:cNvSpPr/>
           <p:nvPr/>
         </p:nvSpPr>
         <p:spPr>
           <a:xfrm>
-            <a:off x="612648" y="1956816"/>
-            <a:ext cx="237744" cy="237744"/>
-          </a:xfrm>
-          <a:prstGeom prst="actionButtonBeginning">
+            <a:off x="8445500" y="2276856"/>
+            <a:ext cx="25400" cy="109728"/>
+          </a:xfrm>
+          <a:prstGeom prst="rect">
             <a:avLst/>
           </a:prstGeom>
           <a:solidFill>
@@ -3474,16 +3778,61 @@
       </p:sp>
       <p:sp>
         <p:nvSpPr>
-          <p:cNvPr id="11" name="Rounded Rectangle 10"/>
+          <p:cNvPr id="19" name="Oval 18"/>
           <p:cNvSpPr/>
           <p:nvPr/>
         </p:nvSpPr>
         <p:spPr>
           <a:xfrm>
-            <a:off x="2578608" y="1856232"/>
-            <a:ext cx="310896" cy="310896"/>
-          </a:xfrm>
-          <a:prstGeom prst="roundRect">
+            <a:off x="6592824" y="2386584"/>
+            <a:ext cx="621792" cy="621792"/>
+          </a:xfrm>
+          <a:prstGeom prst="ellipse">
+            <a:avLst/>
+          </a:prstGeom>
+          <a:solidFill>
+            <a:srgbClr val="E3F2FD"/>
+          </a:solidFill>
+          <a:ln w="22860">
+            <a:solidFill>
+              <a:srgbClr val="2B5C8A"/>
+            </a:solidFill>
+          </a:ln>
+        </p:spPr>
+        <p:style>
+          <a:lnRef idx="1">
+            <a:schemeClr val="accent1"/>
+          </a:lnRef>
+          <a:fillRef idx="3">
+            <a:schemeClr val="accent1"/>
+          </a:fillRef>
+          <a:effectRef idx="2">
+            <a:schemeClr val="accent1"/>
+          </a:effectRef>
+          <a:fontRef idx="minor">
+            <a:schemeClr val="lt1"/>
+          </a:fontRef>
+        </p:style>
+        <p:txBody>
+          <a:bodyPr rtlCol="0" anchor="ctr"/>
+          <a:lstStyle/>
+          <a:p>
+            <a:pPr algn="ctr"/>
+          </a:p>
+        </p:txBody>
+      </p:sp>
+      <p:sp>
+        <p:nvSpPr>
+          <p:cNvPr id="20" name="Oval 19"/>
+          <p:cNvSpPr/>
+          <p:nvPr/>
+        </p:nvSpPr>
+        <p:spPr>
+          <a:xfrm>
+            <a:off x="6647688" y="2441448"/>
+            <a:ext cx="512064" cy="512064"/>
+          </a:xfrm>
+          <a:prstGeom prst="ellipse">
             <a:avLst/>
           </a:prstGeom>
           <a:solidFill>
@@ -3513,27 +3862,72 @@
           <a:p>
             <a:pPr algn="ctr"/>
             <a:r>
-              <a:rPr sz="1300" b="1">
+              <a:rPr sz="1400" b="1">
                 <a:solidFill>
                   <a:srgbClr val="FFFFFF"/>
                 </a:solidFill>
                 <a:latin typeface="Tahoma"/>
               </a:rPr>
-              <a:t>۱</a:t>
-            </a:r>
-          </a:p>
-        </p:txBody>
-      </p:sp>
-      <p:sp>
-        <p:nvSpPr>
-          <p:cNvPr id="12" name="TextBox 11"/>
+              <a:t>۲</a:t>
+            </a:r>
+          </a:p>
+        </p:txBody>
+      </p:sp>
+      <p:sp>
+        <p:nvSpPr>
+          <p:cNvPr id="21" name="Rounded Rectangle 20"/>
+          <p:cNvSpPr/>
+          <p:nvPr/>
+        </p:nvSpPr>
+        <p:spPr>
+          <a:xfrm>
+            <a:off x="6254496" y="3118104"/>
+            <a:ext cx="1298448" cy="868680"/>
+          </a:xfrm>
+          <a:prstGeom prst="roundRect">
+            <a:avLst/>
+          </a:prstGeom>
+          <a:solidFill>
+            <a:srgbClr val="FFFFFF"/>
+          </a:solidFill>
+          <a:ln w="12700">
+            <a:solidFill>
+              <a:srgbClr val="2B5C8A"/>
+            </a:solidFill>
+          </a:ln>
+        </p:spPr>
+        <p:style>
+          <a:lnRef idx="1">
+            <a:schemeClr val="accent1"/>
+          </a:lnRef>
+          <a:fillRef idx="3">
+            <a:schemeClr val="accent1"/>
+          </a:fillRef>
+          <a:effectRef idx="2">
+            <a:schemeClr val="accent1"/>
+          </a:effectRef>
+          <a:fontRef idx="minor">
+            <a:schemeClr val="lt1"/>
+          </a:fontRef>
+        </p:style>
+        <p:txBody>
+          <a:bodyPr rtlCol="0" anchor="ctr"/>
+          <a:lstStyle/>
+          <a:p>
+            <a:pPr algn="ctr"/>
+          </a:p>
+        </p:txBody>
+      </p:sp>
+      <p:sp>
+        <p:nvSpPr>
+          <p:cNvPr id="22" name="TextBox 21"/>
           <p:cNvSpPr txBox="1"/>
           <p:nvPr/>
         </p:nvSpPr>
         <p:spPr>
           <a:xfrm>
-            <a:off x="978408" y="1874520"/>
-            <a:ext cx="1892808" cy="292608"/>
+            <a:off x="6309360" y="3191256"/>
+            <a:ext cx="1188720" cy="274320"/>
           </a:xfrm>
           <a:prstGeom prst="rect">
             <a:avLst/>
@@ -3546,29 +3940,29 @@
           </a:bodyPr>
           <a:lstStyle/>
           <a:p>
-            <a:pPr algn="r" a:rtl="1"/>
-            <a:r>
-              <a:rPr sz="1200" b="1">
+            <a:pPr algn="ctr" a:rtl="1"/>
+            <a:r>
+              <a:rPr sz="1000" b="1">
                 <a:solidFill>
                   <a:srgbClr val="2D343E"/>
                 </a:solidFill>
                 <a:latin typeface="Tahoma"/>
               </a:rPr>
-              <a:t>گردآوری نظرات خبرگان</a:t>
-            </a:r>
-          </a:p>
-        </p:txBody>
-      </p:sp>
-      <p:sp>
-        <p:nvSpPr>
-          <p:cNvPr id="13" name="TextBox 12"/>
+              <a:t>مقایسه‌های زوجی</a:t>
+            </a:r>
+          </a:p>
+        </p:txBody>
+      </p:sp>
+      <p:sp>
+        <p:nvSpPr>
+          <p:cNvPr id="23" name="TextBox 22"/>
           <p:cNvSpPr txBox="1"/>
           <p:nvPr/>
         </p:nvSpPr>
         <p:spPr>
           <a:xfrm>
-            <a:off x="978408" y="2185416"/>
-            <a:ext cx="1892808" cy="502920"/>
+            <a:off x="6309360" y="3465576"/>
+            <a:ext cx="1188720" cy="384048"/>
           </a:xfrm>
           <a:prstGeom prst="rect">
             <a:avLst/>
@@ -3581,74 +3975,29 @@
           </a:bodyPr>
           <a:lstStyle/>
           <a:p>
-            <a:pPr algn="r" a:rtl="1"/>
-            <a:r>
-              <a:rPr sz="950" b="0">
+            <a:pPr algn="ctr" a:rtl="1"/>
+            <a:r>
+              <a:rPr sz="850" b="0">
                 <a:solidFill>
                   <a:srgbClr val="6B7280"/>
                 </a:solidFill>
                 <a:latin typeface="Tahoma"/>
               </a:rPr>
-              <a:t>جمع‌آوری ماتریس‌های مقایسه زوجی از خبرگان</a:t>
-            </a:r>
-          </a:p>
-        </p:txBody>
-      </p:sp>
-      <p:sp>
-        <p:nvSpPr>
-          <p:cNvPr id="14" name="Rounded Rectangle 13"/>
+              <a:t>با مقیاس ساعتی AHP (۱ تا ۹)</a:t>
+            </a:r>
+          </a:p>
+        </p:txBody>
+      </p:sp>
+      <p:sp>
+        <p:nvSpPr>
+          <p:cNvPr id="24" name="Rectangle 23"/>
           <p:cNvSpPr/>
           <p:nvPr/>
         </p:nvSpPr>
         <p:spPr>
           <a:xfrm>
-            <a:off x="411480" y="2944368"/>
-            <a:ext cx="2606040" cy="1051560"/>
-          </a:xfrm>
-          <a:prstGeom prst="roundRect">
-            <a:avLst/>
-          </a:prstGeom>
-          <a:solidFill>
-            <a:srgbClr val="FFFFFF"/>
-          </a:solidFill>
-          <a:ln w="15240">
-            <a:solidFill>
-              <a:srgbClr val="2B5C8A"/>
-            </a:solidFill>
-          </a:ln>
-        </p:spPr>
-        <p:style>
-          <a:lnRef idx="1">
-            <a:schemeClr val="accent1"/>
-          </a:lnRef>
-          <a:fillRef idx="3">
-            <a:schemeClr val="accent1"/>
-          </a:fillRef>
-          <a:effectRef idx="2">
-            <a:schemeClr val="accent1"/>
-          </a:effectRef>
-          <a:fontRef idx="minor">
-            <a:schemeClr val="lt1"/>
-          </a:fontRef>
-        </p:style>
-        <p:txBody>
-          <a:bodyPr rtlCol="0" anchor="ctr"/>
-          <a:lstStyle/>
-          <a:p>
-            <a:pPr algn="ctr"/>
-          </a:p>
-        </p:txBody>
-      </p:sp>
-      <p:sp>
-        <p:nvSpPr>
-          <p:cNvPr id="15" name="Rectangle 14"/>
-          <p:cNvSpPr/>
-          <p:nvPr/>
-        </p:nvSpPr>
-        <p:spPr>
-          <a:xfrm>
-            <a:off x="411480" y="2944368"/>
-            <a:ext cx="2606040" cy="54864"/>
+            <a:off x="6891020" y="3008376"/>
+            <a:ext cx="25400" cy="109728"/>
           </a:xfrm>
           <a:prstGeom prst="rect">
             <a:avLst/>
@@ -3684,24 +4033,24 @@
       </p:sp>
       <p:sp>
         <p:nvSpPr>
-          <p:cNvPr id="16" name="Rounded Rectangle 15"/>
+          <p:cNvPr id="25" name="Oval 24"/>
           <p:cNvSpPr/>
           <p:nvPr/>
         </p:nvSpPr>
         <p:spPr>
           <a:xfrm>
-            <a:off x="539496" y="3108960"/>
-            <a:ext cx="384048" cy="384048"/>
-          </a:xfrm>
-          <a:prstGeom prst="roundRect">
+            <a:off x="5038344" y="2386584"/>
+            <a:ext cx="621792" cy="621792"/>
+          </a:xfrm>
+          <a:prstGeom prst="ellipse">
             <a:avLst/>
           </a:prstGeom>
           <a:solidFill>
-            <a:srgbClr val="E3F2FD"/>
+            <a:srgbClr val="E0F2F1"/>
           </a:solidFill>
-          <a:ln w="12700">
+          <a:ln w="22860">
             <a:solidFill>
-              <a:srgbClr val="2B5C8A"/>
+              <a:srgbClr val="009688"/>
             </a:solidFill>
           </a:ln>
         </p:spPr>
@@ -3729,181 +4078,16 @@
       </p:sp>
       <p:sp>
         <p:nvSpPr>
-          <p:cNvPr id="17" name="Action Button: Back or Previous 16"/>
+          <p:cNvPr id="26" name="Oval 25"/>
           <p:cNvSpPr/>
           <p:nvPr/>
         </p:nvSpPr>
         <p:spPr>
           <a:xfrm>
-            <a:off x="612648" y="3172968"/>
-            <a:ext cx="237744" cy="237744"/>
-          </a:xfrm>
-          <a:prstGeom prst="actionButtonBackPrevious">
-            <a:avLst/>
-          </a:prstGeom>
-          <a:solidFill>
-            <a:srgbClr val="2B5C8A"/>
-          </a:solidFill>
-          <a:ln>
-            <a:noFill/>
-          </a:ln>
-        </p:spPr>
-        <p:style>
-          <a:lnRef idx="1">
-            <a:schemeClr val="accent1"/>
-          </a:lnRef>
-          <a:fillRef idx="3">
-            <a:schemeClr val="accent1"/>
-          </a:fillRef>
-          <a:effectRef idx="2">
-            <a:schemeClr val="accent1"/>
-          </a:effectRef>
-          <a:fontRef idx="minor">
-            <a:schemeClr val="lt1"/>
-          </a:fontRef>
-        </p:style>
-        <p:txBody>
-          <a:bodyPr rtlCol="0" anchor="ctr"/>
-          <a:lstStyle/>
-          <a:p>
-            <a:pPr algn="ctr"/>
-          </a:p>
-        </p:txBody>
-      </p:sp>
-      <p:sp>
-        <p:nvSpPr>
-          <p:cNvPr id="18" name="Rounded Rectangle 17"/>
-          <p:cNvSpPr/>
-          <p:nvPr/>
-        </p:nvSpPr>
-        <p:spPr>
-          <a:xfrm>
-            <a:off x="2578608" y="3072384"/>
-            <a:ext cx="310896" cy="310896"/>
-          </a:xfrm>
-          <a:prstGeom prst="roundRect">
-            <a:avLst/>
-          </a:prstGeom>
-          <a:solidFill>
-            <a:srgbClr val="2B5C8A"/>
-          </a:solidFill>
-          <a:ln>
-            <a:noFill/>
-          </a:ln>
-        </p:spPr>
-        <p:style>
-          <a:lnRef idx="1">
-            <a:schemeClr val="accent1"/>
-          </a:lnRef>
-          <a:fillRef idx="3">
-            <a:schemeClr val="accent1"/>
-          </a:fillRef>
-          <a:effectRef idx="2">
-            <a:schemeClr val="accent1"/>
-          </a:effectRef>
-          <a:fontRef idx="minor">
-            <a:schemeClr val="lt1"/>
-          </a:fontRef>
-        </p:style>
-        <p:txBody>
-          <a:bodyPr rtlCol="0" anchor="ctr"/>
-          <a:lstStyle/>
-          <a:p>
-            <a:pPr algn="ctr"/>
-            <a:r>
-              <a:rPr sz="1300" b="1">
-                <a:solidFill>
-                  <a:srgbClr val="FFFFFF"/>
-                </a:solidFill>
-                <a:latin typeface="Tahoma"/>
-              </a:rPr>
-              <a:t>۲</a:t>
-            </a:r>
-          </a:p>
-        </p:txBody>
-      </p:sp>
-      <p:sp>
-        <p:nvSpPr>
-          <p:cNvPr id="19" name="TextBox 18"/>
-          <p:cNvSpPr txBox="1"/>
-          <p:nvPr/>
-        </p:nvSpPr>
-        <p:spPr>
-          <a:xfrm>
-            <a:off x="978408" y="3090672"/>
-            <a:ext cx="1892808" cy="292608"/>
-          </a:xfrm>
-          <a:prstGeom prst="rect">
-            <a:avLst/>
-          </a:prstGeom>
-          <a:noFill/>
-        </p:spPr>
-        <p:txBody>
-          <a:bodyPr wrap="square" anchor="ctr">
-            <a:spAutoFit/>
-          </a:bodyPr>
-          <a:lstStyle/>
-          <a:p>
-            <a:pPr algn="r" a:rtl="1"/>
-            <a:r>
-              <a:rPr sz="1200" b="1">
-                <a:solidFill>
-                  <a:srgbClr val="2D343E"/>
-                </a:solidFill>
-                <a:latin typeface="Tahoma"/>
-              </a:rPr>
-              <a:t>مقایسه‌های زوجی معیارها</a:t>
-            </a:r>
-          </a:p>
-        </p:txBody>
-      </p:sp>
-      <p:sp>
-        <p:nvSpPr>
-          <p:cNvPr id="20" name="TextBox 19"/>
-          <p:cNvSpPr txBox="1"/>
-          <p:nvPr/>
-        </p:nvSpPr>
-        <p:spPr>
-          <a:xfrm>
-            <a:off x="978408" y="3401568"/>
-            <a:ext cx="1892808" cy="502920"/>
-          </a:xfrm>
-          <a:prstGeom prst="rect">
-            <a:avLst/>
-          </a:prstGeom>
-          <a:noFill/>
-        </p:spPr>
-        <p:txBody>
-          <a:bodyPr wrap="square" anchor="ctr">
-            <a:spAutoFit/>
-          </a:bodyPr>
-          <a:lstStyle/>
-          <a:p>
-            <a:pPr algn="r" a:rtl="1"/>
-            <a:r>
-              <a:rPr sz="950" b="0">
-                <a:solidFill>
-                  <a:srgbClr val="6B7280"/>
-                </a:solidFill>
-                <a:latin typeface="Tahoma"/>
-              </a:rPr>
-              <a:t>انجام با مقیاس ساعتی AHP (۱ تا ۹)</a:t>
-            </a:r>
-          </a:p>
-        </p:txBody>
-      </p:sp>
-      <p:sp>
-        <p:nvSpPr>
-          <p:cNvPr id="21" name="Rounded Rectangle 20"/>
-          <p:cNvSpPr/>
-          <p:nvPr/>
-        </p:nvSpPr>
-        <p:spPr>
-          <a:xfrm>
-            <a:off x="3218688" y="1234440"/>
-            <a:ext cx="2606040" cy="384048"/>
-          </a:xfrm>
-          <a:prstGeom prst="roundRect">
+            <a:off x="5093208" y="2441448"/>
+            <a:ext cx="512064" cy="512064"/>
+          </a:xfrm>
+          <a:prstGeom prst="ellipse">
             <a:avLst/>
           </a:prstGeom>
           <a:solidFill>
@@ -3931,29 +4115,29 @@
           <a:bodyPr rtlCol="0" anchor="ctr"/>
           <a:lstStyle/>
           <a:p>
-            <a:pPr algn="ctr" a:rtl="1"/>
-            <a:r>
-              <a:rPr sz="1300" b="1">
+            <a:pPr algn="ctr"/>
+            <a:r>
+              <a:rPr sz="1400" b="1">
                 <a:solidFill>
                   <a:srgbClr val="FFFFFF"/>
                 </a:solidFill>
                 <a:latin typeface="Tahoma"/>
               </a:rPr>
-              <a:t>کنترل کیفیت</a:t>
-            </a:r>
-          </a:p>
-        </p:txBody>
-      </p:sp>
-      <p:sp>
-        <p:nvSpPr>
-          <p:cNvPr id="22" name="Rounded Rectangle 21"/>
+              <a:t>۳</a:t>
+            </a:r>
+          </a:p>
+        </p:txBody>
+      </p:sp>
+      <p:sp>
+        <p:nvSpPr>
+          <p:cNvPr id="27" name="Rounded Rectangle 26"/>
           <p:cNvSpPr/>
           <p:nvPr/>
         </p:nvSpPr>
         <p:spPr>
           <a:xfrm>
-            <a:off x="3218688" y="1728216"/>
-            <a:ext cx="2606040" cy="1051560"/>
+            <a:off x="4700016" y="1408176"/>
+            <a:ext cx="1298448" cy="868680"/>
           </a:xfrm>
           <a:prstGeom prst="roundRect">
             <a:avLst/>
@@ -3961,7 +4145,7 @@
           <a:solidFill>
             <a:srgbClr val="FFFFFF"/>
           </a:solidFill>
-          <a:ln w="15240">
+          <a:ln w="12700">
             <a:solidFill>
               <a:srgbClr val="009688"/>
             </a:solidFill>
@@ -3991,14 +4175,84 @@
       </p:sp>
       <p:sp>
         <p:nvSpPr>
-          <p:cNvPr id="23" name="Rectangle 22"/>
+          <p:cNvPr id="28" name="TextBox 27"/>
+          <p:cNvSpPr txBox="1"/>
+          <p:nvPr/>
+        </p:nvSpPr>
+        <p:spPr>
+          <a:xfrm>
+            <a:off x="4754880" y="1481328"/>
+            <a:ext cx="1188720" cy="274320"/>
+          </a:xfrm>
+          <a:prstGeom prst="rect">
+            <a:avLst/>
+          </a:prstGeom>
+          <a:noFill/>
+        </p:spPr>
+        <p:txBody>
+          <a:bodyPr wrap="square" anchor="ctr">
+            <a:spAutoFit/>
+          </a:bodyPr>
+          <a:lstStyle/>
+          <a:p>
+            <a:pPr algn="ctr" a:rtl="1"/>
+            <a:r>
+              <a:rPr sz="1000" b="1">
+                <a:solidFill>
+                  <a:srgbClr val="2D343E"/>
+                </a:solidFill>
+                <a:latin typeface="Tahoma"/>
+              </a:rPr>
+              <a:t>بررسی سازگاری</a:t>
+            </a:r>
+          </a:p>
+        </p:txBody>
+      </p:sp>
+      <p:sp>
+        <p:nvSpPr>
+          <p:cNvPr id="29" name="TextBox 28"/>
+          <p:cNvSpPr txBox="1"/>
+          <p:nvPr/>
+        </p:nvSpPr>
+        <p:spPr>
+          <a:xfrm>
+            <a:off x="4754880" y="1755648"/>
+            <a:ext cx="1188720" cy="384048"/>
+          </a:xfrm>
+          <a:prstGeom prst="rect">
+            <a:avLst/>
+          </a:prstGeom>
+          <a:noFill/>
+        </p:spPr>
+        <p:txBody>
+          <a:bodyPr wrap="square" anchor="ctr">
+            <a:spAutoFit/>
+          </a:bodyPr>
+          <a:lstStyle/>
+          <a:p>
+            <a:pPr algn="ctr" a:rtl="1"/>
+            <a:r>
+              <a:rPr sz="850" b="0">
+                <a:solidFill>
+                  <a:srgbClr val="6B7280"/>
+                </a:solidFill>
+                <a:latin typeface="Tahoma"/>
+              </a:rPr>
+              <a:t>محاسبه CR برای هر خبره</a:t>
+            </a:r>
+          </a:p>
+        </p:txBody>
+      </p:sp>
+      <p:sp>
+        <p:nvSpPr>
+          <p:cNvPr id="30" name="Rectangle 29"/>
           <p:cNvSpPr/>
           <p:nvPr/>
         </p:nvSpPr>
         <p:spPr>
           <a:xfrm>
-            <a:off x="3218688" y="1728216"/>
-            <a:ext cx="2606040" cy="54864"/>
+            <a:off x="5336540" y="2276856"/>
+            <a:ext cx="25400" cy="109728"/>
           </a:xfrm>
           <a:prstGeom prst="rect">
             <a:avLst/>
@@ -4034,24 +4288,24 @@
       </p:sp>
       <p:sp>
         <p:nvSpPr>
-          <p:cNvPr id="24" name="Rounded Rectangle 23"/>
+          <p:cNvPr id="31" name="Oval 30"/>
           <p:cNvSpPr/>
           <p:nvPr/>
         </p:nvSpPr>
         <p:spPr>
           <a:xfrm>
-            <a:off x="3346704" y="1892808"/>
-            <a:ext cx="384048" cy="384048"/>
-          </a:xfrm>
-          <a:prstGeom prst="roundRect">
+            <a:off x="3483864" y="2386584"/>
+            <a:ext cx="621792" cy="621792"/>
+          </a:xfrm>
+          <a:prstGeom prst="ellipse">
             <a:avLst/>
           </a:prstGeom>
           <a:solidFill>
-            <a:srgbClr val="E0F2F1"/>
+            <a:srgbClr val="E8F5E9"/>
           </a:solidFill>
-          <a:ln w="12700">
+          <a:ln w="22860">
             <a:solidFill>
-              <a:srgbClr val="009688"/>
+              <a:srgbClr val="2E7D32"/>
             </a:solidFill>
           </a:ln>
         </p:spPr>
@@ -4079,20 +4333,20 @@
       </p:sp>
       <p:sp>
         <p:nvSpPr>
-          <p:cNvPr id="25" name="Action Button: Document 24"/>
+          <p:cNvPr id="32" name="Oval 31"/>
           <p:cNvSpPr/>
           <p:nvPr/>
         </p:nvSpPr>
         <p:spPr>
           <a:xfrm>
-            <a:off x="3419856" y="1956816"/>
-            <a:ext cx="237744" cy="237744"/>
-          </a:xfrm>
-          <a:prstGeom prst="actionButtonDocument">
+            <a:off x="3538728" y="2441448"/>
+            <a:ext cx="512064" cy="512064"/>
+          </a:xfrm>
+          <a:prstGeom prst="ellipse">
             <a:avLst/>
           </a:prstGeom>
           <a:solidFill>
-            <a:srgbClr val="009688"/>
+            <a:srgbClr val="2E7D32"/>
           </a:solidFill>
           <a:ln>
             <a:noFill/>
@@ -4117,349 +4371,8 @@
           <a:lstStyle/>
           <a:p>
             <a:pPr algn="ctr"/>
-          </a:p>
-        </p:txBody>
-      </p:sp>
-      <p:sp>
-        <p:nvSpPr>
-          <p:cNvPr id="26" name="Rounded Rectangle 25"/>
-          <p:cNvSpPr/>
-          <p:nvPr/>
-        </p:nvSpPr>
-        <p:spPr>
-          <a:xfrm>
-            <a:off x="5385816" y="1856232"/>
-            <a:ext cx="310896" cy="310896"/>
-          </a:xfrm>
-          <a:prstGeom prst="roundRect">
-            <a:avLst/>
-          </a:prstGeom>
-          <a:solidFill>
-            <a:srgbClr val="009688"/>
-          </a:solidFill>
-          <a:ln>
-            <a:noFill/>
-          </a:ln>
-        </p:spPr>
-        <p:style>
-          <a:lnRef idx="1">
-            <a:schemeClr val="accent1"/>
-          </a:lnRef>
-          <a:fillRef idx="3">
-            <a:schemeClr val="accent1"/>
-          </a:fillRef>
-          <a:effectRef idx="2">
-            <a:schemeClr val="accent1"/>
-          </a:effectRef>
-          <a:fontRef idx="minor">
-            <a:schemeClr val="lt1"/>
-          </a:fontRef>
-        </p:style>
-        <p:txBody>
-          <a:bodyPr rtlCol="0" anchor="ctr"/>
-          <a:lstStyle/>
-          <a:p>
-            <a:pPr algn="ctr"/>
-            <a:r>
-              <a:rPr sz="1300" b="1">
-                <a:solidFill>
-                  <a:srgbClr val="FFFFFF"/>
-                </a:solidFill>
-                <a:latin typeface="Tahoma"/>
-              </a:rPr>
-              <a:t>۳</a:t>
-            </a:r>
-          </a:p>
-        </p:txBody>
-      </p:sp>
-      <p:sp>
-        <p:nvSpPr>
-          <p:cNvPr id="27" name="TextBox 26"/>
-          <p:cNvSpPr txBox="1"/>
-          <p:nvPr/>
-        </p:nvSpPr>
-        <p:spPr>
-          <a:xfrm>
-            <a:off x="3785616" y="1874520"/>
-            <a:ext cx="1892808" cy="292608"/>
-          </a:xfrm>
-          <a:prstGeom prst="rect">
-            <a:avLst/>
-          </a:prstGeom>
-          <a:noFill/>
-        </p:spPr>
-        <p:txBody>
-          <a:bodyPr wrap="square" anchor="ctr">
-            <a:spAutoFit/>
-          </a:bodyPr>
-          <a:lstStyle/>
-          <a:p>
-            <a:pPr algn="r" a:rtl="1"/>
-            <a:r>
-              <a:rPr sz="1200" b="1">
-                <a:solidFill>
-                  <a:srgbClr val="2D343E"/>
-                </a:solidFill>
-                <a:latin typeface="Tahoma"/>
-              </a:rPr>
-              <a:t>بررسی سازگاری هر خبره</a:t>
-            </a:r>
-          </a:p>
-        </p:txBody>
-      </p:sp>
-      <p:sp>
-        <p:nvSpPr>
-          <p:cNvPr id="28" name="TextBox 27"/>
-          <p:cNvSpPr txBox="1"/>
-          <p:nvPr/>
-        </p:nvSpPr>
-        <p:spPr>
-          <a:xfrm>
-            <a:off x="3785616" y="2185416"/>
-            <a:ext cx="1892808" cy="502920"/>
-          </a:xfrm>
-          <a:prstGeom prst="rect">
-            <a:avLst/>
-          </a:prstGeom>
-          <a:noFill/>
-        </p:spPr>
-        <p:txBody>
-          <a:bodyPr wrap="square" anchor="ctr">
-            <a:spAutoFit/>
-          </a:bodyPr>
-          <a:lstStyle/>
-          <a:p>
-            <a:pPr algn="r" a:rtl="1"/>
-            <a:r>
-              <a:rPr sz="950" b="0">
-                <a:solidFill>
-                  <a:srgbClr val="6B7280"/>
-                </a:solidFill>
-                <a:latin typeface="Tahoma"/>
-              </a:rPr>
-              <a:t>محاسبه CR برای ماتریس هر خبره به‌صورت جداگانه</a:t>
-            </a:r>
-          </a:p>
-        </p:txBody>
-      </p:sp>
-      <p:sp>
-        <p:nvSpPr>
-          <p:cNvPr id="29" name="Rounded Rectangle 28"/>
-          <p:cNvSpPr/>
-          <p:nvPr/>
-        </p:nvSpPr>
-        <p:spPr>
-          <a:xfrm>
-            <a:off x="3218688" y="2944368"/>
-            <a:ext cx="2606040" cy="1051560"/>
-          </a:xfrm>
-          <a:prstGeom prst="roundRect">
-            <a:avLst/>
-          </a:prstGeom>
-          <a:solidFill>
-            <a:srgbClr val="FFFFFF"/>
-          </a:solidFill>
-          <a:ln w="15240">
-            <a:solidFill>
-              <a:srgbClr val="009688"/>
-            </a:solidFill>
-          </a:ln>
-        </p:spPr>
-        <p:style>
-          <a:lnRef idx="1">
-            <a:schemeClr val="accent1"/>
-          </a:lnRef>
-          <a:fillRef idx="3">
-            <a:schemeClr val="accent1"/>
-          </a:fillRef>
-          <a:effectRef idx="2">
-            <a:schemeClr val="accent1"/>
-          </a:effectRef>
-          <a:fontRef idx="minor">
-            <a:schemeClr val="lt1"/>
-          </a:fontRef>
-        </p:style>
-        <p:txBody>
-          <a:bodyPr rtlCol="0" anchor="ctr"/>
-          <a:lstStyle/>
-          <a:p>
-            <a:pPr algn="ctr"/>
-          </a:p>
-        </p:txBody>
-      </p:sp>
-      <p:sp>
-        <p:nvSpPr>
-          <p:cNvPr id="30" name="Rectangle 29"/>
-          <p:cNvSpPr/>
-          <p:nvPr/>
-        </p:nvSpPr>
-        <p:spPr>
-          <a:xfrm>
-            <a:off x="3218688" y="2944368"/>
-            <a:ext cx="2606040" cy="54864"/>
-          </a:xfrm>
-          <a:prstGeom prst="rect">
-            <a:avLst/>
-          </a:prstGeom>
-          <a:solidFill>
-            <a:srgbClr val="009688"/>
-          </a:solidFill>
-          <a:ln>
-            <a:noFill/>
-          </a:ln>
-        </p:spPr>
-        <p:style>
-          <a:lnRef idx="1">
-            <a:schemeClr val="accent1"/>
-          </a:lnRef>
-          <a:fillRef idx="3">
-            <a:schemeClr val="accent1"/>
-          </a:fillRef>
-          <a:effectRef idx="2">
-            <a:schemeClr val="accent1"/>
-          </a:effectRef>
-          <a:fontRef idx="minor">
-            <a:schemeClr val="lt1"/>
-          </a:fontRef>
-        </p:style>
-        <p:txBody>
-          <a:bodyPr rtlCol="0" anchor="ctr"/>
-          <a:lstStyle/>
-          <a:p>
-            <a:pPr algn="ctr"/>
-          </a:p>
-        </p:txBody>
-      </p:sp>
-      <p:sp>
-        <p:nvSpPr>
-          <p:cNvPr id="31" name="Rounded Rectangle 30"/>
-          <p:cNvSpPr/>
-          <p:nvPr/>
-        </p:nvSpPr>
-        <p:spPr>
-          <a:xfrm>
-            <a:off x="3346704" y="3108960"/>
-            <a:ext cx="384048" cy="384048"/>
-          </a:xfrm>
-          <a:prstGeom prst="roundRect">
-            <a:avLst/>
-          </a:prstGeom>
-          <a:solidFill>
-            <a:srgbClr val="E0F2F1"/>
-          </a:solidFill>
-          <a:ln w="12700">
-            <a:solidFill>
-              <a:srgbClr val="009688"/>
-            </a:solidFill>
-          </a:ln>
-        </p:spPr>
-        <p:style>
-          <a:lnRef idx="1">
-            <a:schemeClr val="accent1"/>
-          </a:lnRef>
-          <a:fillRef idx="3">
-            <a:schemeClr val="accent1"/>
-          </a:fillRef>
-          <a:effectRef idx="2">
-            <a:schemeClr val="accent1"/>
-          </a:effectRef>
-          <a:fontRef idx="minor">
-            <a:schemeClr val="lt1"/>
-          </a:fontRef>
-        </p:style>
-        <p:txBody>
-          <a:bodyPr rtlCol="0" anchor="ctr"/>
-          <a:lstStyle/>
-          <a:p>
-            <a:pPr algn="ctr"/>
-          </a:p>
-        </p:txBody>
-      </p:sp>
-      <p:sp>
-        <p:nvSpPr>
-          <p:cNvPr id="32" name="Action Button: End 31"/>
-          <p:cNvSpPr/>
-          <p:nvPr/>
-        </p:nvSpPr>
-        <p:spPr>
-          <a:xfrm>
-            <a:off x="3419856" y="3172968"/>
-            <a:ext cx="237744" cy="237744"/>
-          </a:xfrm>
-          <a:prstGeom prst="actionButtonEnd">
-            <a:avLst/>
-          </a:prstGeom>
-          <a:solidFill>
-            <a:srgbClr val="009688"/>
-          </a:solidFill>
-          <a:ln>
-            <a:noFill/>
-          </a:ln>
-        </p:spPr>
-        <p:style>
-          <a:lnRef idx="1">
-            <a:schemeClr val="accent1"/>
-          </a:lnRef>
-          <a:fillRef idx="3">
-            <a:schemeClr val="accent1"/>
-          </a:fillRef>
-          <a:effectRef idx="2">
-            <a:schemeClr val="accent1"/>
-          </a:effectRef>
-          <a:fontRef idx="minor">
-            <a:schemeClr val="lt1"/>
-          </a:fontRef>
-        </p:style>
-        <p:txBody>
-          <a:bodyPr rtlCol="0" anchor="ctr"/>
-          <a:lstStyle/>
-          <a:p>
-            <a:pPr algn="ctr"/>
-          </a:p>
-        </p:txBody>
-      </p:sp>
-      <p:sp>
-        <p:nvSpPr>
-          <p:cNvPr id="33" name="Rounded Rectangle 32"/>
-          <p:cNvSpPr/>
-          <p:nvPr/>
-        </p:nvSpPr>
-        <p:spPr>
-          <a:xfrm>
-            <a:off x="5385816" y="3072384"/>
-            <a:ext cx="310896" cy="310896"/>
-          </a:xfrm>
-          <a:prstGeom prst="roundRect">
-            <a:avLst/>
-          </a:prstGeom>
-          <a:solidFill>
-            <a:srgbClr val="009688"/>
-          </a:solidFill>
-          <a:ln>
-            <a:noFill/>
-          </a:ln>
-        </p:spPr>
-        <p:style>
-          <a:lnRef idx="1">
-            <a:schemeClr val="accent1"/>
-          </a:lnRef>
-          <a:fillRef idx="3">
-            <a:schemeClr val="accent1"/>
-          </a:fillRef>
-          <a:effectRef idx="2">
-            <a:schemeClr val="accent1"/>
-          </a:effectRef>
-          <a:fontRef idx="minor">
-            <a:schemeClr val="lt1"/>
-          </a:fontRef>
-        </p:style>
-        <p:txBody>
-          <a:bodyPr rtlCol="0" anchor="ctr"/>
-          <a:lstStyle/>
-          <a:p>
-            <a:pPr algn="ctr"/>
-            <a:r>
-              <a:rPr sz="1300" b="1">
+            <a:r>
+              <a:rPr sz="1400" b="1">
                 <a:solidFill>
                   <a:srgbClr val="FFFFFF"/>
                 </a:solidFill>
@@ -4472,14 +4385,59 @@
       </p:sp>
       <p:sp>
         <p:nvSpPr>
+          <p:cNvPr id="33" name="Rounded Rectangle 32"/>
+          <p:cNvSpPr/>
+          <p:nvPr/>
+        </p:nvSpPr>
+        <p:spPr>
+          <a:xfrm>
+            <a:off x="3145536" y="3118104"/>
+            <a:ext cx="1298448" cy="868680"/>
+          </a:xfrm>
+          <a:prstGeom prst="roundRect">
+            <a:avLst/>
+          </a:prstGeom>
+          <a:solidFill>
+            <a:srgbClr val="FFFFFF"/>
+          </a:solidFill>
+          <a:ln w="12700">
+            <a:solidFill>
+              <a:srgbClr val="2E7D32"/>
+            </a:solidFill>
+          </a:ln>
+        </p:spPr>
+        <p:style>
+          <a:lnRef idx="1">
+            <a:schemeClr val="accent1"/>
+          </a:lnRef>
+          <a:fillRef idx="3">
+            <a:schemeClr val="accent1"/>
+          </a:fillRef>
+          <a:effectRef idx="2">
+            <a:schemeClr val="accent1"/>
+          </a:effectRef>
+          <a:fontRef idx="minor">
+            <a:schemeClr val="lt1"/>
+          </a:fontRef>
+        </p:style>
+        <p:txBody>
+          <a:bodyPr rtlCol="0" anchor="ctr"/>
+          <a:lstStyle/>
+          <a:p>
+            <a:pPr algn="ctr"/>
+          </a:p>
+        </p:txBody>
+      </p:sp>
+      <p:sp>
+        <p:nvSpPr>
           <p:cNvPr id="34" name="TextBox 33"/>
           <p:cNvSpPr txBox="1"/>
           <p:nvPr/>
         </p:nvSpPr>
         <p:spPr>
           <a:xfrm>
-            <a:off x="3785616" y="3090672"/>
-            <a:ext cx="1892808" cy="292608"/>
+            <a:off x="3200400" y="3191256"/>
+            <a:ext cx="1188720" cy="274320"/>
           </a:xfrm>
           <a:prstGeom prst="rect">
             <a:avLst/>
@@ -4492,15 +4450,15 @@
           </a:bodyPr>
           <a:lstStyle/>
           <a:p>
-            <a:pPr algn="r" a:rtl="1"/>
-            <a:r>
-              <a:rPr sz="1200" b="1">
+            <a:pPr algn="ctr" a:rtl="1"/>
+            <a:r>
+              <a:rPr sz="1000" b="1">
                 <a:solidFill>
                   <a:srgbClr val="2D343E"/>
                 </a:solidFill>
                 <a:latin typeface="Tahoma"/>
               </a:rPr>
-              <a:t>پذیرش ماتریس‌های سازگار</a:t>
+              <a:t>پذیرش ماتریس‌ها</a:t>
             </a:r>
           </a:p>
         </p:txBody>
@@ -4513,8 +4471,8 @@
         </p:nvSpPr>
         <p:spPr>
           <a:xfrm>
-            <a:off x="3785616" y="3401568"/>
-            <a:ext cx="1892808" cy="502920"/>
+            <a:off x="3200400" y="3465576"/>
+            <a:ext cx="1188720" cy="384048"/>
           </a:xfrm>
           <a:prstGeom prst="rect">
             <a:avLst/>
@@ -4527,15 +4485,15 @@
           </a:bodyPr>
           <a:lstStyle/>
           <a:p>
-            <a:pPr algn="r" a:rtl="1"/>
-            <a:r>
-              <a:rPr sz="950" b="0">
+            <a:pPr algn="ctr" a:rtl="1"/>
+            <a:r>
+              <a:rPr sz="850" b="0">
                 <a:solidFill>
                   <a:srgbClr val="6B7280"/>
                 </a:solidFill>
                 <a:latin typeface="Tahoma"/>
               </a:rPr>
-              <a:t>فقط ماتریس‌هایی با نسبت سازگاری کمتر از ۰٫۱ پذیرفته می‌شوند</a:t>
+              <a:t>فقط CR &lt; ۰٫۱ پذیرفته می‌شود</a:t>
             </a:r>
           </a:p>
         </p:txBody>
@@ -4548,8 +4506,8 @@
         </p:nvSpPr>
         <p:spPr>
           <a:xfrm>
-            <a:off x="3346704" y="3685032"/>
-            <a:ext cx="960120" cy="219456"/>
+            <a:off x="3328416" y="3785616"/>
+            <a:ext cx="914400" cy="164592"/>
           </a:xfrm>
           <a:prstGeom prst="roundRect">
             <a:avLst/>
@@ -4583,7 +4541,7 @@
           <a:p>
             <a:pPr algn="ctr"/>
             <a:r>
-              <a:rPr sz="900" b="1">
+              <a:rPr sz="750" b="1">
                 <a:solidFill>
                   <a:srgbClr val="1B5E20"/>
                 </a:solidFill>
@@ -4596,16 +4554,359 @@
       </p:sp>
       <p:sp>
         <p:nvSpPr>
-          <p:cNvPr id="37" name="Rounded Rectangle 36"/>
+          <p:cNvPr id="37" name="Rectangle 36"/>
           <p:cNvSpPr/>
           <p:nvPr/>
         </p:nvSpPr>
         <p:spPr>
           <a:xfrm>
-            <a:off x="6025896" y="1234440"/>
-            <a:ext cx="2606040" cy="384048"/>
+            <a:off x="3782060" y="3008376"/>
+            <a:ext cx="25400" cy="109728"/>
+          </a:xfrm>
+          <a:prstGeom prst="rect">
+            <a:avLst/>
+          </a:prstGeom>
+          <a:solidFill>
+            <a:srgbClr val="2E7D32"/>
+          </a:solidFill>
+          <a:ln>
+            <a:noFill/>
+          </a:ln>
+        </p:spPr>
+        <p:style>
+          <a:lnRef idx="1">
+            <a:schemeClr val="accent1"/>
+          </a:lnRef>
+          <a:fillRef idx="3">
+            <a:schemeClr val="accent1"/>
+          </a:fillRef>
+          <a:effectRef idx="2">
+            <a:schemeClr val="accent1"/>
+          </a:effectRef>
+          <a:fontRef idx="minor">
+            <a:schemeClr val="lt1"/>
+          </a:fontRef>
+        </p:style>
+        <p:txBody>
+          <a:bodyPr rtlCol="0" anchor="ctr"/>
+          <a:lstStyle/>
+          <a:p>
+            <a:pPr algn="ctr"/>
+          </a:p>
+        </p:txBody>
+      </p:sp>
+      <p:sp>
+        <p:nvSpPr>
+          <p:cNvPr id="38" name="Oval 37"/>
+          <p:cNvSpPr/>
+          <p:nvPr/>
+        </p:nvSpPr>
+        <p:spPr>
+          <a:xfrm>
+            <a:off x="1929384" y="2386584"/>
+            <a:ext cx="621792" cy="621792"/>
+          </a:xfrm>
+          <a:prstGeom prst="ellipse">
+            <a:avLst/>
+          </a:prstGeom>
+          <a:solidFill>
+            <a:srgbClr val="E3F2FD"/>
+          </a:solidFill>
+          <a:ln w="22860">
+            <a:solidFill>
+              <a:srgbClr val="2B5C8A"/>
+            </a:solidFill>
+          </a:ln>
+        </p:spPr>
+        <p:style>
+          <a:lnRef idx="1">
+            <a:schemeClr val="accent1"/>
+          </a:lnRef>
+          <a:fillRef idx="3">
+            <a:schemeClr val="accent1"/>
+          </a:fillRef>
+          <a:effectRef idx="2">
+            <a:schemeClr val="accent1"/>
+          </a:effectRef>
+          <a:fontRef idx="minor">
+            <a:schemeClr val="lt1"/>
+          </a:fontRef>
+        </p:style>
+        <p:txBody>
+          <a:bodyPr rtlCol="0" anchor="ctr"/>
+          <a:lstStyle/>
+          <a:p>
+            <a:pPr algn="ctr"/>
+          </a:p>
+        </p:txBody>
+      </p:sp>
+      <p:sp>
+        <p:nvSpPr>
+          <p:cNvPr id="39" name="Oval 38"/>
+          <p:cNvSpPr/>
+          <p:nvPr/>
+        </p:nvSpPr>
+        <p:spPr>
+          <a:xfrm>
+            <a:off x="1984248" y="2441448"/>
+            <a:ext cx="512064" cy="512064"/>
+          </a:xfrm>
+          <a:prstGeom prst="ellipse">
+            <a:avLst/>
+          </a:prstGeom>
+          <a:solidFill>
+            <a:srgbClr val="2B5C8A"/>
+          </a:solidFill>
+          <a:ln>
+            <a:noFill/>
+          </a:ln>
+        </p:spPr>
+        <p:style>
+          <a:lnRef idx="1">
+            <a:schemeClr val="accent1"/>
+          </a:lnRef>
+          <a:fillRef idx="3">
+            <a:schemeClr val="accent1"/>
+          </a:fillRef>
+          <a:effectRef idx="2">
+            <a:schemeClr val="accent1"/>
+          </a:effectRef>
+          <a:fontRef idx="minor">
+            <a:schemeClr val="lt1"/>
+          </a:fontRef>
+        </p:style>
+        <p:txBody>
+          <a:bodyPr rtlCol="0" anchor="ctr"/>
+          <a:lstStyle/>
+          <a:p>
+            <a:pPr algn="ctr"/>
+            <a:r>
+              <a:rPr sz="1400" b="1">
+                <a:solidFill>
+                  <a:srgbClr val="FFFFFF"/>
+                </a:solidFill>
+                <a:latin typeface="Tahoma"/>
+              </a:rPr>
+              <a:t>۵</a:t>
+            </a:r>
+          </a:p>
+        </p:txBody>
+      </p:sp>
+      <p:sp>
+        <p:nvSpPr>
+          <p:cNvPr id="40" name="Rounded Rectangle 39"/>
+          <p:cNvSpPr/>
+          <p:nvPr/>
+        </p:nvSpPr>
+        <p:spPr>
+          <a:xfrm>
+            <a:off x="1591056" y="1408176"/>
+            <a:ext cx="1298448" cy="868680"/>
           </a:xfrm>
           <a:prstGeom prst="roundRect">
+            <a:avLst/>
+          </a:prstGeom>
+          <a:solidFill>
+            <a:srgbClr val="FFFFFF"/>
+          </a:solidFill>
+          <a:ln w="12700">
+            <a:solidFill>
+              <a:srgbClr val="2B5C8A"/>
+            </a:solidFill>
+          </a:ln>
+        </p:spPr>
+        <p:style>
+          <a:lnRef idx="1">
+            <a:schemeClr val="accent1"/>
+          </a:lnRef>
+          <a:fillRef idx="3">
+            <a:schemeClr val="accent1"/>
+          </a:fillRef>
+          <a:effectRef idx="2">
+            <a:schemeClr val="accent1"/>
+          </a:effectRef>
+          <a:fontRef idx="minor">
+            <a:schemeClr val="lt1"/>
+          </a:fontRef>
+        </p:style>
+        <p:txBody>
+          <a:bodyPr rtlCol="0" anchor="ctr"/>
+          <a:lstStyle/>
+          <a:p>
+            <a:pPr algn="ctr"/>
+          </a:p>
+        </p:txBody>
+      </p:sp>
+      <p:sp>
+        <p:nvSpPr>
+          <p:cNvPr id="41" name="TextBox 40"/>
+          <p:cNvSpPr txBox="1"/>
+          <p:nvPr/>
+        </p:nvSpPr>
+        <p:spPr>
+          <a:xfrm>
+            <a:off x="1645920" y="1481328"/>
+            <a:ext cx="1188720" cy="274320"/>
+          </a:xfrm>
+          <a:prstGeom prst="rect">
+            <a:avLst/>
+          </a:prstGeom>
+          <a:noFill/>
+        </p:spPr>
+        <p:txBody>
+          <a:bodyPr wrap="square" anchor="ctr">
+            <a:spAutoFit/>
+          </a:bodyPr>
+          <a:lstStyle/>
+          <a:p>
+            <a:pPr algn="ctr" a:rtl="1"/>
+            <a:r>
+              <a:rPr sz="1000" b="1">
+                <a:solidFill>
+                  <a:srgbClr val="2D343E"/>
+                </a:solidFill>
+                <a:latin typeface="Tahoma"/>
+              </a:rPr>
+              <a:t>میانگین هندسی</a:t>
+            </a:r>
+          </a:p>
+        </p:txBody>
+      </p:sp>
+      <p:sp>
+        <p:nvSpPr>
+          <p:cNvPr id="42" name="TextBox 41"/>
+          <p:cNvSpPr txBox="1"/>
+          <p:nvPr/>
+        </p:nvSpPr>
+        <p:spPr>
+          <a:xfrm>
+            <a:off x="1645920" y="1755648"/>
+            <a:ext cx="1188720" cy="384048"/>
+          </a:xfrm>
+          <a:prstGeom prst="rect">
+            <a:avLst/>
+          </a:prstGeom>
+          <a:noFill/>
+        </p:spPr>
+        <p:txBody>
+          <a:bodyPr wrap="square" anchor="ctr">
+            <a:spAutoFit/>
+          </a:bodyPr>
+          <a:lstStyle/>
+          <a:p>
+            <a:pPr algn="ctr" a:rtl="1"/>
+            <a:r>
+              <a:rPr sz="850" b="0">
+                <a:solidFill>
+                  <a:srgbClr val="6B7280"/>
+                </a:solidFill>
+                <a:latin typeface="Tahoma"/>
+              </a:rPr>
+              <a:t>تجمیع نظرات پذیرفته‌شده</a:t>
+            </a:r>
+          </a:p>
+        </p:txBody>
+      </p:sp>
+      <p:sp>
+        <p:nvSpPr>
+          <p:cNvPr id="43" name="Rectangle 42"/>
+          <p:cNvSpPr/>
+          <p:nvPr/>
+        </p:nvSpPr>
+        <p:spPr>
+          <a:xfrm>
+            <a:off x="2227580" y="2276856"/>
+            <a:ext cx="25400" cy="109728"/>
+          </a:xfrm>
+          <a:prstGeom prst="rect">
+            <a:avLst/>
+          </a:prstGeom>
+          <a:solidFill>
+            <a:srgbClr val="2B5C8A"/>
+          </a:solidFill>
+          <a:ln>
+            <a:noFill/>
+          </a:ln>
+        </p:spPr>
+        <p:style>
+          <a:lnRef idx="1">
+            <a:schemeClr val="accent1"/>
+          </a:lnRef>
+          <a:fillRef idx="3">
+            <a:schemeClr val="accent1"/>
+          </a:fillRef>
+          <a:effectRef idx="2">
+            <a:schemeClr val="accent1"/>
+          </a:effectRef>
+          <a:fontRef idx="minor">
+            <a:schemeClr val="lt1"/>
+          </a:fontRef>
+        </p:style>
+        <p:txBody>
+          <a:bodyPr rtlCol="0" anchor="ctr"/>
+          <a:lstStyle/>
+          <a:p>
+            <a:pPr algn="ctr"/>
+          </a:p>
+        </p:txBody>
+      </p:sp>
+      <p:sp>
+        <p:nvSpPr>
+          <p:cNvPr id="44" name="Oval 43"/>
+          <p:cNvSpPr/>
+          <p:nvPr/>
+        </p:nvSpPr>
+        <p:spPr>
+          <a:xfrm>
+            <a:off x="374904" y="2386584"/>
+            <a:ext cx="621792" cy="621792"/>
+          </a:xfrm>
+          <a:prstGeom prst="ellipse">
+            <a:avLst/>
+          </a:prstGeom>
+          <a:solidFill>
+            <a:srgbClr val="E8F5E9"/>
+          </a:solidFill>
+          <a:ln w="31750">
+            <a:solidFill>
+              <a:srgbClr val="1E3A5F"/>
+            </a:solidFill>
+          </a:ln>
+        </p:spPr>
+        <p:style>
+          <a:lnRef idx="1">
+            <a:schemeClr val="accent1"/>
+          </a:lnRef>
+          <a:fillRef idx="3">
+            <a:schemeClr val="accent1"/>
+          </a:fillRef>
+          <a:effectRef idx="2">
+            <a:schemeClr val="accent1"/>
+          </a:effectRef>
+          <a:fontRef idx="minor">
+            <a:schemeClr val="lt1"/>
+          </a:fontRef>
+        </p:style>
+        <p:txBody>
+          <a:bodyPr rtlCol="0" anchor="ctr"/>
+          <a:lstStyle/>
+          <a:p>
+            <a:pPr algn="ctr"/>
+          </a:p>
+        </p:txBody>
+      </p:sp>
+      <p:sp>
+        <p:nvSpPr>
+          <p:cNvPr id="45" name="Oval 44"/>
+          <p:cNvSpPr/>
+          <p:nvPr/>
+        </p:nvSpPr>
+        <p:spPr>
+          <a:xfrm>
+            <a:off x="429768" y="2441448"/>
+            <a:ext cx="512064" cy="512064"/>
+          </a:xfrm>
+          <a:prstGeom prst="ellipse">
             <a:avLst/>
           </a:prstGeom>
           <a:solidFill>
@@ -4633,327 +4934,29 @@
           <a:bodyPr rtlCol="0" anchor="ctr"/>
           <a:lstStyle/>
           <a:p>
-            <a:pPr algn="ctr" a:rtl="1"/>
-            <a:r>
-              <a:rPr sz="1300" b="1">
+            <a:pPr algn="ctr"/>
+            <a:r>
+              <a:rPr sz="1600" b="1">
                 <a:solidFill>
                   <a:srgbClr val="FFFFFF"/>
                 </a:solidFill>
                 <a:latin typeface="Tahoma"/>
               </a:rPr>
-              <a:t>تجمیع و خروجی</a:t>
-            </a:r>
-          </a:p>
-        </p:txBody>
-      </p:sp>
-      <p:sp>
-        <p:nvSpPr>
-          <p:cNvPr id="38" name="Rounded Rectangle 37"/>
+              <a:t>۶</a:t>
+            </a:r>
+          </a:p>
+        </p:txBody>
+      </p:sp>
+      <p:sp>
+        <p:nvSpPr>
+          <p:cNvPr id="46" name="Rounded Rectangle 45"/>
           <p:cNvSpPr/>
           <p:nvPr/>
         </p:nvSpPr>
         <p:spPr>
           <a:xfrm>
-            <a:off x="6025896" y="1728216"/>
-            <a:ext cx="2606040" cy="1051560"/>
-          </a:xfrm>
-          <a:prstGeom prst="roundRect">
-            <a:avLst/>
-          </a:prstGeom>
-          <a:solidFill>
-            <a:srgbClr val="FFFFFF"/>
-          </a:solidFill>
-          <a:ln w="15240">
-            <a:solidFill>
-              <a:srgbClr val="1E3A5F"/>
-            </a:solidFill>
-          </a:ln>
-        </p:spPr>
-        <p:style>
-          <a:lnRef idx="1">
-            <a:schemeClr val="accent1"/>
-          </a:lnRef>
-          <a:fillRef idx="3">
-            <a:schemeClr val="accent1"/>
-          </a:fillRef>
-          <a:effectRef idx="2">
-            <a:schemeClr val="accent1"/>
-          </a:effectRef>
-          <a:fontRef idx="minor">
-            <a:schemeClr val="lt1"/>
-          </a:fontRef>
-        </p:style>
-        <p:txBody>
-          <a:bodyPr rtlCol="0" anchor="ctr"/>
-          <a:lstStyle/>
-          <a:p>
-            <a:pPr algn="ctr"/>
-          </a:p>
-        </p:txBody>
-      </p:sp>
-      <p:sp>
-        <p:nvSpPr>
-          <p:cNvPr id="39" name="Rectangle 38"/>
-          <p:cNvSpPr/>
-          <p:nvPr/>
-        </p:nvSpPr>
-        <p:spPr>
-          <a:xfrm>
-            <a:off x="6025896" y="1728216"/>
-            <a:ext cx="2606040" cy="54864"/>
-          </a:xfrm>
-          <a:prstGeom prst="rect">
-            <a:avLst/>
-          </a:prstGeom>
-          <a:solidFill>
-            <a:srgbClr val="1E3A5F"/>
-          </a:solidFill>
-          <a:ln>
-            <a:noFill/>
-          </a:ln>
-        </p:spPr>
-        <p:style>
-          <a:lnRef idx="1">
-            <a:schemeClr val="accent1"/>
-          </a:lnRef>
-          <a:fillRef idx="3">
-            <a:schemeClr val="accent1"/>
-          </a:fillRef>
-          <a:effectRef idx="2">
-            <a:schemeClr val="accent1"/>
-          </a:effectRef>
-          <a:fontRef idx="minor">
-            <a:schemeClr val="lt1"/>
-          </a:fontRef>
-        </p:style>
-        <p:txBody>
-          <a:bodyPr rtlCol="0" anchor="ctr"/>
-          <a:lstStyle/>
-          <a:p>
-            <a:pPr algn="ctr"/>
-          </a:p>
-        </p:txBody>
-      </p:sp>
-      <p:sp>
-        <p:nvSpPr>
-          <p:cNvPr id="40" name="Rounded Rectangle 39"/>
-          <p:cNvSpPr/>
-          <p:nvPr/>
-        </p:nvSpPr>
-        <p:spPr>
-          <a:xfrm>
-            <a:off x="6153912" y="1892808"/>
-            <a:ext cx="384048" cy="384048"/>
-          </a:xfrm>
-          <a:prstGeom prst="roundRect">
-            <a:avLst/>
-          </a:prstGeom>
-          <a:solidFill>
-            <a:srgbClr val="E8F5E9"/>
-          </a:solidFill>
-          <a:ln w="12700">
-            <a:solidFill>
-              <a:srgbClr val="1E3A5F"/>
-            </a:solidFill>
-          </a:ln>
-        </p:spPr>
-        <p:style>
-          <a:lnRef idx="1">
-            <a:schemeClr val="accent1"/>
-          </a:lnRef>
-          <a:fillRef idx="3">
-            <a:schemeClr val="accent1"/>
-          </a:fillRef>
-          <a:effectRef idx="2">
-            <a:schemeClr val="accent1"/>
-          </a:effectRef>
-          <a:fontRef idx="minor">
-            <a:schemeClr val="lt1"/>
-          </a:fontRef>
-        </p:style>
-        <p:txBody>
-          <a:bodyPr rtlCol="0" anchor="ctr"/>
-          <a:lstStyle/>
-          <a:p>
-            <a:pPr algn="ctr"/>
-          </a:p>
-        </p:txBody>
-      </p:sp>
-      <p:sp>
-        <p:nvSpPr>
-          <p:cNvPr id="41" name="Action Button: Return 40"/>
-          <p:cNvSpPr/>
-          <p:nvPr/>
-        </p:nvSpPr>
-        <p:spPr>
-          <a:xfrm>
-            <a:off x="6227064" y="1956816"/>
-            <a:ext cx="237744" cy="237744"/>
-          </a:xfrm>
-          <a:prstGeom prst="actionButtonReturn">
-            <a:avLst/>
-          </a:prstGeom>
-          <a:solidFill>
-            <a:srgbClr val="1E3A5F"/>
-          </a:solidFill>
-          <a:ln>
-            <a:noFill/>
-          </a:ln>
-        </p:spPr>
-        <p:style>
-          <a:lnRef idx="1">
-            <a:schemeClr val="accent1"/>
-          </a:lnRef>
-          <a:fillRef idx="3">
-            <a:schemeClr val="accent1"/>
-          </a:fillRef>
-          <a:effectRef idx="2">
-            <a:schemeClr val="accent1"/>
-          </a:effectRef>
-          <a:fontRef idx="minor">
-            <a:schemeClr val="lt1"/>
-          </a:fontRef>
-        </p:style>
-        <p:txBody>
-          <a:bodyPr rtlCol="0" anchor="ctr"/>
-          <a:lstStyle/>
-          <a:p>
-            <a:pPr algn="ctr"/>
-          </a:p>
-        </p:txBody>
-      </p:sp>
-      <p:sp>
-        <p:nvSpPr>
-          <p:cNvPr id="42" name="Rounded Rectangle 41"/>
-          <p:cNvSpPr/>
-          <p:nvPr/>
-        </p:nvSpPr>
-        <p:spPr>
-          <a:xfrm>
-            <a:off x="8193024" y="1856232"/>
-            <a:ext cx="310896" cy="310896"/>
-          </a:xfrm>
-          <a:prstGeom prst="roundRect">
-            <a:avLst/>
-          </a:prstGeom>
-          <a:solidFill>
-            <a:srgbClr val="1E3A5F"/>
-          </a:solidFill>
-          <a:ln>
-            <a:noFill/>
-          </a:ln>
-        </p:spPr>
-        <p:style>
-          <a:lnRef idx="1">
-            <a:schemeClr val="accent1"/>
-          </a:lnRef>
-          <a:fillRef idx="3">
-            <a:schemeClr val="accent1"/>
-          </a:fillRef>
-          <a:effectRef idx="2">
-            <a:schemeClr val="accent1"/>
-          </a:effectRef>
-          <a:fontRef idx="minor">
-            <a:schemeClr val="lt1"/>
-          </a:fontRef>
-        </p:style>
-        <p:txBody>
-          <a:bodyPr rtlCol="0" anchor="ctr"/>
-          <a:lstStyle/>
-          <a:p>
-            <a:pPr algn="ctr"/>
-            <a:r>
-              <a:rPr sz="1300" b="1">
-                <a:solidFill>
-                  <a:srgbClr val="FFFFFF"/>
-                </a:solidFill>
-                <a:latin typeface="Tahoma"/>
-              </a:rPr>
-              <a:t>۵</a:t>
-            </a:r>
-          </a:p>
-        </p:txBody>
-      </p:sp>
-      <p:sp>
-        <p:nvSpPr>
-          <p:cNvPr id="43" name="TextBox 42"/>
-          <p:cNvSpPr txBox="1"/>
-          <p:nvPr/>
-        </p:nvSpPr>
-        <p:spPr>
-          <a:xfrm>
-            <a:off x="6592824" y="1874520"/>
-            <a:ext cx="1892808" cy="292608"/>
-          </a:xfrm>
-          <a:prstGeom prst="rect">
-            <a:avLst/>
-          </a:prstGeom>
-          <a:noFill/>
-        </p:spPr>
-        <p:txBody>
-          <a:bodyPr wrap="square" anchor="ctr">
-            <a:spAutoFit/>
-          </a:bodyPr>
-          <a:lstStyle/>
-          <a:p>
-            <a:pPr algn="r" a:rtl="1"/>
-            <a:r>
-              <a:rPr sz="1200" b="1">
-                <a:solidFill>
-                  <a:srgbClr val="2D343E"/>
-                </a:solidFill>
-                <a:latin typeface="Tahoma"/>
-              </a:rPr>
-              <a:t>تجمیع با میانگین هندسی</a:t>
-            </a:r>
-          </a:p>
-        </p:txBody>
-      </p:sp>
-      <p:sp>
-        <p:nvSpPr>
-          <p:cNvPr id="44" name="TextBox 43"/>
-          <p:cNvSpPr txBox="1"/>
-          <p:nvPr/>
-        </p:nvSpPr>
-        <p:spPr>
-          <a:xfrm>
-            <a:off x="6592824" y="2185416"/>
-            <a:ext cx="1892808" cy="502920"/>
-          </a:xfrm>
-          <a:prstGeom prst="rect">
-            <a:avLst/>
-          </a:prstGeom>
-          <a:noFill/>
-        </p:spPr>
-        <p:txBody>
-          <a:bodyPr wrap="square" anchor="ctr">
-            <a:spAutoFit/>
-          </a:bodyPr>
-          <a:lstStyle/>
-          <a:p>
-            <a:pPr algn="r" a:rtl="1"/>
-            <a:r>
-              <a:rPr sz="950" b="0">
-                <a:solidFill>
-                  <a:srgbClr val="6B7280"/>
-                </a:solidFill>
-                <a:latin typeface="Tahoma"/>
-              </a:rPr>
-              <a:t>نظرات پذیرفته‌شده با میانگین هندسی ادغام می‌شوند</a:t>
-            </a:r>
-          </a:p>
-        </p:txBody>
-      </p:sp>
-      <p:sp>
-        <p:nvSpPr>
-          <p:cNvPr id="45" name="Rounded Rectangle 44"/>
-          <p:cNvSpPr/>
-          <p:nvPr/>
-        </p:nvSpPr>
-        <p:spPr>
-          <a:xfrm>
-            <a:off x="6025896" y="2944368"/>
-            <a:ext cx="2606040" cy="1051560"/>
+            <a:off x="36576" y="3118104"/>
+            <a:ext cx="1298448" cy="868680"/>
           </a:xfrm>
           <a:prstGeom prst="roundRect">
             <a:avLst/>
@@ -4991,14 +4994,84 @@
       </p:sp>
       <p:sp>
         <p:nvSpPr>
-          <p:cNvPr id="46" name="Rectangle 45"/>
+          <p:cNvPr id="47" name="TextBox 46"/>
+          <p:cNvSpPr txBox="1"/>
+          <p:nvPr/>
+        </p:nvSpPr>
+        <p:spPr>
+          <a:xfrm>
+            <a:off x="91440" y="3191256"/>
+            <a:ext cx="1188720" cy="274320"/>
+          </a:xfrm>
+          <a:prstGeom prst="rect">
+            <a:avLst/>
+          </a:prstGeom>
+          <a:noFill/>
+        </p:spPr>
+        <p:txBody>
+          <a:bodyPr wrap="square" anchor="ctr">
+            <a:spAutoFit/>
+          </a:bodyPr>
+          <a:lstStyle/>
+          <a:p>
+            <a:pPr algn="ctr" a:rtl="1"/>
+            <a:r>
+              <a:rPr sz="1000" b="1">
+                <a:solidFill>
+                  <a:srgbClr val="FFFFFF"/>
+                </a:solidFill>
+                <a:latin typeface="Tahoma"/>
+              </a:rPr>
+              <a:t>وزن نهایی معیارها</a:t>
+            </a:r>
+          </a:p>
+        </p:txBody>
+      </p:sp>
+      <p:sp>
+        <p:nvSpPr>
+          <p:cNvPr id="48" name="TextBox 47"/>
+          <p:cNvSpPr txBox="1"/>
+          <p:nvPr/>
+        </p:nvSpPr>
+        <p:spPr>
+          <a:xfrm>
+            <a:off x="91440" y="3465576"/>
+            <a:ext cx="1188720" cy="384048"/>
+          </a:xfrm>
+          <a:prstGeom prst="rect">
+            <a:avLst/>
+          </a:prstGeom>
+          <a:noFill/>
+        </p:spPr>
+        <p:txBody>
+          <a:bodyPr wrap="square" anchor="ctr">
+            <a:spAutoFit/>
+          </a:bodyPr>
+          <a:lstStyle/>
+          <a:p>
+            <a:pPr algn="ctr" a:rtl="1"/>
+            <a:r>
+              <a:rPr sz="850" b="0">
+                <a:solidFill>
+                  <a:srgbClr val="BBDEFB"/>
+                </a:solidFill>
+                <a:latin typeface="Tahoma"/>
+              </a:rPr>
+              <a:t>ماتریس تجمیع‌شده مبنای محاسبه</a:t>
+            </a:r>
+          </a:p>
+        </p:txBody>
+      </p:sp>
+      <p:sp>
+        <p:nvSpPr>
+          <p:cNvPr id="49" name="Rectangle 48"/>
           <p:cNvSpPr/>
           <p:nvPr/>
         </p:nvSpPr>
         <p:spPr>
           <a:xfrm>
-            <a:off x="6025896" y="2944368"/>
-            <a:ext cx="2606040" cy="54864"/>
+            <a:off x="673100" y="3008376"/>
+            <a:ext cx="25400" cy="109728"/>
           </a:xfrm>
           <a:prstGeom prst="rect">
             <a:avLst/>
@@ -5034,154 +5107,49 @@
       </p:sp>
       <p:sp>
         <p:nvSpPr>
-          <p:cNvPr id="47" name="Rounded Rectangle 46"/>
-          <p:cNvSpPr/>
+          <p:cNvPr id="50" name="TextBox 49"/>
+          <p:cNvSpPr txBox="1"/>
           <p:nvPr/>
         </p:nvSpPr>
         <p:spPr>
           <a:xfrm>
-            <a:off x="6153912" y="3108960"/>
-            <a:ext cx="384048" cy="384048"/>
-          </a:xfrm>
-          <a:prstGeom prst="roundRect">
-            <a:avLst/>
-          </a:prstGeom>
-          <a:solidFill>
-            <a:srgbClr val="E8F5E9"/>
-          </a:solidFill>
-          <a:ln w="12700">
-            <a:solidFill>
-              <a:srgbClr val="1E3A5F"/>
-            </a:solidFill>
-          </a:ln>
-        </p:spPr>
-        <p:style>
-          <a:lnRef idx="1">
-            <a:schemeClr val="accent1"/>
-          </a:lnRef>
-          <a:fillRef idx="3">
-            <a:schemeClr val="accent1"/>
-          </a:fillRef>
-          <a:effectRef idx="2">
-            <a:schemeClr val="accent1"/>
-          </a:effectRef>
-          <a:fontRef idx="minor">
-            <a:schemeClr val="lt1"/>
-          </a:fontRef>
-        </p:style>
-        <p:txBody>
-          <a:bodyPr rtlCol="0" anchor="ctr"/>
-          <a:lstStyle/>
-          <a:p>
-            <a:pPr algn="ctr"/>
-          </a:p>
-        </p:txBody>
-      </p:sp>
-      <p:sp>
-        <p:nvSpPr>
-          <p:cNvPr id="48" name="5-Point Star 47"/>
-          <p:cNvSpPr/>
-          <p:nvPr/>
-        </p:nvSpPr>
-        <p:spPr>
-          <a:xfrm>
-            <a:off x="6227064" y="3172968"/>
-            <a:ext cx="237744" cy="237744"/>
-          </a:xfrm>
-          <a:prstGeom prst="star5">
-            <a:avLst/>
-          </a:prstGeom>
-          <a:solidFill>
-            <a:srgbClr val="1E3A5F"/>
-          </a:solidFill>
-          <a:ln>
-            <a:noFill/>
-          </a:ln>
-        </p:spPr>
-        <p:style>
-          <a:lnRef idx="1">
-            <a:schemeClr val="accent1"/>
-          </a:lnRef>
-          <a:fillRef idx="3">
-            <a:schemeClr val="accent1"/>
-          </a:fillRef>
-          <a:effectRef idx="2">
-            <a:schemeClr val="accent1"/>
-          </a:effectRef>
-          <a:fontRef idx="minor">
-            <a:schemeClr val="lt1"/>
-          </a:fontRef>
-        </p:style>
-        <p:txBody>
-          <a:bodyPr rtlCol="0" anchor="ctr"/>
-          <a:lstStyle/>
-          <a:p>
-            <a:pPr algn="ctr"/>
-          </a:p>
-        </p:txBody>
-      </p:sp>
-      <p:sp>
-        <p:nvSpPr>
-          <p:cNvPr id="49" name="Rounded Rectangle 48"/>
-          <p:cNvSpPr/>
-          <p:nvPr/>
-        </p:nvSpPr>
-        <p:spPr>
-          <a:xfrm>
-            <a:off x="8193024" y="3072384"/>
-            <a:ext cx="310896" cy="310896"/>
-          </a:xfrm>
-          <a:prstGeom prst="roundRect">
-            <a:avLst/>
-          </a:prstGeom>
-          <a:solidFill>
-            <a:srgbClr val="1E3A5F"/>
-          </a:solidFill>
-          <a:ln>
-            <a:noFill/>
-          </a:ln>
-        </p:spPr>
-        <p:style>
-          <a:lnRef idx="1">
-            <a:schemeClr val="accent1"/>
-          </a:lnRef>
-          <a:fillRef idx="3">
-            <a:schemeClr val="accent1"/>
-          </a:fillRef>
-          <a:effectRef idx="2">
-            <a:schemeClr val="accent1"/>
-          </a:effectRef>
-          <a:fontRef idx="minor">
-            <a:schemeClr val="lt1"/>
-          </a:fontRef>
-        </p:style>
-        <p:txBody>
-          <a:bodyPr rtlCol="0" anchor="ctr"/>
-          <a:lstStyle/>
-          <a:p>
-            <a:pPr algn="ctr"/>
-            <a:r>
-              <a:rPr sz="1300" b="1">
+            <a:off x="8001000" y="3200400"/>
+            <a:ext cx="914400" cy="228600"/>
+          </a:xfrm>
+          <a:prstGeom prst="rect">
+            <a:avLst/>
+          </a:prstGeom>
+          <a:noFill/>
+        </p:spPr>
+        <p:txBody>
+          <a:bodyPr wrap="square" anchor="ctr">
+            <a:spAutoFit/>
+          </a:bodyPr>
+          <a:lstStyle/>
+          <a:p>
+            <a:pPr algn="ctr" a:rtl="1"/>
+            <a:r>
+              <a:rPr sz="900" b="1">
                 <a:solidFill>
-                  <a:srgbClr val="FFFFFF"/>
+                  <a:srgbClr val="2B5C8A"/>
                 </a:solidFill>
                 <a:latin typeface="Tahoma"/>
               </a:rPr>
-              <a:t>۶</a:t>
-            </a:r>
-          </a:p>
-        </p:txBody>
-      </p:sp>
-      <p:sp>
-        <p:nvSpPr>
-          <p:cNvPr id="50" name="TextBox 49"/>
+              <a:t>شروع</a:t>
+            </a:r>
+          </a:p>
+        </p:txBody>
+      </p:sp>
+      <p:sp>
+        <p:nvSpPr>
+          <p:cNvPr id="51" name="TextBox 50"/>
           <p:cNvSpPr txBox="1"/>
           <p:nvPr/>
         </p:nvSpPr>
         <p:spPr>
           <a:xfrm>
-            <a:off x="6592824" y="3090672"/>
-            <a:ext cx="1892808" cy="292608"/>
+            <a:off x="594360" y="3200400"/>
+            <a:ext cx="914400" cy="228600"/>
           </a:xfrm>
           <a:prstGeom prst="rect">
             <a:avLst/>
@@ -5194,50 +5162,15 @@
           </a:bodyPr>
           <a:lstStyle/>
           <a:p>
-            <a:pPr algn="r" a:rtl="1"/>
-            <a:r>
-              <a:rPr sz="1200" b="1">
+            <a:pPr algn="ctr" a:rtl="1"/>
+            <a:r>
+              <a:rPr sz="900" b="1">
                 <a:solidFill>
-                  <a:srgbClr val="FFFFFF"/>
+                  <a:srgbClr val="1E3A5F"/>
                 </a:solidFill>
                 <a:latin typeface="Tahoma"/>
               </a:rPr>
-              <a:t>محاسبه وزن نهایی معیارها</a:t>
-            </a:r>
-          </a:p>
-        </p:txBody>
-      </p:sp>
-      <p:sp>
-        <p:nvSpPr>
-          <p:cNvPr id="51" name="TextBox 50"/>
-          <p:cNvSpPr txBox="1"/>
-          <p:nvPr/>
-        </p:nvSpPr>
-        <p:spPr>
-          <a:xfrm>
-            <a:off x="6592824" y="3401568"/>
-            <a:ext cx="1892808" cy="502920"/>
-          </a:xfrm>
-          <a:prstGeom prst="rect">
-            <a:avLst/>
-          </a:prstGeom>
-          <a:noFill/>
-        </p:spPr>
-        <p:txBody>
-          <a:bodyPr wrap="square" anchor="ctr">
-            <a:spAutoFit/>
-          </a:bodyPr>
-          <a:lstStyle/>
-          <a:p>
-            <a:pPr algn="r" a:rtl="1"/>
-            <a:r>
-              <a:rPr sz="950" b="0">
-                <a:solidFill>
-                  <a:srgbClr val="BBDEFB"/>
-                </a:solidFill>
-                <a:latin typeface="Tahoma"/>
-              </a:rPr>
-              <a:t>ماتریس تجمیع‌شده مبنای بردار وزن نهایی است</a:t>
+              <a:t>پایان</a:t>
             </a:r>
           </a:p>
         </p:txBody>
@@ -5250,8 +5183,8 @@
         </p:nvSpPr>
         <p:spPr>
           <a:xfrm>
-            <a:off x="411480" y="4315968"/>
-            <a:ext cx="8321040" cy="566928"/>
+            <a:off x="411480" y="4160520"/>
+            <a:ext cx="8321040" cy="658368"/>
           </a:xfrm>
           <a:prstGeom prst="roundRect">
             <a:avLst/>
@@ -5295,8 +5228,8 @@
         </p:nvSpPr>
         <p:spPr>
           <a:xfrm>
-            <a:off x="548640" y="4434840"/>
-            <a:ext cx="8046720" cy="347472"/>
+            <a:off x="548640" y="4297680"/>
+            <a:ext cx="8046720" cy="411480"/>
           </a:xfrm>
           <a:prstGeom prst="rect">
             <a:avLst/>
@@ -5317,7 +5250,11 @@
                 </a:solidFill>
                 <a:latin typeface="Tahoma"/>
               </a:rPr>
-              <a:t>مقیاس ساعتی: ۱ = برابر  ·  ۳ = متوسط  ·  ۵ = قوی  ·  ۷ = خیلی قوی  ·  ۹ = مطلق  |  آستانه سازگاری: CR &lt; 0.1</a:t>
+              <a:t>مقیاس ساعتی AHP: ۱ = برابر  ·  ۳ = متوسط  ·  ۵ = قوی  ·  ۹ = مطلق</a:t>
+            </a:r>
+            <a:br/>
+            <a:r>
+              <a:t>آستانه پذیرش سازگاری: CR &lt; 0.1</a:t>
             </a:r>
           </a:p>
         </p:txBody>

</xml_diff>

<commit_message>
Restyle AHP expert timeline to match research framework graphics
Use blue RTL boxes with grey arrows, right sidebar, and compact
six-step layout consistent with چارچوب کلی پژوهش slide.

Co-authored-by: sazmanfava854-sudo <sazmanfava854-sudo@users.noreply.github.com>
</commit_message>
<xml_diff>
--- a/presentations/فرآیند_تجمیع_نظرات_خبرگان_AHP.pptx
+++ b/presentations/فرآیند_تجمیع_نظرات_خبرگان_AHP.pptx
@@ -3103,7 +3103,7 @@
             <a:avLst/>
           </a:prstGeom>
           <a:solidFill>
-            <a:srgbClr val="F7F9FC"/>
+            <a:srgbClr val="FFFFFF"/>
           </a:solidFill>
           <a:ln>
             <a:noFill/>
@@ -3139,14 +3139,14 @@
         </p:nvSpPr>
         <p:spPr>
           <a:xfrm>
-            <a:off x="0" y="0"/>
-            <a:ext cx="9144000" cy="109728"/>
+            <a:off x="8641080" y="0"/>
+            <a:ext cx="502920" cy="5143500"/>
           </a:xfrm>
           <a:prstGeom prst="rect">
             <a:avLst/>
           </a:prstGeom>
           <a:solidFill>
-            <a:srgbClr val="1E3A5F"/>
+            <a:srgbClr val="2563EB"/>
           </a:solidFill>
           <a:ln>
             <a:noFill/>
@@ -3176,90 +3176,20 @@
       </p:sp>
       <p:sp>
         <p:nvSpPr>
-          <p:cNvPr id="4" name="TextBox 3"/>
-          <p:cNvSpPr txBox="1"/>
-          <p:nvPr/>
-        </p:nvSpPr>
-        <p:spPr>
-          <a:xfrm>
-            <a:off x="411480" y="256032"/>
-            <a:ext cx="8321040" cy="502920"/>
-          </a:xfrm>
-          <a:prstGeom prst="rect">
-            <a:avLst/>
-          </a:prstGeom>
-          <a:noFill/>
-        </p:spPr>
-        <p:txBody>
-          <a:bodyPr wrap="square" anchor="ctr">
-            <a:spAutoFit/>
-          </a:bodyPr>
-          <a:lstStyle/>
-          <a:p>
-            <a:pPr algn="ctr" a:rtl="1"/>
-            <a:r>
-              <a:rPr sz="2800" b="1">
-                <a:solidFill>
-                  <a:srgbClr val="1E3A5F"/>
-                </a:solidFill>
-                <a:latin typeface="Tahoma"/>
-              </a:rPr>
-              <a:t>گردآوری و تجمیع نظرات خبرگان در AHP</a:t>
-            </a:r>
-          </a:p>
-        </p:txBody>
-      </p:sp>
-      <p:sp>
-        <p:nvSpPr>
-          <p:cNvPr id="5" name="TextBox 4"/>
-          <p:cNvSpPr txBox="1"/>
-          <p:nvPr/>
-        </p:nvSpPr>
-        <p:spPr>
-          <a:xfrm>
-            <a:off x="411480" y="749808"/>
-            <a:ext cx="8321040" cy="320040"/>
-          </a:xfrm>
-          <a:prstGeom prst="rect">
-            <a:avLst/>
-          </a:prstGeom>
-          <a:noFill/>
-        </p:spPr>
-        <p:txBody>
-          <a:bodyPr wrap="square" anchor="ctr">
-            <a:spAutoFit/>
-          </a:bodyPr>
-          <a:lstStyle/>
-          <a:p>
-            <a:pPr algn="ctr" a:rtl="1"/>
-            <a:r>
-              <a:rPr sz="1300" b="0">
-                <a:solidFill>
-                  <a:srgbClr val="6B7280"/>
-                </a:solidFill>
-                <a:latin typeface="Tahoma"/>
-              </a:rPr>
-              <a:t>تایم‌لاین افقی مراحل فرآیند</a:t>
-            </a:r>
-          </a:p>
-        </p:txBody>
-      </p:sp>
-      <p:sp>
-        <p:nvSpPr>
-          <p:cNvPr id="6" name="Rectangle 5"/>
+          <p:cNvPr id="4" name="Oval 3"/>
           <p:cNvSpPr/>
           <p:nvPr/>
         </p:nvSpPr>
         <p:spPr>
           <a:xfrm>
-            <a:off x="685800" y="2672080"/>
-            <a:ext cx="7772400" cy="50800"/>
-          </a:xfrm>
-          <a:prstGeom prst="rect">
+            <a:off x="8764524" y="694944"/>
+            <a:ext cx="256032" cy="256032"/>
+          </a:xfrm>
+          <a:prstGeom prst="ellipse">
             <a:avLst/>
           </a:prstGeom>
           <a:solidFill>
-            <a:srgbClr val="D1D9E6"/>
+            <a:srgbClr val="DBEAFE"/>
           </a:solidFill>
           <a:ln>
             <a:noFill/>
@@ -3289,20 +3219,20 @@
       </p:sp>
       <p:sp>
         <p:nvSpPr>
-          <p:cNvPr id="7" name="Rectangle 6"/>
+          <p:cNvPr id="5" name="Oval 4"/>
           <p:cNvSpPr/>
           <p:nvPr/>
         </p:nvSpPr>
         <p:spPr>
           <a:xfrm>
-            <a:off x="685800" y="2852928"/>
-            <a:ext cx="2377440" cy="36576"/>
-          </a:xfrm>
-          <a:prstGeom prst="rect">
+            <a:off x="8764524" y="1426464"/>
+            <a:ext cx="256032" cy="256032"/>
+          </a:xfrm>
+          <a:prstGeom prst="ellipse">
             <a:avLst/>
           </a:prstGeom>
           <a:solidFill>
-            <a:srgbClr val="2B5C8A"/>
+            <a:srgbClr val="DBEAFE"/>
           </a:solidFill>
           <a:ln>
             <a:noFill/>
@@ -3332,55 +3262,20 @@
       </p:sp>
       <p:sp>
         <p:nvSpPr>
-          <p:cNvPr id="8" name="TextBox 7"/>
-          <p:cNvSpPr txBox="1"/>
-          <p:nvPr/>
-        </p:nvSpPr>
-        <p:spPr>
-          <a:xfrm>
-            <a:off x="685800" y="2907792"/>
-            <a:ext cx="2377440" cy="201168"/>
-          </a:xfrm>
-          <a:prstGeom prst="rect">
-            <a:avLst/>
-          </a:prstGeom>
-          <a:noFill/>
-        </p:spPr>
-        <p:txBody>
-          <a:bodyPr wrap="square" anchor="ctr">
-            <a:spAutoFit/>
-          </a:bodyPr>
-          <a:lstStyle/>
-          <a:p>
-            <a:pPr algn="ctr" a:rtl="1"/>
-            <a:r>
-              <a:rPr sz="800" b="0">
-                <a:solidFill>
-                  <a:srgbClr val="2B5C8A"/>
-                </a:solidFill>
-                <a:latin typeface="Tahoma"/>
-              </a:rPr>
-              <a:t>گردآوری</a:t>
-            </a:r>
-          </a:p>
-        </p:txBody>
-      </p:sp>
-      <p:sp>
-        <p:nvSpPr>
-          <p:cNvPr id="9" name="Rectangle 8"/>
+          <p:cNvPr id="6" name="Oval 5"/>
           <p:cNvSpPr/>
           <p:nvPr/>
         </p:nvSpPr>
         <p:spPr>
           <a:xfrm>
-            <a:off x="3063240" y="2852928"/>
-            <a:ext cx="2377440" cy="36576"/>
-          </a:xfrm>
-          <a:prstGeom prst="rect">
+            <a:off x="8764524" y="2203704"/>
+            <a:ext cx="256032" cy="256032"/>
+          </a:xfrm>
+          <a:prstGeom prst="ellipse">
             <a:avLst/>
           </a:prstGeom>
           <a:solidFill>
-            <a:srgbClr val="009688"/>
+            <a:srgbClr val="DBEAFE"/>
           </a:solidFill>
           <a:ln>
             <a:noFill/>
@@ -3410,55 +3305,20 @@
       </p:sp>
       <p:sp>
         <p:nvSpPr>
-          <p:cNvPr id="10" name="TextBox 9"/>
-          <p:cNvSpPr txBox="1"/>
-          <p:nvPr/>
-        </p:nvSpPr>
-        <p:spPr>
-          <a:xfrm>
-            <a:off x="3063240" y="2907792"/>
-            <a:ext cx="2377440" cy="201168"/>
-          </a:xfrm>
-          <a:prstGeom prst="rect">
-            <a:avLst/>
-          </a:prstGeom>
-          <a:noFill/>
-        </p:spPr>
-        <p:txBody>
-          <a:bodyPr wrap="square" anchor="ctr">
-            <a:spAutoFit/>
-          </a:bodyPr>
-          <a:lstStyle/>
-          <a:p>
-            <a:pPr algn="ctr" a:rtl="1"/>
-            <a:r>
-              <a:rPr sz="800" b="0">
-                <a:solidFill>
-                  <a:srgbClr val="009688"/>
-                </a:solidFill>
-                <a:latin typeface="Tahoma"/>
-              </a:rPr>
-              <a:t>کنترل کیفیت</a:t>
-            </a:r>
-          </a:p>
-        </p:txBody>
-      </p:sp>
-      <p:sp>
-        <p:nvSpPr>
-          <p:cNvPr id="11" name="Rectangle 10"/>
+          <p:cNvPr id="7" name="Oval 6"/>
           <p:cNvSpPr/>
           <p:nvPr/>
         </p:nvSpPr>
         <p:spPr>
           <a:xfrm>
-            <a:off x="5440680" y="2852928"/>
-            <a:ext cx="3017520" cy="36576"/>
-          </a:xfrm>
-          <a:prstGeom prst="rect">
+            <a:off x="8691372" y="2907792"/>
+            <a:ext cx="402336" cy="402336"/>
+          </a:xfrm>
+          <a:prstGeom prst="ellipse">
             <a:avLst/>
           </a:prstGeom>
           <a:solidFill>
-            <a:srgbClr val="1E3A5F"/>
+            <a:srgbClr val="FFFFFF"/>
           </a:solidFill>
           <a:ln>
             <a:noFill/>
@@ -3488,60 +3348,23 @@
       </p:sp>
       <p:sp>
         <p:nvSpPr>
-          <p:cNvPr id="12" name="TextBox 11"/>
-          <p:cNvSpPr txBox="1"/>
-          <p:nvPr/>
-        </p:nvSpPr>
-        <p:spPr>
-          <a:xfrm>
-            <a:off x="5440680" y="2907792"/>
-            <a:ext cx="3017520" cy="201168"/>
-          </a:xfrm>
-          <a:prstGeom prst="rect">
-            <a:avLst/>
-          </a:prstGeom>
-          <a:noFill/>
-        </p:spPr>
-        <p:txBody>
-          <a:bodyPr wrap="square" anchor="ctr">
-            <a:spAutoFit/>
-          </a:bodyPr>
-          <a:lstStyle/>
-          <a:p>
-            <a:pPr algn="ctr" a:rtl="1"/>
-            <a:r>
-              <a:rPr sz="800" b="0">
-                <a:solidFill>
-                  <a:srgbClr val="1E3A5F"/>
-                </a:solidFill>
-                <a:latin typeface="Tahoma"/>
-              </a:rPr>
-              <a:t>خروجی</a:t>
-            </a:r>
-          </a:p>
-        </p:txBody>
-      </p:sp>
-      <p:sp>
-        <p:nvSpPr>
-          <p:cNvPr id="13" name="Oval 12"/>
+          <p:cNvPr id="8" name="Oval 7"/>
           <p:cNvSpPr/>
           <p:nvPr/>
         </p:nvSpPr>
         <p:spPr>
           <a:xfrm>
-            <a:off x="8147304" y="2386584"/>
-            <a:ext cx="621792" cy="621792"/>
+            <a:off x="8764524" y="2980944"/>
+            <a:ext cx="256032" cy="256032"/>
           </a:xfrm>
           <a:prstGeom prst="ellipse">
             <a:avLst/>
           </a:prstGeom>
           <a:solidFill>
-            <a:srgbClr val="E3F2FD"/>
+            <a:srgbClr val="FFFFFF"/>
           </a:solidFill>
-          <a:ln w="22860">
-            <a:solidFill>
-              <a:srgbClr val="2B5C8A"/>
-            </a:solidFill>
+          <a:ln>
+            <a:noFill/>
           </a:ln>
         </p:spPr>
         <p:style>
@@ -3568,20 +3391,20 @@
       </p:sp>
       <p:sp>
         <p:nvSpPr>
-          <p:cNvPr id="14" name="Oval 13"/>
+          <p:cNvPr id="9" name="Oval 8"/>
           <p:cNvSpPr/>
           <p:nvPr/>
         </p:nvSpPr>
         <p:spPr>
           <a:xfrm>
-            <a:off x="8202168" y="2441448"/>
-            <a:ext cx="512064" cy="512064"/>
+            <a:off x="8764524" y="3758184"/>
+            <a:ext cx="256032" cy="256032"/>
           </a:xfrm>
           <a:prstGeom prst="ellipse">
             <a:avLst/>
           </a:prstGeom>
           <a:solidFill>
-            <a:srgbClr val="2B5C8A"/>
+            <a:srgbClr val="DBEAFE"/>
           </a:solidFill>
           <a:ln>
             <a:noFill/>
@@ -3606,39 +3429,430 @@
           <a:lstStyle/>
           <a:p>
             <a:pPr algn="ctr"/>
-            <a:r>
-              <a:rPr sz="1400" b="1">
+          </a:p>
+        </p:txBody>
+      </p:sp>
+      <p:sp>
+        <p:nvSpPr>
+          <p:cNvPr id="10" name="TextBox 9"/>
+          <p:cNvSpPr txBox="1"/>
+          <p:nvPr/>
+        </p:nvSpPr>
+        <p:spPr>
+          <a:xfrm>
+            <a:off x="411480" y="320040"/>
+            <a:ext cx="7863840" cy="502920"/>
+          </a:xfrm>
+          <a:prstGeom prst="rect">
+            <a:avLst/>
+          </a:prstGeom>
+          <a:noFill/>
+        </p:spPr>
+        <p:txBody>
+          <a:bodyPr wrap="square" anchor="ctr">
+            <a:spAutoFit/>
+          </a:bodyPr>
+          <a:lstStyle/>
+          <a:p>
+            <a:pPr algn="r" a:rtl="1"/>
+            <a:r>
+              <a:rPr sz="2400" b="1">
+                <a:solidFill>
+                  <a:srgbClr val="1E293B"/>
+                </a:solidFill>
+                <a:latin typeface="Tahoma"/>
+              </a:rPr>
+              <a:t>گردآوری و تجمیع نظرات خبرگان</a:t>
+            </a:r>
+          </a:p>
+        </p:txBody>
+      </p:sp>
+      <p:sp>
+        <p:nvSpPr>
+          <p:cNvPr id="11" name="TextBox 10"/>
+          <p:cNvSpPr txBox="1"/>
+          <p:nvPr/>
+        </p:nvSpPr>
+        <p:spPr>
+          <a:xfrm>
+            <a:off x="411480" y="804672"/>
+            <a:ext cx="7863840" cy="292608"/>
+          </a:xfrm>
+          <a:prstGeom prst="rect">
+            <a:avLst/>
+          </a:prstGeom>
+          <a:noFill/>
+        </p:spPr>
+        <p:txBody>
+          <a:bodyPr wrap="square" anchor="ctr">
+            <a:spAutoFit/>
+          </a:bodyPr>
+          <a:lstStyle/>
+          <a:p>
+            <a:pPr algn="r" a:rtl="1"/>
+            <a:r>
+              <a:rPr sz="1100" b="0">
+                <a:solidFill>
+                  <a:srgbClr val="64748B"/>
+                </a:solidFill>
+                <a:latin typeface="Tahoma"/>
+              </a:rPr>
+              <a:t>فرآیند AHP — از جمع‌آوری ماتریس تا محاسبه وزن نهایی</a:t>
+            </a:r>
+          </a:p>
+        </p:txBody>
+      </p:sp>
+      <p:sp>
+        <p:nvSpPr>
+          <p:cNvPr id="12" name="Right Arrow 11"/>
+          <p:cNvSpPr/>
+          <p:nvPr/>
+        </p:nvSpPr>
+        <p:spPr>
+          <a:xfrm rot="10800000">
+            <a:off x="6885432" y="2537460"/>
+            <a:ext cx="256032" cy="182880"/>
+          </a:xfrm>
+          <a:prstGeom prst="rightArrow">
+            <a:avLst/>
+          </a:prstGeom>
+          <a:solidFill>
+            <a:srgbClr val="475569"/>
+          </a:solidFill>
+          <a:ln>
+            <a:noFill/>
+          </a:ln>
+        </p:spPr>
+        <p:style>
+          <a:lnRef idx="1">
+            <a:schemeClr val="accent1"/>
+          </a:lnRef>
+          <a:fillRef idx="3">
+            <a:schemeClr val="accent1"/>
+          </a:fillRef>
+          <a:effectRef idx="2">
+            <a:schemeClr val="accent1"/>
+          </a:effectRef>
+          <a:fontRef idx="minor">
+            <a:schemeClr val="lt1"/>
+          </a:fontRef>
+        </p:style>
+        <p:txBody>
+          <a:bodyPr rtlCol="0" anchor="ctr"/>
+          <a:lstStyle/>
+          <a:p>
+            <a:pPr algn="ctr"/>
+          </a:p>
+        </p:txBody>
+      </p:sp>
+      <p:sp>
+        <p:nvSpPr>
+          <p:cNvPr id="13" name="Right Arrow 12"/>
+          <p:cNvSpPr/>
+          <p:nvPr/>
+        </p:nvSpPr>
+        <p:spPr>
+          <a:xfrm rot="10800000">
+            <a:off x="5513832" y="2537460"/>
+            <a:ext cx="256032" cy="182880"/>
+          </a:xfrm>
+          <a:prstGeom prst="rightArrow">
+            <a:avLst/>
+          </a:prstGeom>
+          <a:solidFill>
+            <a:srgbClr val="475569"/>
+          </a:solidFill>
+          <a:ln>
+            <a:noFill/>
+          </a:ln>
+        </p:spPr>
+        <p:style>
+          <a:lnRef idx="1">
+            <a:schemeClr val="accent1"/>
+          </a:lnRef>
+          <a:fillRef idx="3">
+            <a:schemeClr val="accent1"/>
+          </a:fillRef>
+          <a:effectRef idx="2">
+            <a:schemeClr val="accent1"/>
+          </a:effectRef>
+          <a:fontRef idx="minor">
+            <a:schemeClr val="lt1"/>
+          </a:fontRef>
+        </p:style>
+        <p:txBody>
+          <a:bodyPr rtlCol="0" anchor="ctr"/>
+          <a:lstStyle/>
+          <a:p>
+            <a:pPr algn="ctr"/>
+          </a:p>
+        </p:txBody>
+      </p:sp>
+      <p:sp>
+        <p:nvSpPr>
+          <p:cNvPr id="14" name="Right Arrow 13"/>
+          <p:cNvSpPr/>
+          <p:nvPr/>
+        </p:nvSpPr>
+        <p:spPr>
+          <a:xfrm rot="10800000">
+            <a:off x="4142232" y="2537460"/>
+            <a:ext cx="256032" cy="182880"/>
+          </a:xfrm>
+          <a:prstGeom prst="rightArrow">
+            <a:avLst/>
+          </a:prstGeom>
+          <a:solidFill>
+            <a:srgbClr val="475569"/>
+          </a:solidFill>
+          <a:ln>
+            <a:noFill/>
+          </a:ln>
+        </p:spPr>
+        <p:style>
+          <a:lnRef idx="1">
+            <a:schemeClr val="accent1"/>
+          </a:lnRef>
+          <a:fillRef idx="3">
+            <a:schemeClr val="accent1"/>
+          </a:fillRef>
+          <a:effectRef idx="2">
+            <a:schemeClr val="accent1"/>
+          </a:effectRef>
+          <a:fontRef idx="minor">
+            <a:schemeClr val="lt1"/>
+          </a:fontRef>
+        </p:style>
+        <p:txBody>
+          <a:bodyPr rtlCol="0" anchor="ctr"/>
+          <a:lstStyle/>
+          <a:p>
+            <a:pPr algn="ctr"/>
+          </a:p>
+        </p:txBody>
+      </p:sp>
+      <p:sp>
+        <p:nvSpPr>
+          <p:cNvPr id="15" name="Right Arrow 14"/>
+          <p:cNvSpPr/>
+          <p:nvPr/>
+        </p:nvSpPr>
+        <p:spPr>
+          <a:xfrm rot="10800000">
+            <a:off x="2770632" y="2537460"/>
+            <a:ext cx="256032" cy="182880"/>
+          </a:xfrm>
+          <a:prstGeom prst="rightArrow">
+            <a:avLst/>
+          </a:prstGeom>
+          <a:solidFill>
+            <a:srgbClr val="475569"/>
+          </a:solidFill>
+          <a:ln>
+            <a:noFill/>
+          </a:ln>
+        </p:spPr>
+        <p:style>
+          <a:lnRef idx="1">
+            <a:schemeClr val="accent1"/>
+          </a:lnRef>
+          <a:fillRef idx="3">
+            <a:schemeClr val="accent1"/>
+          </a:fillRef>
+          <a:effectRef idx="2">
+            <a:schemeClr val="accent1"/>
+          </a:effectRef>
+          <a:fontRef idx="minor">
+            <a:schemeClr val="lt1"/>
+          </a:fontRef>
+        </p:style>
+        <p:txBody>
+          <a:bodyPr rtlCol="0" anchor="ctr"/>
+          <a:lstStyle/>
+          <a:p>
+            <a:pPr algn="ctr"/>
+          </a:p>
+        </p:txBody>
+      </p:sp>
+      <p:sp>
+        <p:nvSpPr>
+          <p:cNvPr id="16" name="Right Arrow 15"/>
+          <p:cNvSpPr/>
+          <p:nvPr/>
+        </p:nvSpPr>
+        <p:spPr>
+          <a:xfrm rot="10800000">
+            <a:off x="1399032" y="2537460"/>
+            <a:ext cx="256032" cy="182880"/>
+          </a:xfrm>
+          <a:prstGeom prst="rightArrow">
+            <a:avLst/>
+          </a:prstGeom>
+          <a:solidFill>
+            <a:srgbClr val="475569"/>
+          </a:solidFill>
+          <a:ln>
+            <a:noFill/>
+          </a:ln>
+        </p:spPr>
+        <p:style>
+          <a:lnRef idx="1">
+            <a:schemeClr val="accent1"/>
+          </a:lnRef>
+          <a:fillRef idx="3">
+            <a:schemeClr val="accent1"/>
+          </a:fillRef>
+          <a:effectRef idx="2">
+            <a:schemeClr val="accent1"/>
+          </a:effectRef>
+          <a:fontRef idx="minor">
+            <a:schemeClr val="lt1"/>
+          </a:fontRef>
+        </p:style>
+        <p:txBody>
+          <a:bodyPr rtlCol="0" anchor="ctr"/>
+          <a:lstStyle/>
+          <a:p>
+            <a:pPr algn="ctr"/>
+          </a:p>
+        </p:txBody>
+      </p:sp>
+      <p:sp>
+        <p:nvSpPr>
+          <p:cNvPr id="17" name="Rounded Rectangle 16"/>
+          <p:cNvSpPr/>
+          <p:nvPr/>
+        </p:nvSpPr>
+        <p:spPr>
+          <a:xfrm>
+            <a:off x="7141464" y="2148840"/>
+            <a:ext cx="1115568" cy="960120"/>
+          </a:xfrm>
+          <a:prstGeom prst="roundRect">
+            <a:avLst>
+              <a:gd name="adj" fmla="val 12000"/>
+            </a:avLst>
+          </a:prstGeom>
+          <a:solidFill>
+            <a:srgbClr val="2563EB"/>
+          </a:solidFill>
+          <a:ln>
+            <a:noFill/>
+          </a:ln>
+        </p:spPr>
+        <p:style>
+          <a:lnRef idx="1">
+            <a:schemeClr val="accent1"/>
+          </a:lnRef>
+          <a:fillRef idx="3">
+            <a:schemeClr val="accent1"/>
+          </a:fillRef>
+          <a:effectRef idx="2">
+            <a:schemeClr val="accent1"/>
+          </a:effectRef>
+          <a:fontRef idx="minor">
+            <a:schemeClr val="lt1"/>
+          </a:fontRef>
+        </p:style>
+        <p:txBody>
+          <a:bodyPr rtlCol="0" anchor="ctr"/>
+          <a:lstStyle/>
+          <a:p>
+            <a:pPr algn="ctr"/>
+          </a:p>
+        </p:txBody>
+      </p:sp>
+      <p:sp>
+        <p:nvSpPr>
+          <p:cNvPr id="18" name="TextBox 17"/>
+          <p:cNvSpPr txBox="1"/>
+          <p:nvPr/>
+        </p:nvSpPr>
+        <p:spPr>
+          <a:xfrm>
+            <a:off x="7196328" y="2276856"/>
+            <a:ext cx="1005840" cy="310896"/>
+          </a:xfrm>
+          <a:prstGeom prst="rect">
+            <a:avLst/>
+          </a:prstGeom>
+          <a:noFill/>
+        </p:spPr>
+        <p:txBody>
+          <a:bodyPr wrap="square" anchor="ctr">
+            <a:spAutoFit/>
+          </a:bodyPr>
+          <a:lstStyle/>
+          <a:p>
+            <a:pPr algn="ctr" a:rtl="1"/>
+            <a:r>
+              <a:rPr sz="1100" b="1">
                 <a:solidFill>
                   <a:srgbClr val="FFFFFF"/>
                 </a:solidFill>
                 <a:latin typeface="Tahoma"/>
               </a:rPr>
-              <a:t>۱</a:t>
-            </a:r>
-          </a:p>
-        </p:txBody>
-      </p:sp>
-      <p:sp>
-        <p:nvSpPr>
-          <p:cNvPr id="15" name="Rounded Rectangle 14"/>
+              <a:t>گردآوری نظرات</a:t>
+            </a:r>
+          </a:p>
+        </p:txBody>
+      </p:sp>
+      <p:sp>
+        <p:nvSpPr>
+          <p:cNvPr id="19" name="TextBox 18"/>
+          <p:cNvSpPr txBox="1"/>
+          <p:nvPr/>
+        </p:nvSpPr>
+        <p:spPr>
+          <a:xfrm>
+            <a:off x="7196328" y="2587752"/>
+            <a:ext cx="1005840" cy="438912"/>
+          </a:xfrm>
+          <a:prstGeom prst="rect">
+            <a:avLst/>
+          </a:prstGeom>
+          <a:noFill/>
+        </p:spPr>
+        <p:txBody>
+          <a:bodyPr wrap="square" anchor="ctr">
+            <a:spAutoFit/>
+          </a:bodyPr>
+          <a:lstStyle/>
+          <a:p>
+            <a:pPr algn="ctr" a:rtl="1"/>
+            <a:r>
+              <a:rPr sz="800" b="0">
+                <a:solidFill>
+                  <a:srgbClr val="DBEAFE"/>
+                </a:solidFill>
+                <a:latin typeface="Tahoma"/>
+              </a:rPr>
+              <a:t>جمع‌آوری ماتریس‌های زوجی از خبرگان</a:t>
+            </a:r>
+          </a:p>
+        </p:txBody>
+      </p:sp>
+      <p:sp>
+        <p:nvSpPr>
+          <p:cNvPr id="20" name="Rounded Rectangle 19"/>
           <p:cNvSpPr/>
           <p:nvPr/>
         </p:nvSpPr>
         <p:spPr>
           <a:xfrm>
-            <a:off x="7808976" y="1408176"/>
-            <a:ext cx="1298448" cy="868680"/>
+            <a:off x="5769864" y="2148840"/>
+            <a:ext cx="1115568" cy="960120"/>
           </a:xfrm>
           <a:prstGeom prst="roundRect">
-            <a:avLst/>
+            <a:avLst>
+              <a:gd name="adj" fmla="val 12000"/>
+            </a:avLst>
           </a:prstGeom>
           <a:solidFill>
-            <a:srgbClr val="FFFFFF"/>
+            <a:srgbClr val="2563EB"/>
           </a:solidFill>
-          <a:ln w="12700">
-            <a:solidFill>
-              <a:srgbClr val="2B5C8A"/>
-            </a:solidFill>
+          <a:ln>
+            <a:noFill/>
           </a:ln>
         </p:spPr>
         <p:style>
@@ -3665,14 +3879,14 @@
       </p:sp>
       <p:sp>
         <p:nvSpPr>
-          <p:cNvPr id="16" name="TextBox 15"/>
+          <p:cNvPr id="21" name="TextBox 20"/>
           <p:cNvSpPr txBox="1"/>
           <p:nvPr/>
         </p:nvSpPr>
         <p:spPr>
           <a:xfrm>
-            <a:off x="7863840" y="1481328"/>
-            <a:ext cx="1188720" cy="274320"/>
+            <a:off x="5824728" y="2276856"/>
+            <a:ext cx="1005840" cy="310896"/>
           </a:xfrm>
           <a:prstGeom prst="rect">
             <a:avLst/>
@@ -3687,27 +3901,27 @@
           <a:p>
             <a:pPr algn="ctr" a:rtl="1"/>
             <a:r>
-              <a:rPr sz="1000" b="1">
+              <a:rPr sz="1100" b="1">
                 <a:solidFill>
-                  <a:srgbClr val="2D343E"/>
+                  <a:srgbClr val="FFFFFF"/>
                 </a:solidFill>
                 <a:latin typeface="Tahoma"/>
               </a:rPr>
-              <a:t>گردآوری نظرات خبرگان</a:t>
-            </a:r>
-          </a:p>
-        </p:txBody>
-      </p:sp>
-      <p:sp>
-        <p:nvSpPr>
-          <p:cNvPr id="17" name="TextBox 16"/>
+              <a:t>مقایسه زوجی</a:t>
+            </a:r>
+          </a:p>
+        </p:txBody>
+      </p:sp>
+      <p:sp>
+        <p:nvSpPr>
+          <p:cNvPr id="22" name="TextBox 21"/>
           <p:cNvSpPr txBox="1"/>
           <p:nvPr/>
         </p:nvSpPr>
         <p:spPr>
           <a:xfrm>
-            <a:off x="7863840" y="1755648"/>
-            <a:ext cx="1188720" cy="384048"/>
+            <a:off x="5824728" y="2587752"/>
+            <a:ext cx="1005840" cy="438912"/>
           </a:xfrm>
           <a:prstGeom prst="rect">
             <a:avLst/>
@@ -3722,33 +3936,35 @@
           <a:p>
             <a:pPr algn="ctr" a:rtl="1"/>
             <a:r>
-              <a:rPr sz="850" b="0">
+              <a:rPr sz="800" b="0">
                 <a:solidFill>
-                  <a:srgbClr val="6B7280"/>
+                  <a:srgbClr val="DBEAFE"/>
                 </a:solidFill>
                 <a:latin typeface="Tahoma"/>
               </a:rPr>
-              <a:t>جمع‌آوری ماتریس‌های مقایسه زوجی</a:t>
-            </a:r>
-          </a:p>
-        </p:txBody>
-      </p:sp>
-      <p:sp>
-        <p:nvSpPr>
-          <p:cNvPr id="18" name="Rectangle 17"/>
+              <a:t>با مقیاس ساعتی AHP (۱ تا ۹)</a:t>
+            </a:r>
+          </a:p>
+        </p:txBody>
+      </p:sp>
+      <p:sp>
+        <p:nvSpPr>
+          <p:cNvPr id="23" name="Rounded Rectangle 22"/>
           <p:cNvSpPr/>
           <p:nvPr/>
         </p:nvSpPr>
         <p:spPr>
           <a:xfrm>
-            <a:off x="8445500" y="2276856"/>
-            <a:ext cx="25400" cy="109728"/>
-          </a:xfrm>
-          <a:prstGeom prst="rect">
-            <a:avLst/>
+            <a:off x="4398264" y="2148840"/>
+            <a:ext cx="1115568" cy="960120"/>
+          </a:xfrm>
+          <a:prstGeom prst="roundRect">
+            <a:avLst>
+              <a:gd name="adj" fmla="val 12000"/>
+            </a:avLst>
           </a:prstGeom>
           <a:solidFill>
-            <a:srgbClr val="2B5C8A"/>
+            <a:srgbClr val="2563EB"/>
           </a:solidFill>
           <a:ln>
             <a:noFill/>
@@ -3778,25 +3994,95 @@
       </p:sp>
       <p:sp>
         <p:nvSpPr>
-          <p:cNvPr id="19" name="Oval 18"/>
+          <p:cNvPr id="24" name="TextBox 23"/>
+          <p:cNvSpPr txBox="1"/>
+          <p:nvPr/>
+        </p:nvSpPr>
+        <p:spPr>
+          <a:xfrm>
+            <a:off x="4453128" y="2276856"/>
+            <a:ext cx="1005840" cy="310896"/>
+          </a:xfrm>
+          <a:prstGeom prst="rect">
+            <a:avLst/>
+          </a:prstGeom>
+          <a:noFill/>
+        </p:spPr>
+        <p:txBody>
+          <a:bodyPr wrap="square" anchor="ctr">
+            <a:spAutoFit/>
+          </a:bodyPr>
+          <a:lstStyle/>
+          <a:p>
+            <a:pPr algn="ctr" a:rtl="1"/>
+            <a:r>
+              <a:rPr sz="1100" b="1">
+                <a:solidFill>
+                  <a:srgbClr val="FFFFFF"/>
+                </a:solidFill>
+                <a:latin typeface="Tahoma"/>
+              </a:rPr>
+              <a:t>بررسی سازگاری</a:t>
+            </a:r>
+          </a:p>
+        </p:txBody>
+      </p:sp>
+      <p:sp>
+        <p:nvSpPr>
+          <p:cNvPr id="25" name="TextBox 24"/>
+          <p:cNvSpPr txBox="1"/>
+          <p:nvPr/>
+        </p:nvSpPr>
+        <p:spPr>
+          <a:xfrm>
+            <a:off x="4453128" y="2587752"/>
+            <a:ext cx="1005840" cy="438912"/>
+          </a:xfrm>
+          <a:prstGeom prst="rect">
+            <a:avLst/>
+          </a:prstGeom>
+          <a:noFill/>
+        </p:spPr>
+        <p:txBody>
+          <a:bodyPr wrap="square" anchor="ctr">
+            <a:spAutoFit/>
+          </a:bodyPr>
+          <a:lstStyle/>
+          <a:p>
+            <a:pPr algn="ctr" a:rtl="1"/>
+            <a:r>
+              <a:rPr sz="800" b="0">
+                <a:solidFill>
+                  <a:srgbClr val="DBEAFE"/>
+                </a:solidFill>
+                <a:latin typeface="Tahoma"/>
+              </a:rPr>
+              <a:t>محاسبه CR برای هر خبره</a:t>
+            </a:r>
+          </a:p>
+        </p:txBody>
+      </p:sp>
+      <p:sp>
+        <p:nvSpPr>
+          <p:cNvPr id="26" name="Rounded Rectangle 25"/>
           <p:cNvSpPr/>
           <p:nvPr/>
         </p:nvSpPr>
         <p:spPr>
           <a:xfrm>
-            <a:off x="6592824" y="2386584"/>
-            <a:ext cx="621792" cy="621792"/>
-          </a:xfrm>
-          <a:prstGeom prst="ellipse">
-            <a:avLst/>
+            <a:off x="3026664" y="2148840"/>
+            <a:ext cx="1115568" cy="960120"/>
+          </a:xfrm>
+          <a:prstGeom prst="roundRect">
+            <a:avLst>
+              <a:gd name="adj" fmla="val 12000"/>
+            </a:avLst>
           </a:prstGeom>
           <a:solidFill>
-            <a:srgbClr val="E3F2FD"/>
+            <a:srgbClr val="2563EB"/>
           </a:solidFill>
-          <a:ln w="22860">
-            <a:solidFill>
-              <a:srgbClr val="2B5C8A"/>
-            </a:solidFill>
+          <a:ln>
+            <a:noFill/>
           </a:ln>
         </p:spPr>
         <p:style>
@@ -3823,20 +4109,92 @@
       </p:sp>
       <p:sp>
         <p:nvSpPr>
-          <p:cNvPr id="20" name="Oval 19"/>
+          <p:cNvPr id="27" name="TextBox 26"/>
+          <p:cNvSpPr txBox="1"/>
+          <p:nvPr/>
+        </p:nvSpPr>
+        <p:spPr>
+          <a:xfrm>
+            <a:off x="3081528" y="2276856"/>
+            <a:ext cx="1005840" cy="310896"/>
+          </a:xfrm>
+          <a:prstGeom prst="rect">
+            <a:avLst/>
+          </a:prstGeom>
+          <a:noFill/>
+        </p:spPr>
+        <p:txBody>
+          <a:bodyPr wrap="square" anchor="ctr">
+            <a:spAutoFit/>
+          </a:bodyPr>
+          <a:lstStyle/>
+          <a:p>
+            <a:pPr algn="ctr" a:rtl="1"/>
+            <a:r>
+              <a:rPr sz="1100" b="1">
+                <a:solidFill>
+                  <a:srgbClr val="FFFFFF"/>
+                </a:solidFill>
+                <a:latin typeface="Tahoma"/>
+              </a:rPr>
+              <a:t>پذیرش ماتریس</a:t>
+            </a:r>
+          </a:p>
+        </p:txBody>
+      </p:sp>
+      <p:sp>
+        <p:nvSpPr>
+          <p:cNvPr id="28" name="TextBox 27"/>
+          <p:cNvSpPr txBox="1"/>
+          <p:nvPr/>
+        </p:nvSpPr>
+        <p:spPr>
+          <a:xfrm>
+            <a:off x="3081528" y="2587752"/>
+            <a:ext cx="1005840" cy="438912"/>
+          </a:xfrm>
+          <a:prstGeom prst="rect">
+            <a:avLst/>
+          </a:prstGeom>
+          <a:noFill/>
+        </p:spPr>
+        <p:txBody>
+          <a:bodyPr wrap="square" anchor="ctr">
+            <a:spAutoFit/>
+          </a:bodyPr>
+          <a:lstStyle/>
+          <a:p>
+            <a:pPr algn="ctr" a:rtl="1"/>
+            <a:r>
+              <a:rPr sz="800" b="0">
+                <a:solidFill>
+                  <a:srgbClr val="DBEAFE"/>
+                </a:solidFill>
+                <a:latin typeface="Tahoma"/>
+              </a:rPr>
+              <a:t>فقط CR &lt; ۰٫۱ پذیرفته می‌شود</a:t>
+            </a:r>
+          </a:p>
+        </p:txBody>
+      </p:sp>
+      <p:sp>
+        <p:nvSpPr>
+          <p:cNvPr id="29" name="Rounded Rectangle 28"/>
           <p:cNvSpPr/>
           <p:nvPr/>
         </p:nvSpPr>
         <p:spPr>
           <a:xfrm>
-            <a:off x="6647688" y="2441448"/>
-            <a:ext cx="512064" cy="512064"/>
-          </a:xfrm>
-          <a:prstGeom prst="ellipse">
-            <a:avLst/>
+            <a:off x="1655064" y="2148840"/>
+            <a:ext cx="1115568" cy="960120"/>
+          </a:xfrm>
+          <a:prstGeom prst="roundRect">
+            <a:avLst>
+              <a:gd name="adj" fmla="val 12000"/>
+            </a:avLst>
           </a:prstGeom>
           <a:solidFill>
-            <a:srgbClr val="2B5C8A"/>
+            <a:srgbClr val="2563EB"/>
           </a:solidFill>
           <a:ln>
             <a:noFill/>
@@ -3861,39 +4219,100 @@
           <a:lstStyle/>
           <a:p>
             <a:pPr algn="ctr"/>
-            <a:r>
-              <a:rPr sz="1400" b="1">
+          </a:p>
+        </p:txBody>
+      </p:sp>
+      <p:sp>
+        <p:nvSpPr>
+          <p:cNvPr id="30" name="TextBox 29"/>
+          <p:cNvSpPr txBox="1"/>
+          <p:nvPr/>
+        </p:nvSpPr>
+        <p:spPr>
+          <a:xfrm>
+            <a:off x="1709928" y="2276856"/>
+            <a:ext cx="1005840" cy="310896"/>
+          </a:xfrm>
+          <a:prstGeom prst="rect">
+            <a:avLst/>
+          </a:prstGeom>
+          <a:noFill/>
+        </p:spPr>
+        <p:txBody>
+          <a:bodyPr wrap="square" anchor="ctr">
+            <a:spAutoFit/>
+          </a:bodyPr>
+          <a:lstStyle/>
+          <a:p>
+            <a:pPr algn="ctr" a:rtl="1"/>
+            <a:r>
+              <a:rPr sz="1100" b="1">
                 <a:solidFill>
                   <a:srgbClr val="FFFFFF"/>
                 </a:solidFill>
                 <a:latin typeface="Tahoma"/>
               </a:rPr>
-              <a:t>۲</a:t>
-            </a:r>
-          </a:p>
-        </p:txBody>
-      </p:sp>
-      <p:sp>
-        <p:nvSpPr>
-          <p:cNvPr id="21" name="Rounded Rectangle 20"/>
+              <a:t>میانگین هندسی</a:t>
+            </a:r>
+          </a:p>
+        </p:txBody>
+      </p:sp>
+      <p:sp>
+        <p:nvSpPr>
+          <p:cNvPr id="31" name="TextBox 30"/>
+          <p:cNvSpPr txBox="1"/>
+          <p:nvPr/>
+        </p:nvSpPr>
+        <p:spPr>
+          <a:xfrm>
+            <a:off x="1709928" y="2587752"/>
+            <a:ext cx="1005840" cy="438912"/>
+          </a:xfrm>
+          <a:prstGeom prst="rect">
+            <a:avLst/>
+          </a:prstGeom>
+          <a:noFill/>
+        </p:spPr>
+        <p:txBody>
+          <a:bodyPr wrap="square" anchor="ctr">
+            <a:spAutoFit/>
+          </a:bodyPr>
+          <a:lstStyle/>
+          <a:p>
+            <a:pPr algn="ctr" a:rtl="1"/>
+            <a:r>
+              <a:rPr sz="800" b="0">
+                <a:solidFill>
+                  <a:srgbClr val="DBEAFE"/>
+                </a:solidFill>
+                <a:latin typeface="Tahoma"/>
+              </a:rPr>
+              <a:t>تجمیع نظرات پذیرفته‌شده</a:t>
+            </a:r>
+          </a:p>
+        </p:txBody>
+      </p:sp>
+      <p:sp>
+        <p:nvSpPr>
+          <p:cNvPr id="32" name="Rounded Rectangle 31"/>
           <p:cNvSpPr/>
           <p:nvPr/>
         </p:nvSpPr>
         <p:spPr>
           <a:xfrm>
-            <a:off x="6254496" y="3118104"/>
-            <a:ext cx="1298448" cy="868680"/>
+            <a:off x="530352" y="2299716"/>
+            <a:ext cx="868680" cy="658368"/>
           </a:xfrm>
           <a:prstGeom prst="roundRect">
-            <a:avLst/>
+            <a:avLst>
+              <a:gd name="adj" fmla="val 12000"/>
+            </a:avLst>
           </a:prstGeom>
           <a:solidFill>
-            <a:srgbClr val="FFFFFF"/>
+            <a:srgbClr val="1D4ED8"/>
           </a:solidFill>
-          <a:ln w="12700">
-            <a:solidFill>
-              <a:srgbClr val="2B5C8A"/>
-            </a:solidFill>
+          <a:ln>
+            <a:noFill/>
           </a:ln>
         </p:spPr>
         <p:style>
@@ -3920,1088 +4339,14 @@
       </p:sp>
       <p:sp>
         <p:nvSpPr>
-          <p:cNvPr id="22" name="TextBox 21"/>
+          <p:cNvPr id="33" name="TextBox 32"/>
           <p:cNvSpPr txBox="1"/>
           <p:nvPr/>
         </p:nvSpPr>
         <p:spPr>
           <a:xfrm>
-            <a:off x="6309360" y="3191256"/>
-            <a:ext cx="1188720" cy="274320"/>
-          </a:xfrm>
-          <a:prstGeom prst="rect">
-            <a:avLst/>
-          </a:prstGeom>
-          <a:noFill/>
-        </p:spPr>
-        <p:txBody>
-          <a:bodyPr wrap="square" anchor="ctr">
-            <a:spAutoFit/>
-          </a:bodyPr>
-          <a:lstStyle/>
-          <a:p>
-            <a:pPr algn="ctr" a:rtl="1"/>
-            <a:r>
-              <a:rPr sz="1000" b="1">
-                <a:solidFill>
-                  <a:srgbClr val="2D343E"/>
-                </a:solidFill>
-                <a:latin typeface="Tahoma"/>
-              </a:rPr>
-              <a:t>مقایسه‌های زوجی</a:t>
-            </a:r>
-          </a:p>
-        </p:txBody>
-      </p:sp>
-      <p:sp>
-        <p:nvSpPr>
-          <p:cNvPr id="23" name="TextBox 22"/>
-          <p:cNvSpPr txBox="1"/>
-          <p:nvPr/>
-        </p:nvSpPr>
-        <p:spPr>
-          <a:xfrm>
-            <a:off x="6309360" y="3465576"/>
-            <a:ext cx="1188720" cy="384048"/>
-          </a:xfrm>
-          <a:prstGeom prst="rect">
-            <a:avLst/>
-          </a:prstGeom>
-          <a:noFill/>
-        </p:spPr>
-        <p:txBody>
-          <a:bodyPr wrap="square" anchor="ctr">
-            <a:spAutoFit/>
-          </a:bodyPr>
-          <a:lstStyle/>
-          <a:p>
-            <a:pPr algn="ctr" a:rtl="1"/>
-            <a:r>
-              <a:rPr sz="850" b="0">
-                <a:solidFill>
-                  <a:srgbClr val="6B7280"/>
-                </a:solidFill>
-                <a:latin typeface="Tahoma"/>
-              </a:rPr>
-              <a:t>با مقیاس ساعتی AHP (۱ تا ۹)</a:t>
-            </a:r>
-          </a:p>
-        </p:txBody>
-      </p:sp>
-      <p:sp>
-        <p:nvSpPr>
-          <p:cNvPr id="24" name="Rectangle 23"/>
-          <p:cNvSpPr/>
-          <p:nvPr/>
-        </p:nvSpPr>
-        <p:spPr>
-          <a:xfrm>
-            <a:off x="6891020" y="3008376"/>
-            <a:ext cx="25400" cy="109728"/>
-          </a:xfrm>
-          <a:prstGeom prst="rect">
-            <a:avLst/>
-          </a:prstGeom>
-          <a:solidFill>
-            <a:srgbClr val="2B5C8A"/>
-          </a:solidFill>
-          <a:ln>
-            <a:noFill/>
-          </a:ln>
-        </p:spPr>
-        <p:style>
-          <a:lnRef idx="1">
-            <a:schemeClr val="accent1"/>
-          </a:lnRef>
-          <a:fillRef idx="3">
-            <a:schemeClr val="accent1"/>
-          </a:fillRef>
-          <a:effectRef idx="2">
-            <a:schemeClr val="accent1"/>
-          </a:effectRef>
-          <a:fontRef idx="minor">
-            <a:schemeClr val="lt1"/>
-          </a:fontRef>
-        </p:style>
-        <p:txBody>
-          <a:bodyPr rtlCol="0" anchor="ctr"/>
-          <a:lstStyle/>
-          <a:p>
-            <a:pPr algn="ctr"/>
-          </a:p>
-        </p:txBody>
-      </p:sp>
-      <p:sp>
-        <p:nvSpPr>
-          <p:cNvPr id="25" name="Oval 24"/>
-          <p:cNvSpPr/>
-          <p:nvPr/>
-        </p:nvSpPr>
-        <p:spPr>
-          <a:xfrm>
-            <a:off x="5038344" y="2386584"/>
-            <a:ext cx="621792" cy="621792"/>
-          </a:xfrm>
-          <a:prstGeom prst="ellipse">
-            <a:avLst/>
-          </a:prstGeom>
-          <a:solidFill>
-            <a:srgbClr val="E0F2F1"/>
-          </a:solidFill>
-          <a:ln w="22860">
-            <a:solidFill>
-              <a:srgbClr val="009688"/>
-            </a:solidFill>
-          </a:ln>
-        </p:spPr>
-        <p:style>
-          <a:lnRef idx="1">
-            <a:schemeClr val="accent1"/>
-          </a:lnRef>
-          <a:fillRef idx="3">
-            <a:schemeClr val="accent1"/>
-          </a:fillRef>
-          <a:effectRef idx="2">
-            <a:schemeClr val="accent1"/>
-          </a:effectRef>
-          <a:fontRef idx="minor">
-            <a:schemeClr val="lt1"/>
-          </a:fontRef>
-        </p:style>
-        <p:txBody>
-          <a:bodyPr rtlCol="0" anchor="ctr"/>
-          <a:lstStyle/>
-          <a:p>
-            <a:pPr algn="ctr"/>
-          </a:p>
-        </p:txBody>
-      </p:sp>
-      <p:sp>
-        <p:nvSpPr>
-          <p:cNvPr id="26" name="Oval 25"/>
-          <p:cNvSpPr/>
-          <p:nvPr/>
-        </p:nvSpPr>
-        <p:spPr>
-          <a:xfrm>
-            <a:off x="5093208" y="2441448"/>
-            <a:ext cx="512064" cy="512064"/>
-          </a:xfrm>
-          <a:prstGeom prst="ellipse">
-            <a:avLst/>
-          </a:prstGeom>
-          <a:solidFill>
-            <a:srgbClr val="009688"/>
-          </a:solidFill>
-          <a:ln>
-            <a:noFill/>
-          </a:ln>
-        </p:spPr>
-        <p:style>
-          <a:lnRef idx="1">
-            <a:schemeClr val="accent1"/>
-          </a:lnRef>
-          <a:fillRef idx="3">
-            <a:schemeClr val="accent1"/>
-          </a:fillRef>
-          <a:effectRef idx="2">
-            <a:schemeClr val="accent1"/>
-          </a:effectRef>
-          <a:fontRef idx="minor">
-            <a:schemeClr val="lt1"/>
-          </a:fontRef>
-        </p:style>
-        <p:txBody>
-          <a:bodyPr rtlCol="0" anchor="ctr"/>
-          <a:lstStyle/>
-          <a:p>
-            <a:pPr algn="ctr"/>
-            <a:r>
-              <a:rPr sz="1400" b="1">
-                <a:solidFill>
-                  <a:srgbClr val="FFFFFF"/>
-                </a:solidFill>
-                <a:latin typeface="Tahoma"/>
-              </a:rPr>
-              <a:t>۳</a:t>
-            </a:r>
-          </a:p>
-        </p:txBody>
-      </p:sp>
-      <p:sp>
-        <p:nvSpPr>
-          <p:cNvPr id="27" name="Rounded Rectangle 26"/>
-          <p:cNvSpPr/>
-          <p:nvPr/>
-        </p:nvSpPr>
-        <p:spPr>
-          <a:xfrm>
-            <a:off x="4700016" y="1408176"/>
-            <a:ext cx="1298448" cy="868680"/>
-          </a:xfrm>
-          <a:prstGeom prst="roundRect">
-            <a:avLst/>
-          </a:prstGeom>
-          <a:solidFill>
-            <a:srgbClr val="FFFFFF"/>
-          </a:solidFill>
-          <a:ln w="12700">
-            <a:solidFill>
-              <a:srgbClr val="009688"/>
-            </a:solidFill>
-          </a:ln>
-        </p:spPr>
-        <p:style>
-          <a:lnRef idx="1">
-            <a:schemeClr val="accent1"/>
-          </a:lnRef>
-          <a:fillRef idx="3">
-            <a:schemeClr val="accent1"/>
-          </a:fillRef>
-          <a:effectRef idx="2">
-            <a:schemeClr val="accent1"/>
-          </a:effectRef>
-          <a:fontRef idx="minor">
-            <a:schemeClr val="lt1"/>
-          </a:fontRef>
-        </p:style>
-        <p:txBody>
-          <a:bodyPr rtlCol="0" anchor="ctr"/>
-          <a:lstStyle/>
-          <a:p>
-            <a:pPr algn="ctr"/>
-          </a:p>
-        </p:txBody>
-      </p:sp>
-      <p:sp>
-        <p:nvSpPr>
-          <p:cNvPr id="28" name="TextBox 27"/>
-          <p:cNvSpPr txBox="1"/>
-          <p:nvPr/>
-        </p:nvSpPr>
-        <p:spPr>
-          <a:xfrm>
-            <a:off x="4754880" y="1481328"/>
-            <a:ext cx="1188720" cy="274320"/>
-          </a:xfrm>
-          <a:prstGeom prst="rect">
-            <a:avLst/>
-          </a:prstGeom>
-          <a:noFill/>
-        </p:spPr>
-        <p:txBody>
-          <a:bodyPr wrap="square" anchor="ctr">
-            <a:spAutoFit/>
-          </a:bodyPr>
-          <a:lstStyle/>
-          <a:p>
-            <a:pPr algn="ctr" a:rtl="1"/>
-            <a:r>
-              <a:rPr sz="1000" b="1">
-                <a:solidFill>
-                  <a:srgbClr val="2D343E"/>
-                </a:solidFill>
-                <a:latin typeface="Tahoma"/>
-              </a:rPr>
-              <a:t>بررسی سازگاری</a:t>
-            </a:r>
-          </a:p>
-        </p:txBody>
-      </p:sp>
-      <p:sp>
-        <p:nvSpPr>
-          <p:cNvPr id="29" name="TextBox 28"/>
-          <p:cNvSpPr txBox="1"/>
-          <p:nvPr/>
-        </p:nvSpPr>
-        <p:spPr>
-          <a:xfrm>
-            <a:off x="4754880" y="1755648"/>
-            <a:ext cx="1188720" cy="384048"/>
-          </a:xfrm>
-          <a:prstGeom prst="rect">
-            <a:avLst/>
-          </a:prstGeom>
-          <a:noFill/>
-        </p:spPr>
-        <p:txBody>
-          <a:bodyPr wrap="square" anchor="ctr">
-            <a:spAutoFit/>
-          </a:bodyPr>
-          <a:lstStyle/>
-          <a:p>
-            <a:pPr algn="ctr" a:rtl="1"/>
-            <a:r>
-              <a:rPr sz="850" b="0">
-                <a:solidFill>
-                  <a:srgbClr val="6B7280"/>
-                </a:solidFill>
-                <a:latin typeface="Tahoma"/>
-              </a:rPr>
-              <a:t>محاسبه CR برای هر خبره</a:t>
-            </a:r>
-          </a:p>
-        </p:txBody>
-      </p:sp>
-      <p:sp>
-        <p:nvSpPr>
-          <p:cNvPr id="30" name="Rectangle 29"/>
-          <p:cNvSpPr/>
-          <p:nvPr/>
-        </p:nvSpPr>
-        <p:spPr>
-          <a:xfrm>
-            <a:off x="5336540" y="2276856"/>
-            <a:ext cx="25400" cy="109728"/>
-          </a:xfrm>
-          <a:prstGeom prst="rect">
-            <a:avLst/>
-          </a:prstGeom>
-          <a:solidFill>
-            <a:srgbClr val="009688"/>
-          </a:solidFill>
-          <a:ln>
-            <a:noFill/>
-          </a:ln>
-        </p:spPr>
-        <p:style>
-          <a:lnRef idx="1">
-            <a:schemeClr val="accent1"/>
-          </a:lnRef>
-          <a:fillRef idx="3">
-            <a:schemeClr val="accent1"/>
-          </a:fillRef>
-          <a:effectRef idx="2">
-            <a:schemeClr val="accent1"/>
-          </a:effectRef>
-          <a:fontRef idx="minor">
-            <a:schemeClr val="lt1"/>
-          </a:fontRef>
-        </p:style>
-        <p:txBody>
-          <a:bodyPr rtlCol="0" anchor="ctr"/>
-          <a:lstStyle/>
-          <a:p>
-            <a:pPr algn="ctr"/>
-          </a:p>
-        </p:txBody>
-      </p:sp>
-      <p:sp>
-        <p:nvSpPr>
-          <p:cNvPr id="31" name="Oval 30"/>
-          <p:cNvSpPr/>
-          <p:nvPr/>
-        </p:nvSpPr>
-        <p:spPr>
-          <a:xfrm>
-            <a:off x="3483864" y="2386584"/>
-            <a:ext cx="621792" cy="621792"/>
-          </a:xfrm>
-          <a:prstGeom prst="ellipse">
-            <a:avLst/>
-          </a:prstGeom>
-          <a:solidFill>
-            <a:srgbClr val="E8F5E9"/>
-          </a:solidFill>
-          <a:ln w="22860">
-            <a:solidFill>
-              <a:srgbClr val="2E7D32"/>
-            </a:solidFill>
-          </a:ln>
-        </p:spPr>
-        <p:style>
-          <a:lnRef idx="1">
-            <a:schemeClr val="accent1"/>
-          </a:lnRef>
-          <a:fillRef idx="3">
-            <a:schemeClr val="accent1"/>
-          </a:fillRef>
-          <a:effectRef idx="2">
-            <a:schemeClr val="accent1"/>
-          </a:effectRef>
-          <a:fontRef idx="minor">
-            <a:schemeClr val="lt1"/>
-          </a:fontRef>
-        </p:style>
-        <p:txBody>
-          <a:bodyPr rtlCol="0" anchor="ctr"/>
-          <a:lstStyle/>
-          <a:p>
-            <a:pPr algn="ctr"/>
-          </a:p>
-        </p:txBody>
-      </p:sp>
-      <p:sp>
-        <p:nvSpPr>
-          <p:cNvPr id="32" name="Oval 31"/>
-          <p:cNvSpPr/>
-          <p:nvPr/>
-        </p:nvSpPr>
-        <p:spPr>
-          <a:xfrm>
-            <a:off x="3538728" y="2441448"/>
-            <a:ext cx="512064" cy="512064"/>
-          </a:xfrm>
-          <a:prstGeom prst="ellipse">
-            <a:avLst/>
-          </a:prstGeom>
-          <a:solidFill>
-            <a:srgbClr val="2E7D32"/>
-          </a:solidFill>
-          <a:ln>
-            <a:noFill/>
-          </a:ln>
-        </p:spPr>
-        <p:style>
-          <a:lnRef idx="1">
-            <a:schemeClr val="accent1"/>
-          </a:lnRef>
-          <a:fillRef idx="3">
-            <a:schemeClr val="accent1"/>
-          </a:fillRef>
-          <a:effectRef idx="2">
-            <a:schemeClr val="accent1"/>
-          </a:effectRef>
-          <a:fontRef idx="minor">
-            <a:schemeClr val="lt1"/>
-          </a:fontRef>
-        </p:style>
-        <p:txBody>
-          <a:bodyPr rtlCol="0" anchor="ctr"/>
-          <a:lstStyle/>
-          <a:p>
-            <a:pPr algn="ctr"/>
-            <a:r>
-              <a:rPr sz="1400" b="1">
-                <a:solidFill>
-                  <a:srgbClr val="FFFFFF"/>
-                </a:solidFill>
-                <a:latin typeface="Tahoma"/>
-              </a:rPr>
-              <a:t>۴</a:t>
-            </a:r>
-          </a:p>
-        </p:txBody>
-      </p:sp>
-      <p:sp>
-        <p:nvSpPr>
-          <p:cNvPr id="33" name="Rounded Rectangle 32"/>
-          <p:cNvSpPr/>
-          <p:nvPr/>
-        </p:nvSpPr>
-        <p:spPr>
-          <a:xfrm>
-            <a:off x="3145536" y="3118104"/>
-            <a:ext cx="1298448" cy="868680"/>
-          </a:xfrm>
-          <a:prstGeom prst="roundRect">
-            <a:avLst/>
-          </a:prstGeom>
-          <a:solidFill>
-            <a:srgbClr val="FFFFFF"/>
-          </a:solidFill>
-          <a:ln w="12700">
-            <a:solidFill>
-              <a:srgbClr val="2E7D32"/>
-            </a:solidFill>
-          </a:ln>
-        </p:spPr>
-        <p:style>
-          <a:lnRef idx="1">
-            <a:schemeClr val="accent1"/>
-          </a:lnRef>
-          <a:fillRef idx="3">
-            <a:schemeClr val="accent1"/>
-          </a:fillRef>
-          <a:effectRef idx="2">
-            <a:schemeClr val="accent1"/>
-          </a:effectRef>
-          <a:fontRef idx="minor">
-            <a:schemeClr val="lt1"/>
-          </a:fontRef>
-        </p:style>
-        <p:txBody>
-          <a:bodyPr rtlCol="0" anchor="ctr"/>
-          <a:lstStyle/>
-          <a:p>
-            <a:pPr algn="ctr"/>
-          </a:p>
-        </p:txBody>
-      </p:sp>
-      <p:sp>
-        <p:nvSpPr>
-          <p:cNvPr id="34" name="TextBox 33"/>
-          <p:cNvSpPr txBox="1"/>
-          <p:nvPr/>
-        </p:nvSpPr>
-        <p:spPr>
-          <a:xfrm>
-            <a:off x="3200400" y="3191256"/>
-            <a:ext cx="1188720" cy="274320"/>
-          </a:xfrm>
-          <a:prstGeom prst="rect">
-            <a:avLst/>
-          </a:prstGeom>
-          <a:noFill/>
-        </p:spPr>
-        <p:txBody>
-          <a:bodyPr wrap="square" anchor="ctr">
-            <a:spAutoFit/>
-          </a:bodyPr>
-          <a:lstStyle/>
-          <a:p>
-            <a:pPr algn="ctr" a:rtl="1"/>
-            <a:r>
-              <a:rPr sz="1000" b="1">
-                <a:solidFill>
-                  <a:srgbClr val="2D343E"/>
-                </a:solidFill>
-                <a:latin typeface="Tahoma"/>
-              </a:rPr>
-              <a:t>پذیرش ماتریس‌ها</a:t>
-            </a:r>
-          </a:p>
-        </p:txBody>
-      </p:sp>
-      <p:sp>
-        <p:nvSpPr>
-          <p:cNvPr id="35" name="TextBox 34"/>
-          <p:cNvSpPr txBox="1"/>
-          <p:nvPr/>
-        </p:nvSpPr>
-        <p:spPr>
-          <a:xfrm>
-            <a:off x="3200400" y="3465576"/>
-            <a:ext cx="1188720" cy="384048"/>
-          </a:xfrm>
-          <a:prstGeom prst="rect">
-            <a:avLst/>
-          </a:prstGeom>
-          <a:noFill/>
-        </p:spPr>
-        <p:txBody>
-          <a:bodyPr wrap="square" anchor="ctr">
-            <a:spAutoFit/>
-          </a:bodyPr>
-          <a:lstStyle/>
-          <a:p>
-            <a:pPr algn="ctr" a:rtl="1"/>
-            <a:r>
-              <a:rPr sz="850" b="0">
-                <a:solidFill>
-                  <a:srgbClr val="6B7280"/>
-                </a:solidFill>
-                <a:latin typeface="Tahoma"/>
-              </a:rPr>
-              <a:t>فقط CR &lt; ۰٫۱ پذیرفته می‌شود</a:t>
-            </a:r>
-          </a:p>
-        </p:txBody>
-      </p:sp>
-      <p:sp>
-        <p:nvSpPr>
-          <p:cNvPr id="36" name="Rounded Rectangle 35"/>
-          <p:cNvSpPr/>
-          <p:nvPr/>
-        </p:nvSpPr>
-        <p:spPr>
-          <a:xfrm>
-            <a:off x="3328416" y="3785616"/>
-            <a:ext cx="914400" cy="164592"/>
-          </a:xfrm>
-          <a:prstGeom prst="roundRect">
-            <a:avLst/>
-          </a:prstGeom>
-          <a:solidFill>
-            <a:srgbClr val="E8F5E9"/>
-          </a:solidFill>
-          <a:ln w="12700">
-            <a:solidFill>
-              <a:srgbClr val="2E7D32"/>
-            </a:solidFill>
-          </a:ln>
-        </p:spPr>
-        <p:style>
-          <a:lnRef idx="1">
-            <a:schemeClr val="accent1"/>
-          </a:lnRef>
-          <a:fillRef idx="3">
-            <a:schemeClr val="accent1"/>
-          </a:fillRef>
-          <a:effectRef idx="2">
-            <a:schemeClr val="accent1"/>
-          </a:effectRef>
-          <a:fontRef idx="minor">
-            <a:schemeClr val="lt1"/>
-          </a:fontRef>
-        </p:style>
-        <p:txBody>
-          <a:bodyPr rtlCol="0" anchor="ctr"/>
-          <a:lstStyle/>
-          <a:p>
-            <a:pPr algn="ctr"/>
-            <a:r>
-              <a:rPr sz="750" b="1">
-                <a:solidFill>
-                  <a:srgbClr val="1B5E20"/>
-                </a:solidFill>
-                <a:latin typeface="Tahoma"/>
-              </a:rPr>
-              <a:t>CR &lt; 0.1</a:t>
-            </a:r>
-          </a:p>
-        </p:txBody>
-      </p:sp>
-      <p:sp>
-        <p:nvSpPr>
-          <p:cNvPr id="37" name="Rectangle 36"/>
-          <p:cNvSpPr/>
-          <p:nvPr/>
-        </p:nvSpPr>
-        <p:spPr>
-          <a:xfrm>
-            <a:off x="3782060" y="3008376"/>
-            <a:ext cx="25400" cy="109728"/>
-          </a:xfrm>
-          <a:prstGeom prst="rect">
-            <a:avLst/>
-          </a:prstGeom>
-          <a:solidFill>
-            <a:srgbClr val="2E7D32"/>
-          </a:solidFill>
-          <a:ln>
-            <a:noFill/>
-          </a:ln>
-        </p:spPr>
-        <p:style>
-          <a:lnRef idx="1">
-            <a:schemeClr val="accent1"/>
-          </a:lnRef>
-          <a:fillRef idx="3">
-            <a:schemeClr val="accent1"/>
-          </a:fillRef>
-          <a:effectRef idx="2">
-            <a:schemeClr val="accent1"/>
-          </a:effectRef>
-          <a:fontRef idx="minor">
-            <a:schemeClr val="lt1"/>
-          </a:fontRef>
-        </p:style>
-        <p:txBody>
-          <a:bodyPr rtlCol="0" anchor="ctr"/>
-          <a:lstStyle/>
-          <a:p>
-            <a:pPr algn="ctr"/>
-          </a:p>
-        </p:txBody>
-      </p:sp>
-      <p:sp>
-        <p:nvSpPr>
-          <p:cNvPr id="38" name="Oval 37"/>
-          <p:cNvSpPr/>
-          <p:nvPr/>
-        </p:nvSpPr>
-        <p:spPr>
-          <a:xfrm>
-            <a:off x="1929384" y="2386584"/>
-            <a:ext cx="621792" cy="621792"/>
-          </a:xfrm>
-          <a:prstGeom prst="ellipse">
-            <a:avLst/>
-          </a:prstGeom>
-          <a:solidFill>
-            <a:srgbClr val="E3F2FD"/>
-          </a:solidFill>
-          <a:ln w="22860">
-            <a:solidFill>
-              <a:srgbClr val="2B5C8A"/>
-            </a:solidFill>
-          </a:ln>
-        </p:spPr>
-        <p:style>
-          <a:lnRef idx="1">
-            <a:schemeClr val="accent1"/>
-          </a:lnRef>
-          <a:fillRef idx="3">
-            <a:schemeClr val="accent1"/>
-          </a:fillRef>
-          <a:effectRef idx="2">
-            <a:schemeClr val="accent1"/>
-          </a:effectRef>
-          <a:fontRef idx="minor">
-            <a:schemeClr val="lt1"/>
-          </a:fontRef>
-        </p:style>
-        <p:txBody>
-          <a:bodyPr rtlCol="0" anchor="ctr"/>
-          <a:lstStyle/>
-          <a:p>
-            <a:pPr algn="ctr"/>
-          </a:p>
-        </p:txBody>
-      </p:sp>
-      <p:sp>
-        <p:nvSpPr>
-          <p:cNvPr id="39" name="Oval 38"/>
-          <p:cNvSpPr/>
-          <p:nvPr/>
-        </p:nvSpPr>
-        <p:spPr>
-          <a:xfrm>
-            <a:off x="1984248" y="2441448"/>
-            <a:ext cx="512064" cy="512064"/>
-          </a:xfrm>
-          <a:prstGeom prst="ellipse">
-            <a:avLst/>
-          </a:prstGeom>
-          <a:solidFill>
-            <a:srgbClr val="2B5C8A"/>
-          </a:solidFill>
-          <a:ln>
-            <a:noFill/>
-          </a:ln>
-        </p:spPr>
-        <p:style>
-          <a:lnRef idx="1">
-            <a:schemeClr val="accent1"/>
-          </a:lnRef>
-          <a:fillRef idx="3">
-            <a:schemeClr val="accent1"/>
-          </a:fillRef>
-          <a:effectRef idx="2">
-            <a:schemeClr val="accent1"/>
-          </a:effectRef>
-          <a:fontRef idx="minor">
-            <a:schemeClr val="lt1"/>
-          </a:fontRef>
-        </p:style>
-        <p:txBody>
-          <a:bodyPr rtlCol="0" anchor="ctr"/>
-          <a:lstStyle/>
-          <a:p>
-            <a:pPr algn="ctr"/>
-            <a:r>
-              <a:rPr sz="1400" b="1">
-                <a:solidFill>
-                  <a:srgbClr val="FFFFFF"/>
-                </a:solidFill>
-                <a:latin typeface="Tahoma"/>
-              </a:rPr>
-              <a:t>۵</a:t>
-            </a:r>
-          </a:p>
-        </p:txBody>
-      </p:sp>
-      <p:sp>
-        <p:nvSpPr>
-          <p:cNvPr id="40" name="Rounded Rectangle 39"/>
-          <p:cNvSpPr/>
-          <p:nvPr/>
-        </p:nvSpPr>
-        <p:spPr>
-          <a:xfrm>
-            <a:off x="1591056" y="1408176"/>
-            <a:ext cx="1298448" cy="868680"/>
-          </a:xfrm>
-          <a:prstGeom prst="roundRect">
-            <a:avLst/>
-          </a:prstGeom>
-          <a:solidFill>
-            <a:srgbClr val="FFFFFF"/>
-          </a:solidFill>
-          <a:ln w="12700">
-            <a:solidFill>
-              <a:srgbClr val="2B5C8A"/>
-            </a:solidFill>
-          </a:ln>
-        </p:spPr>
-        <p:style>
-          <a:lnRef idx="1">
-            <a:schemeClr val="accent1"/>
-          </a:lnRef>
-          <a:fillRef idx="3">
-            <a:schemeClr val="accent1"/>
-          </a:fillRef>
-          <a:effectRef idx="2">
-            <a:schemeClr val="accent1"/>
-          </a:effectRef>
-          <a:fontRef idx="minor">
-            <a:schemeClr val="lt1"/>
-          </a:fontRef>
-        </p:style>
-        <p:txBody>
-          <a:bodyPr rtlCol="0" anchor="ctr"/>
-          <a:lstStyle/>
-          <a:p>
-            <a:pPr algn="ctr"/>
-          </a:p>
-        </p:txBody>
-      </p:sp>
-      <p:sp>
-        <p:nvSpPr>
-          <p:cNvPr id="41" name="TextBox 40"/>
-          <p:cNvSpPr txBox="1"/>
-          <p:nvPr/>
-        </p:nvSpPr>
-        <p:spPr>
-          <a:xfrm>
-            <a:off x="1645920" y="1481328"/>
-            <a:ext cx="1188720" cy="274320"/>
-          </a:xfrm>
-          <a:prstGeom prst="rect">
-            <a:avLst/>
-          </a:prstGeom>
-          <a:noFill/>
-        </p:spPr>
-        <p:txBody>
-          <a:bodyPr wrap="square" anchor="ctr">
-            <a:spAutoFit/>
-          </a:bodyPr>
-          <a:lstStyle/>
-          <a:p>
-            <a:pPr algn="ctr" a:rtl="1"/>
-            <a:r>
-              <a:rPr sz="1000" b="1">
-                <a:solidFill>
-                  <a:srgbClr val="2D343E"/>
-                </a:solidFill>
-                <a:latin typeface="Tahoma"/>
-              </a:rPr>
-              <a:t>میانگین هندسی</a:t>
-            </a:r>
-          </a:p>
-        </p:txBody>
-      </p:sp>
-      <p:sp>
-        <p:nvSpPr>
-          <p:cNvPr id="42" name="TextBox 41"/>
-          <p:cNvSpPr txBox="1"/>
-          <p:nvPr/>
-        </p:nvSpPr>
-        <p:spPr>
-          <a:xfrm>
-            <a:off x="1645920" y="1755648"/>
-            <a:ext cx="1188720" cy="384048"/>
-          </a:xfrm>
-          <a:prstGeom prst="rect">
-            <a:avLst/>
-          </a:prstGeom>
-          <a:noFill/>
-        </p:spPr>
-        <p:txBody>
-          <a:bodyPr wrap="square" anchor="ctr">
-            <a:spAutoFit/>
-          </a:bodyPr>
-          <a:lstStyle/>
-          <a:p>
-            <a:pPr algn="ctr" a:rtl="1"/>
-            <a:r>
-              <a:rPr sz="850" b="0">
-                <a:solidFill>
-                  <a:srgbClr val="6B7280"/>
-                </a:solidFill>
-                <a:latin typeface="Tahoma"/>
-              </a:rPr>
-              <a:t>تجمیع نظرات پذیرفته‌شده</a:t>
-            </a:r>
-          </a:p>
-        </p:txBody>
-      </p:sp>
-      <p:sp>
-        <p:nvSpPr>
-          <p:cNvPr id="43" name="Rectangle 42"/>
-          <p:cNvSpPr/>
-          <p:nvPr/>
-        </p:nvSpPr>
-        <p:spPr>
-          <a:xfrm>
-            <a:off x="2227580" y="2276856"/>
-            <a:ext cx="25400" cy="109728"/>
-          </a:xfrm>
-          <a:prstGeom prst="rect">
-            <a:avLst/>
-          </a:prstGeom>
-          <a:solidFill>
-            <a:srgbClr val="2B5C8A"/>
-          </a:solidFill>
-          <a:ln>
-            <a:noFill/>
-          </a:ln>
-        </p:spPr>
-        <p:style>
-          <a:lnRef idx="1">
-            <a:schemeClr val="accent1"/>
-          </a:lnRef>
-          <a:fillRef idx="3">
-            <a:schemeClr val="accent1"/>
-          </a:fillRef>
-          <a:effectRef idx="2">
-            <a:schemeClr val="accent1"/>
-          </a:effectRef>
-          <a:fontRef idx="minor">
-            <a:schemeClr val="lt1"/>
-          </a:fontRef>
-        </p:style>
-        <p:txBody>
-          <a:bodyPr rtlCol="0" anchor="ctr"/>
-          <a:lstStyle/>
-          <a:p>
-            <a:pPr algn="ctr"/>
-          </a:p>
-        </p:txBody>
-      </p:sp>
-      <p:sp>
-        <p:nvSpPr>
-          <p:cNvPr id="44" name="Oval 43"/>
-          <p:cNvSpPr/>
-          <p:nvPr/>
-        </p:nvSpPr>
-        <p:spPr>
-          <a:xfrm>
-            <a:off x="374904" y="2386584"/>
-            <a:ext cx="621792" cy="621792"/>
-          </a:xfrm>
-          <a:prstGeom prst="ellipse">
-            <a:avLst/>
-          </a:prstGeom>
-          <a:solidFill>
-            <a:srgbClr val="E8F5E9"/>
-          </a:solidFill>
-          <a:ln w="31750">
-            <a:solidFill>
-              <a:srgbClr val="1E3A5F"/>
-            </a:solidFill>
-          </a:ln>
-        </p:spPr>
-        <p:style>
-          <a:lnRef idx="1">
-            <a:schemeClr val="accent1"/>
-          </a:lnRef>
-          <a:fillRef idx="3">
-            <a:schemeClr val="accent1"/>
-          </a:fillRef>
-          <a:effectRef idx="2">
-            <a:schemeClr val="accent1"/>
-          </a:effectRef>
-          <a:fontRef idx="minor">
-            <a:schemeClr val="lt1"/>
-          </a:fontRef>
-        </p:style>
-        <p:txBody>
-          <a:bodyPr rtlCol="0" anchor="ctr"/>
-          <a:lstStyle/>
-          <a:p>
-            <a:pPr algn="ctr"/>
-          </a:p>
-        </p:txBody>
-      </p:sp>
-      <p:sp>
-        <p:nvSpPr>
-          <p:cNvPr id="45" name="Oval 44"/>
-          <p:cNvSpPr/>
-          <p:nvPr/>
-        </p:nvSpPr>
-        <p:spPr>
-          <a:xfrm>
-            <a:off x="429768" y="2441448"/>
-            <a:ext cx="512064" cy="512064"/>
-          </a:xfrm>
-          <a:prstGeom prst="ellipse">
-            <a:avLst/>
-          </a:prstGeom>
-          <a:solidFill>
-            <a:srgbClr val="1E3A5F"/>
-          </a:solidFill>
-          <a:ln>
-            <a:noFill/>
-          </a:ln>
-        </p:spPr>
-        <p:style>
-          <a:lnRef idx="1">
-            <a:schemeClr val="accent1"/>
-          </a:lnRef>
-          <a:fillRef idx="3">
-            <a:schemeClr val="accent1"/>
-          </a:fillRef>
-          <a:effectRef idx="2">
-            <a:schemeClr val="accent1"/>
-          </a:effectRef>
-          <a:fontRef idx="minor">
-            <a:schemeClr val="lt1"/>
-          </a:fontRef>
-        </p:style>
-        <p:txBody>
-          <a:bodyPr rtlCol="0" anchor="ctr"/>
-          <a:lstStyle/>
-          <a:p>
-            <a:pPr algn="ctr"/>
-            <a:r>
-              <a:rPr sz="1600" b="1">
-                <a:solidFill>
-                  <a:srgbClr val="FFFFFF"/>
-                </a:solidFill>
-                <a:latin typeface="Tahoma"/>
-              </a:rPr>
-              <a:t>۶</a:t>
-            </a:r>
-          </a:p>
-        </p:txBody>
-      </p:sp>
-      <p:sp>
-        <p:nvSpPr>
-          <p:cNvPr id="46" name="Rounded Rectangle 45"/>
-          <p:cNvSpPr/>
-          <p:nvPr/>
-        </p:nvSpPr>
-        <p:spPr>
-          <a:xfrm>
-            <a:off x="36576" y="3118104"/>
-            <a:ext cx="1298448" cy="868680"/>
-          </a:xfrm>
-          <a:prstGeom prst="roundRect">
-            <a:avLst/>
-          </a:prstGeom>
-          <a:solidFill>
-            <a:srgbClr val="1E3A5F"/>
-          </a:solidFill>
-          <a:ln w="25400">
-            <a:solidFill>
-              <a:srgbClr val="1E3A5F"/>
-            </a:solidFill>
-          </a:ln>
-        </p:spPr>
-        <p:style>
-          <a:lnRef idx="1">
-            <a:schemeClr val="accent1"/>
-          </a:lnRef>
-          <a:fillRef idx="3">
-            <a:schemeClr val="accent1"/>
-          </a:fillRef>
-          <a:effectRef idx="2">
-            <a:schemeClr val="accent1"/>
-          </a:effectRef>
-          <a:fontRef idx="minor">
-            <a:schemeClr val="lt1"/>
-          </a:fontRef>
-        </p:style>
-        <p:txBody>
-          <a:bodyPr rtlCol="0" anchor="ctr"/>
-          <a:lstStyle/>
-          <a:p>
-            <a:pPr algn="ctr"/>
-          </a:p>
-        </p:txBody>
-      </p:sp>
-      <p:sp>
-        <p:nvSpPr>
-          <p:cNvPr id="47" name="TextBox 46"/>
-          <p:cNvSpPr txBox="1"/>
-          <p:nvPr/>
-        </p:nvSpPr>
-        <p:spPr>
-          <a:xfrm>
-            <a:off x="91440" y="3191256"/>
-            <a:ext cx="1188720" cy="274320"/>
+            <a:off x="576072" y="2464308"/>
+            <a:ext cx="777240" cy="411480"/>
           </a:xfrm>
           <a:prstGeom prst="rect">
             <a:avLst/>
@@ -5022,21 +4367,21 @@
                 </a:solidFill>
                 <a:latin typeface="Tahoma"/>
               </a:rPr>
-              <a:t>وزن نهایی معیارها</a:t>
-            </a:r>
-          </a:p>
-        </p:txBody>
-      </p:sp>
-      <p:sp>
-        <p:nvSpPr>
-          <p:cNvPr id="48" name="TextBox 47"/>
+              <a:t>وزن نهایی</a:t>
+            </a:r>
+          </a:p>
+        </p:txBody>
+      </p:sp>
+      <p:sp>
+        <p:nvSpPr>
+          <p:cNvPr id="34" name="TextBox 33"/>
           <p:cNvSpPr txBox="1"/>
           <p:nvPr/>
         </p:nvSpPr>
         <p:spPr>
           <a:xfrm>
-            <a:off x="91440" y="3465576"/>
-            <a:ext cx="1188720" cy="384048"/>
+            <a:off x="411480" y="4434840"/>
+            <a:ext cx="2286000" cy="320040"/>
           </a:xfrm>
           <a:prstGeom prst="rect">
             <a:avLst/>
@@ -5049,35 +4394,35 @@
           </a:bodyPr>
           <a:lstStyle/>
           <a:p>
-            <a:pPr algn="ctr" a:rtl="1"/>
-            <a:r>
-              <a:rPr sz="850" b="0">
+            <a:pPr algn="r" a:rtl="1"/>
+            <a:r>
+              <a:rPr sz="1200" b="1">
                 <a:solidFill>
-                  <a:srgbClr val="BBDEFB"/>
+                  <a:srgbClr val="2563EB"/>
                 </a:solidFill>
                 <a:latin typeface="Tahoma"/>
               </a:rPr>
-              <a:t>ماتریس تجمیع‌شده مبنای محاسبه</a:t>
-            </a:r>
-          </a:p>
-        </p:txBody>
-      </p:sp>
-      <p:sp>
-        <p:nvSpPr>
-          <p:cNvPr id="49" name="Rectangle 48"/>
+              <a:t>روش پیشنهادی</a:t>
+            </a:r>
+          </a:p>
+        </p:txBody>
+      </p:sp>
+      <p:sp>
+        <p:nvSpPr>
+          <p:cNvPr id="35" name="Oval 34"/>
           <p:cNvSpPr/>
           <p:nvPr/>
         </p:nvSpPr>
         <p:spPr>
           <a:xfrm>
-            <a:off x="673100" y="3008376"/>
-            <a:ext cx="25400" cy="109728"/>
-          </a:xfrm>
-          <a:prstGeom prst="rect">
+            <a:off x="2743200" y="4462272"/>
+            <a:ext cx="256032" cy="256032"/>
+          </a:xfrm>
+          <a:prstGeom prst="ellipse">
             <a:avLst/>
           </a:prstGeom>
           <a:solidFill>
-            <a:srgbClr val="1E3A5F"/>
+            <a:srgbClr val="2563EB"/>
           </a:solidFill>
           <a:ln>
             <a:noFill/>
@@ -5107,14 +4452,14 @@
       </p:sp>
       <p:sp>
         <p:nvSpPr>
-          <p:cNvPr id="50" name="TextBox 49"/>
+          <p:cNvPr id="36" name="TextBox 35"/>
           <p:cNvSpPr txBox="1"/>
           <p:nvPr/>
         </p:nvSpPr>
         <p:spPr>
           <a:xfrm>
-            <a:off x="8001000" y="3200400"/>
-            <a:ext cx="914400" cy="228600"/>
+            <a:off x="3063240" y="4443984"/>
+            <a:ext cx="320040" cy="274320"/>
           </a:xfrm>
           <a:prstGeom prst="rect">
             <a:avLst/>
@@ -5127,75 +4472,38 @@
           </a:bodyPr>
           <a:lstStyle/>
           <a:p>
-            <a:pPr algn="ctr" a:rtl="1"/>
-            <a:r>
-              <a:rPr sz="900" b="1">
+            <a:pPr algn="ctr"/>
+            <a:r>
+              <a:rPr sz="1100" b="1">
                 <a:solidFill>
-                  <a:srgbClr val="2B5C8A"/>
+                  <a:srgbClr val="1E293B"/>
                 </a:solidFill>
                 <a:latin typeface="Tahoma"/>
               </a:rPr>
-              <a:t>شروع</a:t>
-            </a:r>
-          </a:p>
-        </p:txBody>
-      </p:sp>
-      <p:sp>
-        <p:nvSpPr>
-          <p:cNvPr id="51" name="TextBox 50"/>
-          <p:cNvSpPr txBox="1"/>
-          <p:nvPr/>
-        </p:nvSpPr>
-        <p:spPr>
-          <a:xfrm>
-            <a:off x="594360" y="3200400"/>
-            <a:ext cx="914400" cy="228600"/>
-          </a:xfrm>
-          <a:prstGeom prst="rect">
-            <a:avLst/>
-          </a:prstGeom>
-          <a:noFill/>
-        </p:spPr>
-        <p:txBody>
-          <a:bodyPr wrap="square" anchor="ctr">
-            <a:spAutoFit/>
-          </a:bodyPr>
-          <a:lstStyle/>
-          <a:p>
-            <a:pPr algn="ctr" a:rtl="1"/>
-            <a:r>
-              <a:rPr sz="900" b="1">
-                <a:solidFill>
-                  <a:srgbClr val="1E3A5F"/>
-                </a:solidFill>
-                <a:latin typeface="Tahoma"/>
-              </a:rPr>
-              <a:t>پایان</a:t>
-            </a:r>
-          </a:p>
-        </p:txBody>
-      </p:sp>
-      <p:sp>
-        <p:nvSpPr>
-          <p:cNvPr id="52" name="Rounded Rectangle 51"/>
+              <a:t>16</a:t>
+            </a:r>
+          </a:p>
+        </p:txBody>
+      </p:sp>
+      <p:sp>
+        <p:nvSpPr>
+          <p:cNvPr id="37" name="Oval 36"/>
           <p:cNvSpPr/>
           <p:nvPr/>
         </p:nvSpPr>
         <p:spPr>
           <a:xfrm>
-            <a:off x="411480" y="4160520"/>
-            <a:ext cx="8321040" cy="658368"/>
-          </a:xfrm>
-          <a:prstGeom prst="roundRect">
+            <a:off x="3429000" y="4462272"/>
+            <a:ext cx="256032" cy="256032"/>
+          </a:xfrm>
+          <a:prstGeom prst="ellipse">
             <a:avLst/>
           </a:prstGeom>
           <a:solidFill>
-            <a:srgbClr val="FFF3E0"/>
+            <a:srgbClr val="2563EB"/>
           </a:solidFill>
-          <a:ln w="12700">
-            <a:solidFill>
-              <a:srgbClr val="F57C00"/>
-            </a:solidFill>
+          <a:ln>
+            <a:noFill/>
           </a:ln>
         </p:spPr>
         <p:style>
@@ -5217,80 +4525,6 @@
           <a:lstStyle/>
           <a:p>
             <a:pPr algn="ctr"/>
-          </a:p>
-        </p:txBody>
-      </p:sp>
-      <p:sp>
-        <p:nvSpPr>
-          <p:cNvPr id="53" name="TextBox 52"/>
-          <p:cNvSpPr txBox="1"/>
-          <p:nvPr/>
-        </p:nvSpPr>
-        <p:spPr>
-          <a:xfrm>
-            <a:off x="548640" y="4297680"/>
-            <a:ext cx="8046720" cy="411480"/>
-          </a:xfrm>
-          <a:prstGeom prst="rect">
-            <a:avLst/>
-          </a:prstGeom>
-          <a:noFill/>
-        </p:spPr>
-        <p:txBody>
-          <a:bodyPr wrap="square" anchor="ctr">
-            <a:spAutoFit/>
-          </a:bodyPr>
-          <a:lstStyle/>
-          <a:p>
-            <a:pPr algn="ctr" a:rtl="1"/>
-            <a:r>
-              <a:rPr sz="1000" b="0">
-                <a:solidFill>
-                  <a:srgbClr val="2D343E"/>
-                </a:solidFill>
-                <a:latin typeface="Tahoma"/>
-              </a:rPr>
-              <a:t>مقیاس ساعتی AHP: ۱ = برابر  ·  ۳ = متوسط  ·  ۵ = قوی  ·  ۹ = مطلق</a:t>
-            </a:r>
-            <a:br/>
-            <a:r>
-              <a:t>آستانه پذیرش سازگاری: CR &lt; 0.1</a:t>
-            </a:r>
-          </a:p>
-        </p:txBody>
-      </p:sp>
-      <p:sp>
-        <p:nvSpPr>
-          <p:cNvPr id="54" name="TextBox 53"/>
-          <p:cNvSpPr txBox="1"/>
-          <p:nvPr/>
-        </p:nvSpPr>
-        <p:spPr>
-          <a:xfrm>
-            <a:off x="411480" y="4681728"/>
-            <a:ext cx="8321040" cy="201168"/>
-          </a:xfrm>
-          <a:prstGeom prst="rect">
-            <a:avLst/>
-          </a:prstGeom>
-          <a:noFill/>
-        </p:spPr>
-        <p:txBody>
-          <a:bodyPr wrap="square" anchor="ctr">
-            <a:spAutoFit/>
-          </a:bodyPr>
-          <a:lstStyle/>
-          <a:p>
-            <a:pPr algn="l"/>
-            <a:r>
-              <a:rPr sz="900" b="0">
-                <a:solidFill>
-                  <a:srgbClr val="6B7280"/>
-                </a:solidFill>
-                <a:latin typeface="Tahoma"/>
-              </a:rPr>
-              <a:t>AHP — Analytic Hierarchy Process  |  Saaty</a:t>
-            </a:r>
           </a:p>
         </p:txBody>
       </p:sp>

</xml_diff>